<commit_message>
feat: html manual draft
</commit_message>
<xml_diff>
--- a/Entregas/06 Final Report/Cartaz v2.pptx
+++ b/Entregas/06 Final Report/Cartaz v2.pptx
@@ -5,14 +5,16 @@
     <p:sldMasterId id="2147483708" r:id="rId1"/>
   </p:sldMasterIdLst>
   <p:notesMasterIdLst>
-    <p:notesMasterId r:id="rId7"/>
+    <p:notesMasterId r:id="rId9"/>
   </p:notesMasterIdLst>
   <p:sldIdLst>
     <p:sldId id="256" r:id="rId2"/>
     <p:sldId id="258" r:id="rId3"/>
     <p:sldId id="257" r:id="rId4"/>
     <p:sldId id="259" r:id="rId5"/>
-    <p:sldId id="260" r:id="rId6"/>
+    <p:sldId id="261" r:id="rId6"/>
+    <p:sldId id="260" r:id="rId7"/>
+    <p:sldId id="262" r:id="rId8"/>
   </p:sldIdLst>
   <p:sldSz cx="12801600" cy="9601200" type="A3"/>
   <p:notesSz cx="6858000" cy="9144000"/>
@@ -6079,7 +6081,7 @@
           <a:p>
             <a:fld id="{D8D22204-511D-42DB-B769-E600439F120D}" type="datetimeFigureOut">
               <a:rPr lang="pt-PT" smtClean="0"/>
-              <a:t>07/07/2025</a:t>
+              <a:t>16/07/2025</a:t>
             </a:fld>
             <a:endParaRPr lang="pt-PT"/>
           </a:p>
@@ -6774,6 +6776,119 @@
 </p:notes>
 </file>
 
+<file path=ppt/notesSlides/notesSlide5.xml><?xml version="1.0" encoding="utf-8"?>
+<p:notes xmlns:a="http://schemas.openxmlformats.org/drawingml/2006/main" xmlns:r="http://schemas.openxmlformats.org/officeDocument/2006/relationships" xmlns:p="http://schemas.openxmlformats.org/presentationml/2006/main">
+  <p:cSld>
+    <p:spTree>
+      <p:nvGrpSpPr>
+        <p:cNvPr id="1" name="">
+          <a:extLst>
+            <a:ext uri="{FF2B5EF4-FFF2-40B4-BE49-F238E27FC236}">
+              <a16:creationId xmlns:a16="http://schemas.microsoft.com/office/drawing/2014/main" id="{BD25DE2C-0C26-8F85-692A-4471786827E2}"/>
+            </a:ext>
+          </a:extLst>
+        </p:cNvPr>
+        <p:cNvGrpSpPr/>
+        <p:nvPr/>
+      </p:nvGrpSpPr>
+      <p:grpSpPr>
+        <a:xfrm>
+          <a:off x="0" y="0"/>
+          <a:ext cx="0" cy="0"/>
+          <a:chOff x="0" y="0"/>
+          <a:chExt cx="0" cy="0"/>
+        </a:xfrm>
+      </p:grpSpPr>
+      <p:sp>
+        <p:nvSpPr>
+          <p:cNvPr id="2" name="Marcador de Posição da Imagem do Diapositivo 1">
+            <a:extLst>
+              <a:ext uri="{FF2B5EF4-FFF2-40B4-BE49-F238E27FC236}">
+                <a16:creationId xmlns:a16="http://schemas.microsoft.com/office/drawing/2014/main" id="{26EC3593-DDAF-B630-4896-C34FE4E31EC6}"/>
+              </a:ext>
+            </a:extLst>
+          </p:cNvPr>
+          <p:cNvSpPr>
+            <a:spLocks noGrp="1" noRot="1" noChangeAspect="1"/>
+          </p:cNvSpPr>
+          <p:nvPr>
+            <p:ph type="sldImg"/>
+          </p:nvPr>
+        </p:nvSpPr>
+        <p:spPr>
+          <a:xfrm>
+            <a:off x="1371600" y="1143000"/>
+            <a:ext cx="4114800" cy="3086100"/>
+          </a:xfrm>
+        </p:spPr>
+      </p:sp>
+      <p:sp>
+        <p:nvSpPr>
+          <p:cNvPr id="3" name="Marcador de Posição de Notas 2">
+            <a:extLst>
+              <a:ext uri="{FF2B5EF4-FFF2-40B4-BE49-F238E27FC236}">
+                <a16:creationId xmlns:a16="http://schemas.microsoft.com/office/drawing/2014/main" id="{1B470747-144A-2346-6AA6-89B844E0CBC7}"/>
+              </a:ext>
+            </a:extLst>
+          </p:cNvPr>
+          <p:cNvSpPr>
+            <a:spLocks noGrp="1"/>
+          </p:cNvSpPr>
+          <p:nvPr>
+            <p:ph type="body" idx="1"/>
+          </p:nvPr>
+        </p:nvSpPr>
+        <p:spPr/>
+        <p:txBody>
+          <a:bodyPr/>
+          <a:lstStyle/>
+          <a:p>
+            <a:endParaRPr lang="pt-PT" dirty="0"/>
+          </a:p>
+        </p:txBody>
+      </p:sp>
+      <p:sp>
+        <p:nvSpPr>
+          <p:cNvPr id="4" name="Marcador de Posição do Número do Diapositivo 3">
+            <a:extLst>
+              <a:ext uri="{FF2B5EF4-FFF2-40B4-BE49-F238E27FC236}">
+                <a16:creationId xmlns:a16="http://schemas.microsoft.com/office/drawing/2014/main" id="{21261B07-F878-5FC5-3FA0-10C7D8C624EC}"/>
+              </a:ext>
+            </a:extLst>
+          </p:cNvPr>
+          <p:cNvSpPr>
+            <a:spLocks noGrp="1"/>
+          </p:cNvSpPr>
+          <p:nvPr>
+            <p:ph type="sldNum" sz="quarter" idx="5"/>
+          </p:nvPr>
+        </p:nvSpPr>
+        <p:spPr/>
+        <p:txBody>
+          <a:bodyPr/>
+          <a:lstStyle/>
+          <a:p>
+            <a:fld id="{CABF9CC0-989A-4F43-8280-58B218C542C2}" type="slidenum">
+              <a:rPr lang="pt-PT" smtClean="0"/>
+              <a:t>5</a:t>
+            </a:fld>
+            <a:endParaRPr lang="pt-PT"/>
+          </a:p>
+        </p:txBody>
+      </p:sp>
+    </p:spTree>
+    <p:extLst>
+      <p:ext uri="{BB962C8B-B14F-4D97-AF65-F5344CB8AC3E}">
+        <p14:creationId xmlns:p14="http://schemas.microsoft.com/office/powerpoint/2010/main" val="186167993"/>
+      </p:ext>
+    </p:extLst>
+  </p:cSld>
+  <p:clrMapOvr>
+    <a:masterClrMapping/>
+  </p:clrMapOvr>
+</p:notes>
+</file>
+
 <file path=ppt/slideLayouts/slideLayout1.xml><?xml version="1.0" encoding="utf-8"?>
 <p:sldLayout xmlns:a="http://schemas.openxmlformats.org/drawingml/2006/main" xmlns:r="http://schemas.openxmlformats.org/officeDocument/2006/relationships" xmlns:p="http://schemas.openxmlformats.org/presentationml/2006/main" type="title" preserve="1">
   <p:cSld name="Diapositivo de Título">
@@ -6905,7 +7020,7 @@
           <a:p>
             <a:fld id="{FF3E7115-E5A5-49CB-9497-9E6CDBEED4A9}" type="datetimeFigureOut">
               <a:rPr lang="pt-PT" smtClean="0"/>
-              <a:t>07/07/2025</a:t>
+              <a:t>16/07/2025</a:t>
             </a:fld>
             <a:endParaRPr lang="pt-PT"/>
           </a:p>
@@ -7075,7 +7190,7 @@
           <a:p>
             <a:fld id="{FF3E7115-E5A5-49CB-9497-9E6CDBEED4A9}" type="datetimeFigureOut">
               <a:rPr lang="pt-PT" smtClean="0"/>
-              <a:t>07/07/2025</a:t>
+              <a:t>16/07/2025</a:t>
             </a:fld>
             <a:endParaRPr lang="pt-PT"/>
           </a:p>
@@ -7255,7 +7370,7 @@
           <a:p>
             <a:fld id="{FF3E7115-E5A5-49CB-9497-9E6CDBEED4A9}" type="datetimeFigureOut">
               <a:rPr lang="pt-PT" smtClean="0"/>
-              <a:t>07/07/2025</a:t>
+              <a:t>16/07/2025</a:t>
             </a:fld>
             <a:endParaRPr lang="pt-PT"/>
           </a:p>
@@ -7425,7 +7540,7 @@
           <a:p>
             <a:fld id="{FF3E7115-E5A5-49CB-9497-9E6CDBEED4A9}" type="datetimeFigureOut">
               <a:rPr lang="pt-PT" smtClean="0"/>
-              <a:t>07/07/2025</a:t>
+              <a:t>16/07/2025</a:t>
             </a:fld>
             <a:endParaRPr lang="pt-PT"/>
           </a:p>
@@ -7671,7 +7786,7 @@
           <a:p>
             <a:fld id="{FF3E7115-E5A5-49CB-9497-9E6CDBEED4A9}" type="datetimeFigureOut">
               <a:rPr lang="pt-PT" smtClean="0"/>
-              <a:t>07/07/2025</a:t>
+              <a:t>16/07/2025</a:t>
             </a:fld>
             <a:endParaRPr lang="pt-PT"/>
           </a:p>
@@ -7903,7 +8018,7 @@
           <a:p>
             <a:fld id="{FF3E7115-E5A5-49CB-9497-9E6CDBEED4A9}" type="datetimeFigureOut">
               <a:rPr lang="pt-PT" smtClean="0"/>
-              <a:t>07/07/2025</a:t>
+              <a:t>16/07/2025</a:t>
             </a:fld>
             <a:endParaRPr lang="pt-PT"/>
           </a:p>
@@ -8270,7 +8385,7 @@
           <a:p>
             <a:fld id="{FF3E7115-E5A5-49CB-9497-9E6CDBEED4A9}" type="datetimeFigureOut">
               <a:rPr lang="pt-PT" smtClean="0"/>
-              <a:t>07/07/2025</a:t>
+              <a:t>16/07/2025</a:t>
             </a:fld>
             <a:endParaRPr lang="pt-PT"/>
           </a:p>
@@ -8388,7 +8503,7 @@
           <a:p>
             <a:fld id="{FF3E7115-E5A5-49CB-9497-9E6CDBEED4A9}" type="datetimeFigureOut">
               <a:rPr lang="pt-PT" smtClean="0"/>
-              <a:t>07/07/2025</a:t>
+              <a:t>16/07/2025</a:t>
             </a:fld>
             <a:endParaRPr lang="pt-PT"/>
           </a:p>
@@ -8483,7 +8598,7 @@
           <a:p>
             <a:fld id="{FF3E7115-E5A5-49CB-9497-9E6CDBEED4A9}" type="datetimeFigureOut">
               <a:rPr lang="pt-PT" smtClean="0"/>
-              <a:t>07/07/2025</a:t>
+              <a:t>16/07/2025</a:t>
             </a:fld>
             <a:endParaRPr lang="pt-PT"/>
           </a:p>
@@ -8760,7 +8875,7 @@
           <a:p>
             <a:fld id="{FF3E7115-E5A5-49CB-9497-9E6CDBEED4A9}" type="datetimeFigureOut">
               <a:rPr lang="pt-PT" smtClean="0"/>
-              <a:t>07/07/2025</a:t>
+              <a:t>16/07/2025</a:t>
             </a:fld>
             <a:endParaRPr lang="pt-PT"/>
           </a:p>
@@ -9017,7 +9132,7 @@
           <a:p>
             <a:fld id="{FF3E7115-E5A5-49CB-9497-9E6CDBEED4A9}" type="datetimeFigureOut">
               <a:rPr lang="pt-PT" smtClean="0"/>
-              <a:t>07/07/2025</a:t>
+              <a:t>16/07/2025</a:t>
             </a:fld>
             <a:endParaRPr lang="pt-PT"/>
           </a:p>
@@ -9230,7 +9345,7 @@
           <a:p>
             <a:fld id="{FF3E7115-E5A5-49CB-9497-9E6CDBEED4A9}" type="datetimeFigureOut">
               <a:rPr lang="pt-PT" smtClean="0"/>
-              <a:t>07/07/2025</a:t>
+              <a:t>16/07/2025</a:t>
             </a:fld>
             <a:endParaRPr lang="pt-PT"/>
           </a:p>
@@ -15805,7 +15920,7 @@
         </p:nvSpPr>
         <p:spPr>
           <a:xfrm rot="21174172">
-            <a:off x="-964532" y="16857007"/>
+            <a:off x="1284434" y="10611940"/>
             <a:ext cx="5939679" cy="746808"/>
           </a:xfrm>
           <a:prstGeom prst="rect">
@@ -16951,6 +17066,2301 @@
 </file>
 
 <file path=ppt/slides/slide5.xml><?xml version="1.0" encoding="utf-8"?>
+<p:sld xmlns:a="http://schemas.openxmlformats.org/drawingml/2006/main" xmlns:r="http://schemas.openxmlformats.org/officeDocument/2006/relationships" xmlns:p="http://schemas.openxmlformats.org/presentationml/2006/main">
+  <p:cSld>
+    <p:spTree>
+      <p:nvGrpSpPr>
+        <p:cNvPr id="1" name="">
+          <a:extLst>
+            <a:ext uri="{FF2B5EF4-FFF2-40B4-BE49-F238E27FC236}">
+              <a16:creationId xmlns:a16="http://schemas.microsoft.com/office/drawing/2014/main" id="{3ADD79C5-5E6B-38E6-2298-F4122E429F7E}"/>
+            </a:ext>
+          </a:extLst>
+        </p:cNvPr>
+        <p:cNvGrpSpPr/>
+        <p:nvPr/>
+      </p:nvGrpSpPr>
+      <p:grpSpPr>
+        <a:xfrm>
+          <a:off x="0" y="0"/>
+          <a:ext cx="0" cy="0"/>
+          <a:chOff x="0" y="0"/>
+          <a:chExt cx="0" cy="0"/>
+        </a:xfrm>
+      </p:grpSpPr>
+      <p:grpSp>
+        <p:nvGrpSpPr>
+          <p:cNvPr id="16" name="Agrupar 15">
+            <a:extLst>
+              <a:ext uri="{FF2B5EF4-FFF2-40B4-BE49-F238E27FC236}">
+                <a16:creationId xmlns:a16="http://schemas.microsoft.com/office/drawing/2014/main" id="{62C61438-593D-376A-A9A9-3B9274A4AB0D}"/>
+              </a:ext>
+            </a:extLst>
+          </p:cNvPr>
+          <p:cNvGrpSpPr>
+            <a:grpSpLocks noChangeAspect="1"/>
+          </p:cNvGrpSpPr>
+          <p:nvPr/>
+        </p:nvGrpSpPr>
+        <p:grpSpPr>
+          <a:xfrm>
+            <a:off x="980010" y="4001614"/>
+            <a:ext cx="2588579" cy="1871996"/>
+            <a:chOff x="1330476" y="6556362"/>
+            <a:chExt cx="3939831" cy="2849181"/>
+          </a:xfrm>
+        </p:grpSpPr>
+        <p:pic>
+          <p:nvPicPr>
+            <p:cNvPr id="40" name="Picture 10">
+              <a:extLst>
+                <a:ext uri="{FF2B5EF4-FFF2-40B4-BE49-F238E27FC236}">
+                  <a16:creationId xmlns:a16="http://schemas.microsoft.com/office/drawing/2014/main" id="{1BE9FD7A-A49F-77B7-6341-D980B42D24F4}"/>
+                </a:ext>
+              </a:extLst>
+            </p:cNvPr>
+            <p:cNvPicPr>
+              <a:picLocks noChangeAspect="1" noChangeArrowheads="1"/>
+            </p:cNvPicPr>
+            <p:nvPr/>
+          </p:nvPicPr>
+          <p:blipFill>
+            <a:blip r:embed="rId3">
+              <a:extLst>
+                <a:ext uri="{28A0092B-C50C-407E-A947-70E740481C1C}">
+                  <a14:useLocalDpi xmlns:a14="http://schemas.microsoft.com/office/drawing/2010/main" val="0"/>
+                </a:ext>
+              </a:extLst>
+            </a:blip>
+            <a:srcRect/>
+            <a:stretch>
+              <a:fillRect/>
+            </a:stretch>
+          </p:blipFill>
+          <p:spPr bwMode="auto">
+            <a:xfrm>
+              <a:off x="1670422" y="7584334"/>
+              <a:ext cx="3259941" cy="839434"/>
+            </a:xfrm>
+            <a:prstGeom prst="rect">
+              <a:avLst/>
+            </a:prstGeom>
+            <a:noFill/>
+            <a:extLst>
+              <a:ext uri="{909E8E84-426E-40DD-AFC4-6F175D3DCCD1}">
+                <a14:hiddenFill xmlns:a14="http://schemas.microsoft.com/office/drawing/2010/main">
+                  <a:solidFill>
+                    <a:srgbClr val="FFFFFF"/>
+                  </a:solidFill>
+                </a14:hiddenFill>
+              </a:ext>
+            </a:extLst>
+          </p:spPr>
+        </p:pic>
+        <p:pic>
+          <p:nvPicPr>
+            <p:cNvPr id="41" name="Picture 20" descr="Kotlin Logo PNG Transparent &amp; SVG Vector - Freebie Supply">
+              <a:extLst>
+                <a:ext uri="{FF2B5EF4-FFF2-40B4-BE49-F238E27FC236}">
+                  <a16:creationId xmlns:a16="http://schemas.microsoft.com/office/drawing/2014/main" id="{85267AF5-1ADA-F033-006F-EB995CE30BC9}"/>
+                </a:ext>
+              </a:extLst>
+            </p:cNvPr>
+            <p:cNvPicPr>
+              <a:picLocks noChangeAspect="1" noChangeArrowheads="1"/>
+            </p:cNvPicPr>
+            <p:nvPr/>
+          </p:nvPicPr>
+          <p:blipFill>
+            <a:blip r:embed="rId4">
+              <a:extLst>
+                <a:ext uri="{28A0092B-C50C-407E-A947-70E740481C1C}">
+                  <a14:useLocalDpi xmlns:a14="http://schemas.microsoft.com/office/drawing/2010/main" val="0"/>
+                </a:ext>
+              </a:extLst>
+            </a:blip>
+            <a:srcRect/>
+            <a:stretch>
+              <a:fillRect/>
+            </a:stretch>
+          </p:blipFill>
+          <p:spPr bwMode="auto">
+            <a:xfrm>
+              <a:off x="2399778" y="7919019"/>
+              <a:ext cx="1800371" cy="1350277"/>
+            </a:xfrm>
+            <a:prstGeom prst="rect">
+              <a:avLst/>
+            </a:prstGeom>
+            <a:noFill/>
+            <a:extLst>
+              <a:ext uri="{909E8E84-426E-40DD-AFC4-6F175D3DCCD1}">
+                <a14:hiddenFill xmlns:a14="http://schemas.microsoft.com/office/drawing/2010/main">
+                  <a:solidFill>
+                    <a:srgbClr val="FFFFFF"/>
+                  </a:solidFill>
+                </a14:hiddenFill>
+              </a:ext>
+            </a:extLst>
+          </p:spPr>
+        </p:pic>
+        <p:pic>
+          <p:nvPicPr>
+            <p:cNvPr id="42" name="Picture 26" descr="Understanding JSON Web Tokens (JWT) for Secure Information Sharing | by  Safdar Ali | Medium">
+              <a:extLst>
+                <a:ext uri="{FF2B5EF4-FFF2-40B4-BE49-F238E27FC236}">
+                  <a16:creationId xmlns:a16="http://schemas.microsoft.com/office/drawing/2014/main" id="{F968120E-057E-ADEA-0DD0-6B0DCA293664}"/>
+                </a:ext>
+              </a:extLst>
+            </p:cNvPr>
+            <p:cNvPicPr>
+              <a:picLocks noChangeAspect="1" noChangeArrowheads="1"/>
+            </p:cNvPicPr>
+            <p:nvPr/>
+          </p:nvPicPr>
+          <p:blipFill>
+            <a:blip r:embed="rId5">
+              <a:extLst>
+                <a:ext uri="{28A0092B-C50C-407E-A947-70E740481C1C}">
+                  <a14:useLocalDpi xmlns:a14="http://schemas.microsoft.com/office/drawing/2010/main" val="0"/>
+                </a:ext>
+              </a:extLst>
+            </a:blip>
+            <a:srcRect/>
+            <a:stretch>
+              <a:fillRect/>
+            </a:stretch>
+          </p:blipFill>
+          <p:spPr bwMode="auto">
+            <a:xfrm>
+              <a:off x="2506635" y="8738789"/>
+              <a:ext cx="1587506" cy="666754"/>
+            </a:xfrm>
+            <a:prstGeom prst="rect">
+              <a:avLst/>
+            </a:prstGeom>
+            <a:noFill/>
+            <a:extLst>
+              <a:ext uri="{909E8E84-426E-40DD-AFC4-6F175D3DCCD1}">
+                <a14:hiddenFill xmlns:a14="http://schemas.microsoft.com/office/drawing/2010/main">
+                  <a:solidFill>
+                    <a:srgbClr val="FFFFFF"/>
+                  </a:solidFill>
+                </a14:hiddenFill>
+              </a:ext>
+            </a:extLst>
+          </p:spPr>
+        </p:pic>
+        <p:sp>
+          <p:nvSpPr>
+            <p:cNvPr id="43" name="Retângulo: Cantos Arredondados 42">
+              <a:extLst>
+                <a:ext uri="{FF2B5EF4-FFF2-40B4-BE49-F238E27FC236}">
+                  <a16:creationId xmlns:a16="http://schemas.microsoft.com/office/drawing/2014/main" id="{796105AF-192D-AF64-C87F-3A751B57A5FA}"/>
+                </a:ext>
+              </a:extLst>
+            </p:cNvPr>
+            <p:cNvSpPr>
+              <a:spLocks noChangeAspect="1"/>
+            </p:cNvSpPr>
+            <p:nvPr/>
+          </p:nvSpPr>
+          <p:spPr>
+            <a:xfrm>
+              <a:off x="1330476" y="6556362"/>
+              <a:ext cx="3939831" cy="2739602"/>
+            </a:xfrm>
+            <a:prstGeom prst="roundRect">
+              <a:avLst/>
+            </a:prstGeom>
+            <a:noFill/>
+            <a:ln>
+              <a:solidFill>
+                <a:schemeClr val="tx1"/>
+              </a:solidFill>
+            </a:ln>
+          </p:spPr>
+          <p:style>
+            <a:lnRef idx="2">
+              <a:schemeClr val="accent1">
+                <a:shade val="15000"/>
+              </a:schemeClr>
+            </a:lnRef>
+            <a:fillRef idx="1">
+              <a:schemeClr val="accent1"/>
+            </a:fillRef>
+            <a:effectRef idx="0">
+              <a:schemeClr val="accent1"/>
+            </a:effectRef>
+            <a:fontRef idx="minor">
+              <a:schemeClr val="lt1"/>
+            </a:fontRef>
+          </p:style>
+          <p:txBody>
+            <a:bodyPr rtlCol="0" anchor="ctr"/>
+            <a:lstStyle/>
+            <a:p>
+              <a:pPr algn="ctr"/>
+              <a:endParaRPr lang="pt-PT" sz="3360"/>
+            </a:p>
+          </p:txBody>
+        </p:sp>
+      </p:grpSp>
+      <p:pic>
+        <p:nvPicPr>
+          <p:cNvPr id="39" name="Picture 4" descr="Sql server Icons - Iconshock">
+            <a:extLst>
+              <a:ext uri="{FF2B5EF4-FFF2-40B4-BE49-F238E27FC236}">
+                <a16:creationId xmlns:a16="http://schemas.microsoft.com/office/drawing/2014/main" id="{39C713F1-F522-1ABC-501A-5219F0E8647D}"/>
+              </a:ext>
+            </a:extLst>
+          </p:cNvPr>
+          <p:cNvPicPr>
+            <a:picLocks noChangeAspect="1" noChangeArrowheads="1"/>
+          </p:cNvPicPr>
+          <p:nvPr/>
+        </p:nvPicPr>
+        <p:blipFill>
+          <a:blip r:embed="rId6">
+            <a:extLst>
+              <a:ext uri="{28A0092B-C50C-407E-A947-70E740481C1C}">
+                <a14:useLocalDpi xmlns:a14="http://schemas.microsoft.com/office/drawing/2010/main" val="0"/>
+              </a:ext>
+            </a:extLst>
+          </a:blip>
+          <a:srcRect/>
+          <a:stretch>
+            <a:fillRect/>
+          </a:stretch>
+        </p:blipFill>
+        <p:spPr bwMode="auto">
+          <a:xfrm>
+            <a:off x="1758065" y="7000791"/>
+            <a:ext cx="1032469" cy="1032469"/>
+          </a:xfrm>
+          <a:prstGeom prst="rect">
+            <a:avLst/>
+          </a:prstGeom>
+          <a:noFill/>
+          <a:extLst>
+            <a:ext uri="{909E8E84-426E-40DD-AFC4-6F175D3DCCD1}">
+              <a14:hiddenFill xmlns:a14="http://schemas.microsoft.com/office/drawing/2010/main">
+                <a:solidFill>
+                  <a:srgbClr val="FFFFFF"/>
+                </a:solidFill>
+              </a14:hiddenFill>
+            </a:ext>
+          </a:extLst>
+        </p:spPr>
+      </p:pic>
+      <p:sp>
+        <p:nvSpPr>
+          <p:cNvPr id="45" name="Retângulo: Cantos Arredondados 44">
+            <a:extLst>
+              <a:ext uri="{FF2B5EF4-FFF2-40B4-BE49-F238E27FC236}">
+                <a16:creationId xmlns:a16="http://schemas.microsoft.com/office/drawing/2014/main" id="{4875DFCA-C994-F855-374C-0F902C4AEBAC}"/>
+              </a:ext>
+            </a:extLst>
+          </p:cNvPr>
+          <p:cNvSpPr>
+            <a:spLocks noChangeAspect="1"/>
+          </p:cNvSpPr>
+          <p:nvPr/>
+        </p:nvSpPr>
+        <p:spPr>
+          <a:xfrm>
+            <a:off x="1236866" y="6440158"/>
+            <a:ext cx="2074867" cy="1744274"/>
+          </a:xfrm>
+          <a:prstGeom prst="roundRect">
+            <a:avLst>
+              <a:gd name="adj" fmla="val 13755"/>
+            </a:avLst>
+          </a:prstGeom>
+          <a:noFill/>
+          <a:ln>
+            <a:solidFill>
+              <a:schemeClr val="tx1"/>
+            </a:solidFill>
+          </a:ln>
+        </p:spPr>
+        <p:style>
+          <a:lnRef idx="2">
+            <a:schemeClr val="accent1">
+              <a:shade val="15000"/>
+            </a:schemeClr>
+          </a:lnRef>
+          <a:fillRef idx="1">
+            <a:schemeClr val="accent1"/>
+          </a:fillRef>
+          <a:effectRef idx="0">
+            <a:schemeClr val="accent1"/>
+          </a:effectRef>
+          <a:fontRef idx="minor">
+            <a:schemeClr val="lt1"/>
+          </a:fontRef>
+        </p:style>
+        <p:txBody>
+          <a:bodyPr rtlCol="0" anchor="ctr"/>
+          <a:lstStyle/>
+          <a:p>
+            <a:pPr algn="ctr"/>
+            <a:endParaRPr lang="pt-PT" sz="3360"/>
+          </a:p>
+        </p:txBody>
+      </p:sp>
+      <p:pic>
+        <p:nvPicPr>
+          <p:cNvPr id="49" name="Picture 42" descr="Cloud Icon PNGs for Free Download">
+            <a:extLst>
+              <a:ext uri="{FF2B5EF4-FFF2-40B4-BE49-F238E27FC236}">
+                <a16:creationId xmlns:a16="http://schemas.microsoft.com/office/drawing/2014/main" id="{3E7CC0FA-1E34-FCFF-E591-C23D6AD2E498}"/>
+              </a:ext>
+            </a:extLst>
+          </p:cNvPr>
+          <p:cNvPicPr>
+            <a:picLocks noChangeAspect="1" noChangeArrowheads="1"/>
+          </p:cNvPicPr>
+          <p:nvPr/>
+        </p:nvPicPr>
+        <p:blipFill>
+          <a:blip r:embed="rId7">
+            <a:extLst>
+              <a:ext uri="{28A0092B-C50C-407E-A947-70E740481C1C}">
+                <a14:useLocalDpi xmlns:a14="http://schemas.microsoft.com/office/drawing/2010/main" val="0"/>
+              </a:ext>
+            </a:extLst>
+          </a:blip>
+          <a:srcRect/>
+          <a:stretch>
+            <a:fillRect/>
+          </a:stretch>
+        </p:blipFill>
+        <p:spPr bwMode="auto">
+          <a:xfrm>
+            <a:off x="4394199" y="4226127"/>
+            <a:ext cx="2406291" cy="1336828"/>
+          </a:xfrm>
+          <a:prstGeom prst="rect">
+            <a:avLst/>
+          </a:prstGeom>
+          <a:noFill/>
+          <a:extLst>
+            <a:ext uri="{909E8E84-426E-40DD-AFC4-6F175D3DCCD1}">
+              <a14:hiddenFill xmlns:a14="http://schemas.microsoft.com/office/drawing/2010/main">
+                <a:solidFill>
+                  <a:srgbClr val="FFFFFF"/>
+                </a:solidFill>
+              </a14:hiddenFill>
+            </a:ext>
+          </a:extLst>
+        </p:spPr>
+      </p:pic>
+      <p:sp>
+        <p:nvSpPr>
+          <p:cNvPr id="51" name="Retângulo 50">
+            <a:extLst>
+              <a:ext uri="{FF2B5EF4-FFF2-40B4-BE49-F238E27FC236}">
+                <a16:creationId xmlns:a16="http://schemas.microsoft.com/office/drawing/2014/main" id="{3E2E7B4A-DDA1-5CBD-E555-0418F3EB33C4}"/>
+              </a:ext>
+            </a:extLst>
+          </p:cNvPr>
+          <p:cNvSpPr>
+            <a:spLocks noChangeAspect="1"/>
+          </p:cNvSpPr>
+          <p:nvPr/>
+        </p:nvSpPr>
+        <p:spPr>
+          <a:xfrm rot="21174172">
+            <a:off x="-964532" y="16857007"/>
+            <a:ext cx="5939679" cy="746808"/>
+          </a:xfrm>
+          <a:prstGeom prst="rect">
+            <a:avLst/>
+          </a:prstGeom>
+          <a:noFill/>
+        </p:spPr>
+        <p:txBody>
+          <a:bodyPr wrap="square" lIns="170688" tIns="85344" rIns="170688" bIns="85344">
+            <a:spAutoFit/>
+          </a:bodyPr>
+          <a:lstStyle/>
+          <a:p>
+            <a:pPr algn="ctr"/>
+            <a:r>
+              <a:rPr lang="pt-PT" sz="3733" dirty="0">
+                <a:ln w="0"/>
+                <a:effectLst>
+                  <a:outerShdw blurRad="38100" dist="19050" dir="2700000" algn="tl" rotWithShape="0">
+                    <a:schemeClr val="dk1">
+                      <a:alpha val="40000"/>
+                    </a:schemeClr>
+                  </a:outerShdw>
+                </a:effectLst>
+              </a:rPr>
+              <a:t>Web App</a:t>
+            </a:r>
+          </a:p>
+        </p:txBody>
+      </p:sp>
+      <p:cxnSp>
+        <p:nvCxnSpPr>
+          <p:cNvPr id="25" name="Conexão reta unidirecional 24">
+            <a:extLst>
+              <a:ext uri="{FF2B5EF4-FFF2-40B4-BE49-F238E27FC236}">
+                <a16:creationId xmlns:a16="http://schemas.microsoft.com/office/drawing/2014/main" id="{71172209-C42F-2986-E41A-4DF65292C1CA}"/>
+              </a:ext>
+            </a:extLst>
+          </p:cNvPr>
+          <p:cNvCxnSpPr>
+            <a:cxnSpLocks/>
+            <a:stCxn id="45" idx="0"/>
+            <a:endCxn id="43" idx="2"/>
+          </p:cNvCxnSpPr>
+          <p:nvPr/>
+        </p:nvCxnSpPr>
+        <p:spPr>
+          <a:xfrm flipV="1">
+            <a:off x="2274300" y="5801613"/>
+            <a:ext cx="0" cy="638545"/>
+          </a:xfrm>
+          <a:prstGeom prst="straightConnector1">
+            <a:avLst/>
+          </a:prstGeom>
+          <a:ln>
+            <a:headEnd type="triangle"/>
+            <a:tailEnd type="triangle"/>
+          </a:ln>
+        </p:spPr>
+        <p:style>
+          <a:lnRef idx="2">
+            <a:schemeClr val="accent1"/>
+          </a:lnRef>
+          <a:fillRef idx="0">
+            <a:schemeClr val="accent1"/>
+          </a:fillRef>
+          <a:effectRef idx="1">
+            <a:schemeClr val="accent1"/>
+          </a:effectRef>
+          <a:fontRef idx="minor">
+            <a:schemeClr val="tx1"/>
+          </a:fontRef>
+        </p:style>
+      </p:cxnSp>
+      <p:cxnSp>
+        <p:nvCxnSpPr>
+          <p:cNvPr id="35" name="Conexão reta unidirecional 34">
+            <a:extLst>
+              <a:ext uri="{FF2B5EF4-FFF2-40B4-BE49-F238E27FC236}">
+                <a16:creationId xmlns:a16="http://schemas.microsoft.com/office/drawing/2014/main" id="{AA2BF83B-D110-9D13-17A1-E66AB6192E20}"/>
+              </a:ext>
+            </a:extLst>
+          </p:cNvPr>
+          <p:cNvCxnSpPr>
+            <a:cxnSpLocks/>
+            <a:stCxn id="43" idx="3"/>
+            <a:endCxn id="49" idx="1"/>
+          </p:cNvCxnSpPr>
+          <p:nvPr/>
+        </p:nvCxnSpPr>
+        <p:spPr>
+          <a:xfrm flipV="1">
+            <a:off x="3568589" y="4894541"/>
+            <a:ext cx="825610" cy="7073"/>
+          </a:xfrm>
+          <a:prstGeom prst="straightConnector1">
+            <a:avLst/>
+          </a:prstGeom>
+          <a:ln>
+            <a:headEnd type="triangle"/>
+            <a:tailEnd type="triangle"/>
+          </a:ln>
+        </p:spPr>
+        <p:style>
+          <a:lnRef idx="2">
+            <a:schemeClr val="accent1"/>
+          </a:lnRef>
+          <a:fillRef idx="0">
+            <a:schemeClr val="accent1"/>
+          </a:fillRef>
+          <a:effectRef idx="1">
+            <a:schemeClr val="accent1"/>
+          </a:effectRef>
+          <a:fontRef idx="minor">
+            <a:schemeClr val="tx1"/>
+          </a:fontRef>
+        </p:style>
+      </p:cxnSp>
+      <p:pic>
+        <p:nvPicPr>
+          <p:cNvPr id="56" name="Picture 4" descr="Free Sync Icon - Free Download Design &amp; Development Icons | IconScout">
+            <a:extLst>
+              <a:ext uri="{FF2B5EF4-FFF2-40B4-BE49-F238E27FC236}">
+                <a16:creationId xmlns:a16="http://schemas.microsoft.com/office/drawing/2014/main" id="{7B045783-E90E-65C5-15E5-28D011690419}"/>
+              </a:ext>
+            </a:extLst>
+          </p:cNvPr>
+          <p:cNvPicPr>
+            <a:picLocks noChangeAspect="1" noChangeArrowheads="1"/>
+          </p:cNvPicPr>
+          <p:nvPr/>
+        </p:nvPicPr>
+        <p:blipFill>
+          <a:blip r:embed="rId8">
+            <a:extLst>
+              <a:ext uri="{28A0092B-C50C-407E-A947-70E740481C1C}">
+                <a14:useLocalDpi xmlns:a14="http://schemas.microsoft.com/office/drawing/2010/main" val="0"/>
+              </a:ext>
+            </a:extLst>
+          </a:blip>
+          <a:srcRect/>
+          <a:stretch>
+            <a:fillRect/>
+          </a:stretch>
+        </p:blipFill>
+        <p:spPr bwMode="auto">
+          <a:xfrm>
+            <a:off x="9511130" y="3600084"/>
+            <a:ext cx="533400" cy="533400"/>
+          </a:xfrm>
+          <a:prstGeom prst="rect">
+            <a:avLst/>
+          </a:prstGeom>
+          <a:noFill/>
+          <a:extLst>
+            <a:ext uri="{909E8E84-426E-40DD-AFC4-6F175D3DCCD1}">
+              <a14:hiddenFill xmlns:a14="http://schemas.microsoft.com/office/drawing/2010/main">
+                <a:solidFill>
+                  <a:srgbClr val="FFFFFF"/>
+                </a:solidFill>
+              </a14:hiddenFill>
+            </a:ext>
+          </a:extLst>
+        </p:spPr>
+      </p:pic>
+      <p:grpSp>
+        <p:nvGrpSpPr>
+          <p:cNvPr id="77" name="Agrupar 76">
+            <a:extLst>
+              <a:ext uri="{FF2B5EF4-FFF2-40B4-BE49-F238E27FC236}">
+                <a16:creationId xmlns:a16="http://schemas.microsoft.com/office/drawing/2014/main" id="{C7FF85D9-E498-5CDE-F772-D1E067022F02}"/>
+              </a:ext>
+            </a:extLst>
+          </p:cNvPr>
+          <p:cNvGrpSpPr/>
+          <p:nvPr/>
+        </p:nvGrpSpPr>
+        <p:grpSpPr>
+          <a:xfrm>
+            <a:off x="7478570" y="2010283"/>
+            <a:ext cx="2132051" cy="1449376"/>
+            <a:chOff x="8587622" y="4873842"/>
+            <a:chExt cx="2132051" cy="1449376"/>
+          </a:xfrm>
+        </p:grpSpPr>
+        <p:sp>
+          <p:nvSpPr>
+            <p:cNvPr id="50" name="Retângulo: Cantos Arredondados 49">
+              <a:extLst>
+                <a:ext uri="{FF2B5EF4-FFF2-40B4-BE49-F238E27FC236}">
+                  <a16:creationId xmlns:a16="http://schemas.microsoft.com/office/drawing/2014/main" id="{58FA809B-D7C9-5D4A-057F-B356CBDD3933}"/>
+                </a:ext>
+              </a:extLst>
+            </p:cNvPr>
+            <p:cNvSpPr>
+              <a:spLocks noChangeAspect="1"/>
+            </p:cNvSpPr>
+            <p:nvPr/>
+          </p:nvSpPr>
+          <p:spPr>
+            <a:xfrm>
+              <a:off x="8587623" y="4876960"/>
+              <a:ext cx="2132049" cy="1446258"/>
+            </a:xfrm>
+            <a:prstGeom prst="roundRect">
+              <a:avLst/>
+            </a:prstGeom>
+            <a:noFill/>
+            <a:ln>
+              <a:solidFill>
+                <a:schemeClr val="tx1"/>
+              </a:solidFill>
+            </a:ln>
+          </p:spPr>
+          <p:style>
+            <a:lnRef idx="2">
+              <a:schemeClr val="accent1">
+                <a:shade val="15000"/>
+              </a:schemeClr>
+            </a:lnRef>
+            <a:fillRef idx="1">
+              <a:schemeClr val="accent1"/>
+            </a:fillRef>
+            <a:effectRef idx="0">
+              <a:schemeClr val="accent1"/>
+            </a:effectRef>
+            <a:fontRef idx="minor">
+              <a:schemeClr val="lt1"/>
+            </a:fontRef>
+          </p:style>
+          <p:txBody>
+            <a:bodyPr rtlCol="0" anchor="ctr"/>
+            <a:lstStyle/>
+            <a:p>
+              <a:pPr algn="ctr"/>
+              <a:endParaRPr lang="pt-PT" sz="3360"/>
+            </a:p>
+          </p:txBody>
+        </p:sp>
+        <p:pic>
+          <p:nvPicPr>
+            <p:cNvPr id="53" name="Picture 8" descr="Brand">
+              <a:extLst>
+                <a:ext uri="{FF2B5EF4-FFF2-40B4-BE49-F238E27FC236}">
+                  <a16:creationId xmlns:a16="http://schemas.microsoft.com/office/drawing/2014/main" id="{0C0433AD-C9B0-F7B3-CCD4-3B0C124CA2F2}"/>
+                </a:ext>
+              </a:extLst>
+            </p:cNvPr>
+            <p:cNvPicPr>
+              <a:picLocks noChangeAspect="1" noChangeArrowheads="1"/>
+            </p:cNvPicPr>
+            <p:nvPr/>
+          </p:nvPicPr>
+          <p:blipFill>
+            <a:blip r:embed="rId9">
+              <a:extLst>
+                <a:ext uri="{28A0092B-C50C-407E-A947-70E740481C1C}">
+                  <a14:useLocalDpi xmlns:a14="http://schemas.microsoft.com/office/drawing/2010/main" val="0"/>
+                </a:ext>
+              </a:extLst>
+            </a:blip>
+            <a:srcRect/>
+            <a:stretch>
+              <a:fillRect/>
+            </a:stretch>
+          </p:blipFill>
+          <p:spPr bwMode="auto">
+            <a:xfrm>
+              <a:off x="9900865" y="5345661"/>
+              <a:ext cx="571589" cy="831802"/>
+            </a:xfrm>
+            <a:prstGeom prst="rect">
+              <a:avLst/>
+            </a:prstGeom>
+            <a:noFill/>
+            <a:extLst>
+              <a:ext uri="{909E8E84-426E-40DD-AFC4-6F175D3DCCD1}">
+                <a14:hiddenFill xmlns:a14="http://schemas.microsoft.com/office/drawing/2010/main">
+                  <a:solidFill>
+                    <a:srgbClr val="FFFFFF"/>
+                  </a:solidFill>
+                </a14:hiddenFill>
+              </a:ext>
+            </a:extLst>
+          </p:spPr>
+        </p:pic>
+        <p:pic>
+          <p:nvPicPr>
+            <p:cNvPr id="63" name="Picture 4" descr="Windows Logo PNGs for Free Download">
+              <a:extLst>
+                <a:ext uri="{FF2B5EF4-FFF2-40B4-BE49-F238E27FC236}">
+                  <a16:creationId xmlns:a16="http://schemas.microsoft.com/office/drawing/2014/main" id="{8F911A16-FCDB-F14B-EF8D-638B2027844C}"/>
+                </a:ext>
+              </a:extLst>
+            </p:cNvPr>
+            <p:cNvPicPr>
+              <a:picLocks noChangeAspect="1" noChangeArrowheads="1"/>
+            </p:cNvPicPr>
+            <p:nvPr/>
+          </p:nvPicPr>
+          <p:blipFill>
+            <a:blip r:embed="rId10">
+              <a:extLst>
+                <a:ext uri="{28A0092B-C50C-407E-A947-70E740481C1C}">
+                  <a14:useLocalDpi xmlns:a14="http://schemas.microsoft.com/office/drawing/2010/main" val="0"/>
+                </a:ext>
+              </a:extLst>
+            </a:blip>
+            <a:srcRect/>
+            <a:stretch>
+              <a:fillRect/>
+            </a:stretch>
+          </p:blipFill>
+          <p:spPr bwMode="auto">
+            <a:xfrm>
+              <a:off x="8654310" y="5049476"/>
+              <a:ext cx="1170535" cy="1170535"/>
+            </a:xfrm>
+            <a:prstGeom prst="rect">
+              <a:avLst/>
+            </a:prstGeom>
+            <a:noFill/>
+            <a:extLst>
+              <a:ext uri="{909E8E84-426E-40DD-AFC4-6F175D3DCCD1}">
+                <a14:hiddenFill xmlns:a14="http://schemas.microsoft.com/office/drawing/2010/main">
+                  <a:solidFill>
+                    <a:srgbClr val="FFFFFF"/>
+                  </a:solidFill>
+                </a14:hiddenFill>
+              </a:ext>
+            </a:extLst>
+          </p:spPr>
+        </p:pic>
+        <p:sp>
+          <p:nvSpPr>
+            <p:cNvPr id="57" name="CaixaDeTexto 56">
+              <a:extLst>
+                <a:ext uri="{FF2B5EF4-FFF2-40B4-BE49-F238E27FC236}">
+                  <a16:creationId xmlns:a16="http://schemas.microsoft.com/office/drawing/2014/main" id="{594EA650-2D4A-29AB-F1DB-694F0F92E200}"/>
+                </a:ext>
+              </a:extLst>
+            </p:cNvPr>
+            <p:cNvSpPr txBox="1"/>
+            <p:nvPr/>
+          </p:nvSpPr>
+          <p:spPr>
+            <a:xfrm>
+              <a:off x="8587622" y="4873842"/>
+              <a:ext cx="2132051" cy="369332"/>
+            </a:xfrm>
+            <a:prstGeom prst="rect">
+              <a:avLst/>
+            </a:prstGeom>
+            <a:noFill/>
+          </p:spPr>
+          <p:txBody>
+            <a:bodyPr wrap="square" rtlCol="0">
+              <a:spAutoFit/>
+            </a:bodyPr>
+            <a:lstStyle/>
+            <a:p>
+              <a:pPr algn="ctr"/>
+              <a:r>
+                <a:rPr lang="pt-PT" dirty="0"/>
+                <a:t>Desktop App</a:t>
+              </a:r>
+            </a:p>
+          </p:txBody>
+        </p:sp>
+      </p:grpSp>
+      <p:grpSp>
+        <p:nvGrpSpPr>
+          <p:cNvPr id="78" name="Agrupar 77">
+            <a:extLst>
+              <a:ext uri="{FF2B5EF4-FFF2-40B4-BE49-F238E27FC236}">
+                <a16:creationId xmlns:a16="http://schemas.microsoft.com/office/drawing/2014/main" id="{1E4FA824-2618-C225-B837-564D685C17EE}"/>
+              </a:ext>
+            </a:extLst>
+          </p:cNvPr>
+          <p:cNvGrpSpPr/>
+          <p:nvPr/>
+        </p:nvGrpSpPr>
+        <p:grpSpPr>
+          <a:xfrm>
+            <a:off x="9913599" y="2010282"/>
+            <a:ext cx="2132049" cy="1446259"/>
+            <a:chOff x="8603297" y="7086559"/>
+            <a:chExt cx="2132049" cy="1446258"/>
+          </a:xfrm>
+        </p:grpSpPr>
+        <p:pic>
+          <p:nvPicPr>
+            <p:cNvPr id="1028" name="Picture 4" descr="Database icon - Free download on Iconfinder">
+              <a:extLst>
+                <a:ext uri="{FF2B5EF4-FFF2-40B4-BE49-F238E27FC236}">
+                  <a16:creationId xmlns:a16="http://schemas.microsoft.com/office/drawing/2014/main" id="{5DCA103C-E198-05D4-BE1C-F920C72FFE58}"/>
+                </a:ext>
+              </a:extLst>
+            </p:cNvPr>
+            <p:cNvPicPr>
+              <a:picLocks noChangeAspect="1" noChangeArrowheads="1"/>
+            </p:cNvPicPr>
+            <p:nvPr/>
+          </p:nvPicPr>
+          <p:blipFill>
+            <a:blip r:embed="rId11">
+              <a:extLst>
+                <a:ext uri="{28A0092B-C50C-407E-A947-70E740481C1C}">
+                  <a14:useLocalDpi xmlns:a14="http://schemas.microsoft.com/office/drawing/2010/main" val="0"/>
+                </a:ext>
+              </a:extLst>
+            </a:blip>
+            <a:srcRect/>
+            <a:stretch>
+              <a:fillRect/>
+            </a:stretch>
+          </p:blipFill>
+          <p:spPr bwMode="auto">
+            <a:xfrm>
+              <a:off x="8953441" y="7538699"/>
+              <a:ext cx="741546" cy="741546"/>
+            </a:xfrm>
+            <a:prstGeom prst="rect">
+              <a:avLst/>
+            </a:prstGeom>
+            <a:noFill/>
+            <a:extLst>
+              <a:ext uri="{909E8E84-426E-40DD-AFC4-6F175D3DCCD1}">
+                <a14:hiddenFill xmlns:a14="http://schemas.microsoft.com/office/drawing/2010/main">
+                  <a:solidFill>
+                    <a:srgbClr val="FFFFFF"/>
+                  </a:solidFill>
+                </a14:hiddenFill>
+              </a:ext>
+            </a:extLst>
+          </p:spPr>
+        </p:pic>
+        <p:pic>
+          <p:nvPicPr>
+            <p:cNvPr id="10" name="Imagem 9">
+              <a:extLst>
+                <a:ext uri="{FF2B5EF4-FFF2-40B4-BE49-F238E27FC236}">
+                  <a16:creationId xmlns:a16="http://schemas.microsoft.com/office/drawing/2014/main" id="{D53D3909-1C4B-7D3A-F016-F72F95442156}"/>
+                </a:ext>
+              </a:extLst>
+            </p:cNvPr>
+            <p:cNvPicPr>
+              <a:picLocks noChangeAspect="1"/>
+            </p:cNvPicPr>
+            <p:nvPr/>
+          </p:nvPicPr>
+          <p:blipFill>
+            <a:blip r:embed="rId12"/>
+            <a:stretch>
+              <a:fillRect/>
+            </a:stretch>
+          </p:blipFill>
+          <p:spPr>
+            <a:xfrm>
+              <a:off x="9921674" y="7648767"/>
+              <a:ext cx="607493" cy="601242"/>
+            </a:xfrm>
+            <a:prstGeom prst="rect">
+              <a:avLst/>
+            </a:prstGeom>
+          </p:spPr>
+        </p:pic>
+        <p:sp>
+          <p:nvSpPr>
+            <p:cNvPr id="55" name="Retângulo: Cantos Arredondados 54">
+              <a:extLst>
+                <a:ext uri="{FF2B5EF4-FFF2-40B4-BE49-F238E27FC236}">
+                  <a16:creationId xmlns:a16="http://schemas.microsoft.com/office/drawing/2014/main" id="{EF7D29BA-5675-CF4F-3B9E-D797D898639D}"/>
+                </a:ext>
+              </a:extLst>
+            </p:cNvPr>
+            <p:cNvSpPr>
+              <a:spLocks noChangeAspect="1"/>
+            </p:cNvSpPr>
+            <p:nvPr/>
+          </p:nvSpPr>
+          <p:spPr>
+            <a:xfrm>
+              <a:off x="8603297" y="7086559"/>
+              <a:ext cx="2132049" cy="1446258"/>
+            </a:xfrm>
+            <a:prstGeom prst="roundRect">
+              <a:avLst/>
+            </a:prstGeom>
+            <a:noFill/>
+            <a:ln>
+              <a:solidFill>
+                <a:schemeClr val="tx1"/>
+              </a:solidFill>
+            </a:ln>
+          </p:spPr>
+          <p:style>
+            <a:lnRef idx="2">
+              <a:schemeClr val="accent1">
+                <a:shade val="15000"/>
+              </a:schemeClr>
+            </a:lnRef>
+            <a:fillRef idx="1">
+              <a:schemeClr val="accent1"/>
+            </a:fillRef>
+            <a:effectRef idx="0">
+              <a:schemeClr val="accent1"/>
+            </a:effectRef>
+            <a:fontRef idx="minor">
+              <a:schemeClr val="lt1"/>
+            </a:fontRef>
+          </p:style>
+          <p:txBody>
+            <a:bodyPr rtlCol="0" anchor="ctr"/>
+            <a:lstStyle/>
+            <a:p>
+              <a:pPr algn="ctr"/>
+              <a:endParaRPr lang="pt-PT" sz="3360"/>
+            </a:p>
+          </p:txBody>
+        </p:sp>
+        <p:sp>
+          <p:nvSpPr>
+            <p:cNvPr id="58" name="CaixaDeTexto 57">
+              <a:extLst>
+                <a:ext uri="{FF2B5EF4-FFF2-40B4-BE49-F238E27FC236}">
+                  <a16:creationId xmlns:a16="http://schemas.microsoft.com/office/drawing/2014/main" id="{B3A1C5EE-95BB-2B16-1ADD-EC1FE783BB0F}"/>
+                </a:ext>
+              </a:extLst>
+            </p:cNvPr>
+            <p:cNvSpPr txBox="1"/>
+            <p:nvPr/>
+          </p:nvSpPr>
+          <p:spPr>
+            <a:xfrm>
+              <a:off x="8603297" y="7092379"/>
+              <a:ext cx="2132049" cy="369332"/>
+            </a:xfrm>
+            <a:prstGeom prst="rect">
+              <a:avLst/>
+            </a:prstGeom>
+            <a:noFill/>
+          </p:spPr>
+          <p:txBody>
+            <a:bodyPr wrap="square" rtlCol="0">
+              <a:spAutoFit/>
+            </a:bodyPr>
+            <a:lstStyle/>
+            <a:p>
+              <a:pPr algn="ctr"/>
+              <a:r>
+                <a:rPr lang="pt-PT" dirty="0"/>
+                <a:t>Local Database</a:t>
+              </a:r>
+            </a:p>
+          </p:txBody>
+        </p:sp>
+      </p:grpSp>
+      <p:cxnSp>
+        <p:nvCxnSpPr>
+          <p:cNvPr id="60" name="Conexão reta unidirecional 59">
+            <a:extLst>
+              <a:ext uri="{FF2B5EF4-FFF2-40B4-BE49-F238E27FC236}">
+                <a16:creationId xmlns:a16="http://schemas.microsoft.com/office/drawing/2014/main" id="{ABA9D03E-1BD9-FA1A-8AE4-132F7C473FE4}"/>
+              </a:ext>
+            </a:extLst>
+          </p:cNvPr>
+          <p:cNvCxnSpPr>
+            <a:cxnSpLocks/>
+            <a:stCxn id="55" idx="1"/>
+            <a:endCxn id="50" idx="3"/>
+          </p:cNvCxnSpPr>
+          <p:nvPr/>
+        </p:nvCxnSpPr>
+        <p:spPr>
+          <a:xfrm flipH="1">
+            <a:off x="9610620" y="2733412"/>
+            <a:ext cx="302979" cy="3118"/>
+          </a:xfrm>
+          <a:prstGeom prst="straightConnector1">
+            <a:avLst/>
+          </a:prstGeom>
+          <a:ln>
+            <a:headEnd type="triangle"/>
+            <a:tailEnd type="triangle"/>
+          </a:ln>
+        </p:spPr>
+        <p:style>
+          <a:lnRef idx="2">
+            <a:schemeClr val="accent1"/>
+          </a:lnRef>
+          <a:fillRef idx="0">
+            <a:schemeClr val="accent1"/>
+          </a:fillRef>
+          <a:effectRef idx="1">
+            <a:schemeClr val="accent1"/>
+          </a:effectRef>
+          <a:fontRef idx="minor">
+            <a:schemeClr val="tx1"/>
+          </a:fontRef>
+        </p:style>
+      </p:cxnSp>
+      <p:cxnSp>
+        <p:nvCxnSpPr>
+          <p:cNvPr id="85" name="Conexão reta unidirecional 84">
+            <a:extLst>
+              <a:ext uri="{FF2B5EF4-FFF2-40B4-BE49-F238E27FC236}">
+                <a16:creationId xmlns:a16="http://schemas.microsoft.com/office/drawing/2014/main" id="{FEA7E4DA-08F6-E79E-6E62-C9FF29305C06}"/>
+              </a:ext>
+            </a:extLst>
+          </p:cNvPr>
+          <p:cNvCxnSpPr>
+            <a:cxnSpLocks/>
+            <a:stCxn id="56" idx="1"/>
+          </p:cNvCxnSpPr>
+          <p:nvPr/>
+        </p:nvCxnSpPr>
+        <p:spPr>
+          <a:xfrm rot="10800000" flipV="1">
+            <a:off x="6800490" y="3866783"/>
+            <a:ext cx="2710640" cy="1220011"/>
+          </a:xfrm>
+          <a:prstGeom prst="bentConnector3">
+            <a:avLst>
+              <a:gd name="adj1" fmla="val 50000"/>
+            </a:avLst>
+          </a:prstGeom>
+          <a:ln>
+            <a:headEnd type="triangle"/>
+            <a:tailEnd type="triangle"/>
+          </a:ln>
+        </p:spPr>
+        <p:style>
+          <a:lnRef idx="2">
+            <a:schemeClr val="accent1"/>
+          </a:lnRef>
+          <a:fillRef idx="0">
+            <a:schemeClr val="accent1"/>
+          </a:fillRef>
+          <a:effectRef idx="1">
+            <a:schemeClr val="accent1"/>
+          </a:effectRef>
+          <a:fontRef idx="minor">
+            <a:schemeClr val="tx1"/>
+          </a:fontRef>
+        </p:style>
+      </p:cxnSp>
+      <p:sp>
+        <p:nvSpPr>
+          <p:cNvPr id="88" name="CaixaDeTexto 87">
+            <a:extLst>
+              <a:ext uri="{FF2B5EF4-FFF2-40B4-BE49-F238E27FC236}">
+                <a16:creationId xmlns:a16="http://schemas.microsoft.com/office/drawing/2014/main" id="{473DD855-DDE2-4750-CA7C-5BDD31ACBF70}"/>
+              </a:ext>
+            </a:extLst>
+          </p:cNvPr>
+          <p:cNvSpPr txBox="1"/>
+          <p:nvPr/>
+        </p:nvSpPr>
+        <p:spPr>
+          <a:xfrm>
+            <a:off x="9121008" y="4132598"/>
+            <a:ext cx="1313641" cy="338554"/>
+          </a:xfrm>
+          <a:prstGeom prst="rect">
+            <a:avLst/>
+          </a:prstGeom>
+          <a:noFill/>
+        </p:spPr>
+        <p:txBody>
+          <a:bodyPr wrap="square" rtlCol="0">
+            <a:spAutoFit/>
+          </a:bodyPr>
+          <a:lstStyle/>
+          <a:p>
+            <a:pPr algn="ctr"/>
+            <a:r>
+              <a:rPr lang="pt-PT" sz="1600" dirty="0"/>
+              <a:t>Sync Service</a:t>
+            </a:r>
+          </a:p>
+        </p:txBody>
+      </p:sp>
+      <p:sp>
+        <p:nvSpPr>
+          <p:cNvPr id="89" name="CaixaDeTexto 88">
+            <a:extLst>
+              <a:ext uri="{FF2B5EF4-FFF2-40B4-BE49-F238E27FC236}">
+                <a16:creationId xmlns:a16="http://schemas.microsoft.com/office/drawing/2014/main" id="{7E12FBAD-4BB1-52F9-EE38-524F3B1BFEB0}"/>
+              </a:ext>
+            </a:extLst>
+          </p:cNvPr>
+          <p:cNvSpPr txBox="1"/>
+          <p:nvPr/>
+        </p:nvSpPr>
+        <p:spPr>
+          <a:xfrm>
+            <a:off x="980010" y="4035275"/>
+            <a:ext cx="2588579" cy="369332"/>
+          </a:xfrm>
+          <a:prstGeom prst="rect">
+            <a:avLst/>
+          </a:prstGeom>
+          <a:noFill/>
+        </p:spPr>
+        <p:txBody>
+          <a:bodyPr wrap="square" rtlCol="0">
+            <a:spAutoFit/>
+          </a:bodyPr>
+          <a:lstStyle/>
+          <a:p>
+            <a:pPr algn="ctr"/>
+            <a:r>
+              <a:rPr lang="pt-PT" dirty="0"/>
+              <a:t>Web API</a:t>
+            </a:r>
+          </a:p>
+        </p:txBody>
+      </p:sp>
+      <p:sp>
+        <p:nvSpPr>
+          <p:cNvPr id="95" name="CaixaDeTexto 94">
+            <a:extLst>
+              <a:ext uri="{FF2B5EF4-FFF2-40B4-BE49-F238E27FC236}">
+                <a16:creationId xmlns:a16="http://schemas.microsoft.com/office/drawing/2014/main" id="{D991A3BC-4920-3356-95FA-AB2C97E4BBF1}"/>
+              </a:ext>
+            </a:extLst>
+          </p:cNvPr>
+          <p:cNvSpPr txBox="1"/>
+          <p:nvPr/>
+        </p:nvSpPr>
+        <p:spPr>
+          <a:xfrm>
+            <a:off x="1236865" y="6512155"/>
+            <a:ext cx="2108371" cy="369332"/>
+          </a:xfrm>
+          <a:prstGeom prst="rect">
+            <a:avLst/>
+          </a:prstGeom>
+          <a:noFill/>
+        </p:spPr>
+        <p:txBody>
+          <a:bodyPr wrap="square" rtlCol="0">
+            <a:spAutoFit/>
+          </a:bodyPr>
+          <a:lstStyle/>
+          <a:p>
+            <a:pPr algn="ctr"/>
+            <a:r>
+              <a:rPr lang="pt-PT" dirty="0"/>
+              <a:t>DataBase</a:t>
+            </a:r>
+          </a:p>
+        </p:txBody>
+      </p:sp>
+      <p:sp>
+        <p:nvSpPr>
+          <p:cNvPr id="97" name="Retângulo: Cantos Arredondados 96">
+            <a:extLst>
+              <a:ext uri="{FF2B5EF4-FFF2-40B4-BE49-F238E27FC236}">
+                <a16:creationId xmlns:a16="http://schemas.microsoft.com/office/drawing/2014/main" id="{628E7235-38A4-67EB-7298-4D3D0C933016}"/>
+              </a:ext>
+            </a:extLst>
+          </p:cNvPr>
+          <p:cNvSpPr>
+            <a:spLocks noChangeAspect="1"/>
+          </p:cNvSpPr>
+          <p:nvPr/>
+        </p:nvSpPr>
+        <p:spPr>
+          <a:xfrm>
+            <a:off x="4559911" y="1710046"/>
+            <a:ext cx="2074867" cy="804554"/>
+          </a:xfrm>
+          <a:prstGeom prst="roundRect">
+            <a:avLst>
+              <a:gd name="adj" fmla="val 13755"/>
+            </a:avLst>
+          </a:prstGeom>
+          <a:noFill/>
+          <a:ln>
+            <a:solidFill>
+              <a:schemeClr val="tx1"/>
+            </a:solidFill>
+          </a:ln>
+        </p:spPr>
+        <p:style>
+          <a:lnRef idx="2">
+            <a:schemeClr val="accent1">
+              <a:shade val="15000"/>
+            </a:schemeClr>
+          </a:lnRef>
+          <a:fillRef idx="1">
+            <a:schemeClr val="accent1"/>
+          </a:fillRef>
+          <a:effectRef idx="0">
+            <a:schemeClr val="accent1"/>
+          </a:effectRef>
+          <a:fontRef idx="minor">
+            <a:schemeClr val="lt1"/>
+          </a:fontRef>
+        </p:style>
+        <p:txBody>
+          <a:bodyPr rtlCol="0" anchor="ctr"/>
+          <a:lstStyle/>
+          <a:p>
+            <a:pPr algn="ctr"/>
+            <a:endParaRPr lang="pt-PT" sz="3360"/>
+          </a:p>
+        </p:txBody>
+      </p:sp>
+      <p:sp>
+        <p:nvSpPr>
+          <p:cNvPr id="98" name="CaixaDeTexto 97">
+            <a:extLst>
+              <a:ext uri="{FF2B5EF4-FFF2-40B4-BE49-F238E27FC236}">
+                <a16:creationId xmlns:a16="http://schemas.microsoft.com/office/drawing/2014/main" id="{ED44DC56-05F8-8B09-AFFE-F5614C3C2900}"/>
+              </a:ext>
+            </a:extLst>
+          </p:cNvPr>
+          <p:cNvSpPr txBox="1"/>
+          <p:nvPr/>
+        </p:nvSpPr>
+        <p:spPr>
+          <a:xfrm>
+            <a:off x="4559910" y="1787925"/>
+            <a:ext cx="2074867" cy="646331"/>
+          </a:xfrm>
+          <a:prstGeom prst="rect">
+            <a:avLst/>
+          </a:prstGeom>
+          <a:noFill/>
+        </p:spPr>
+        <p:txBody>
+          <a:bodyPr wrap="square" rtlCol="0">
+            <a:spAutoFit/>
+          </a:bodyPr>
+          <a:lstStyle/>
+          <a:p>
+            <a:pPr algn="ctr"/>
+            <a:r>
+              <a:rPr lang="pt-PT" dirty="0"/>
+              <a:t>External </a:t>
+            </a:r>
+          </a:p>
+          <a:p>
+            <a:pPr algn="ctr"/>
+            <a:r>
+              <a:rPr lang="pt-PT" dirty="0"/>
+              <a:t>Clients</a:t>
+            </a:r>
+          </a:p>
+        </p:txBody>
+      </p:sp>
+      <p:cxnSp>
+        <p:nvCxnSpPr>
+          <p:cNvPr id="99" name="Conexão reta unidirecional 98">
+            <a:extLst>
+              <a:ext uri="{FF2B5EF4-FFF2-40B4-BE49-F238E27FC236}">
+                <a16:creationId xmlns:a16="http://schemas.microsoft.com/office/drawing/2014/main" id="{2425DC48-5D96-828C-AAA5-66ACCC507ECD}"/>
+              </a:ext>
+            </a:extLst>
+          </p:cNvPr>
+          <p:cNvCxnSpPr>
+            <a:cxnSpLocks/>
+            <a:stCxn id="49" idx="0"/>
+            <a:endCxn id="97" idx="2"/>
+          </p:cNvCxnSpPr>
+          <p:nvPr/>
+        </p:nvCxnSpPr>
+        <p:spPr>
+          <a:xfrm flipV="1">
+            <a:off x="5597345" y="2514600"/>
+            <a:ext cx="0" cy="1711527"/>
+          </a:xfrm>
+          <a:prstGeom prst="straightConnector1">
+            <a:avLst/>
+          </a:prstGeom>
+          <a:ln>
+            <a:headEnd type="triangle"/>
+            <a:tailEnd type="triangle"/>
+          </a:ln>
+        </p:spPr>
+        <p:style>
+          <a:lnRef idx="2">
+            <a:schemeClr val="accent1"/>
+          </a:lnRef>
+          <a:fillRef idx="0">
+            <a:schemeClr val="accent1"/>
+          </a:fillRef>
+          <a:effectRef idx="1">
+            <a:schemeClr val="accent1"/>
+          </a:effectRef>
+          <a:fontRef idx="minor">
+            <a:schemeClr val="tx1"/>
+          </a:fontRef>
+        </p:style>
+      </p:cxnSp>
+      <p:sp>
+        <p:nvSpPr>
+          <p:cNvPr id="102" name="Retângulo: Cantos Arredondados 101">
+            <a:extLst>
+              <a:ext uri="{FF2B5EF4-FFF2-40B4-BE49-F238E27FC236}">
+                <a16:creationId xmlns:a16="http://schemas.microsoft.com/office/drawing/2014/main" id="{962E7B48-147A-B269-E29D-8EF3670159AE}"/>
+              </a:ext>
+            </a:extLst>
+          </p:cNvPr>
+          <p:cNvSpPr>
+            <a:spLocks noChangeAspect="1"/>
+          </p:cNvSpPr>
+          <p:nvPr/>
+        </p:nvSpPr>
+        <p:spPr>
+          <a:xfrm>
+            <a:off x="787388" y="2733412"/>
+            <a:ext cx="2976378" cy="5940713"/>
+          </a:xfrm>
+          <a:prstGeom prst="roundRect">
+            <a:avLst>
+              <a:gd name="adj" fmla="val 13755"/>
+            </a:avLst>
+          </a:prstGeom>
+          <a:noFill/>
+          <a:ln>
+            <a:solidFill>
+              <a:schemeClr val="tx1"/>
+            </a:solidFill>
+          </a:ln>
+        </p:spPr>
+        <p:style>
+          <a:lnRef idx="2">
+            <a:schemeClr val="accent1">
+              <a:shade val="15000"/>
+            </a:schemeClr>
+          </a:lnRef>
+          <a:fillRef idx="1">
+            <a:schemeClr val="accent1"/>
+          </a:fillRef>
+          <a:effectRef idx="0">
+            <a:schemeClr val="accent1"/>
+          </a:effectRef>
+          <a:fontRef idx="minor">
+            <a:schemeClr val="lt1"/>
+          </a:fontRef>
+        </p:style>
+        <p:txBody>
+          <a:bodyPr rtlCol="0" anchor="ctr"/>
+          <a:lstStyle/>
+          <a:p>
+            <a:pPr algn="ctr"/>
+            <a:endParaRPr lang="pt-PT" sz="3360"/>
+          </a:p>
+        </p:txBody>
+      </p:sp>
+      <p:sp>
+        <p:nvSpPr>
+          <p:cNvPr id="103" name="CaixaDeTexto 102">
+            <a:extLst>
+              <a:ext uri="{FF2B5EF4-FFF2-40B4-BE49-F238E27FC236}">
+                <a16:creationId xmlns:a16="http://schemas.microsoft.com/office/drawing/2014/main" id="{2F3B66BC-57A0-0530-AB2C-D5643EDC6D13}"/>
+              </a:ext>
+            </a:extLst>
+          </p:cNvPr>
+          <p:cNvSpPr txBox="1"/>
+          <p:nvPr/>
+        </p:nvSpPr>
+        <p:spPr>
+          <a:xfrm>
+            <a:off x="787389" y="2744308"/>
+            <a:ext cx="2976378" cy="369332"/>
+          </a:xfrm>
+          <a:prstGeom prst="rect">
+            <a:avLst/>
+          </a:prstGeom>
+          <a:noFill/>
+        </p:spPr>
+        <p:txBody>
+          <a:bodyPr wrap="square" rtlCol="0">
+            <a:spAutoFit/>
+          </a:bodyPr>
+          <a:lstStyle/>
+          <a:p>
+            <a:pPr algn="ctr"/>
+            <a:r>
+              <a:rPr lang="pt-PT" b="1" dirty="0"/>
+              <a:t>Backend</a:t>
+            </a:r>
+          </a:p>
+        </p:txBody>
+      </p:sp>
+      <p:sp>
+        <p:nvSpPr>
+          <p:cNvPr id="104" name="Retângulo: Cantos Arredondados 103">
+            <a:extLst>
+              <a:ext uri="{FF2B5EF4-FFF2-40B4-BE49-F238E27FC236}">
+                <a16:creationId xmlns:a16="http://schemas.microsoft.com/office/drawing/2014/main" id="{23279E53-23F4-3B34-8683-341F0927051F}"/>
+              </a:ext>
+            </a:extLst>
+          </p:cNvPr>
+          <p:cNvSpPr>
+            <a:spLocks noChangeAspect="1"/>
+          </p:cNvSpPr>
+          <p:nvPr/>
+        </p:nvSpPr>
+        <p:spPr>
+          <a:xfrm>
+            <a:off x="7325558" y="1486982"/>
+            <a:ext cx="4904542" cy="3070006"/>
+          </a:xfrm>
+          <a:prstGeom prst="roundRect">
+            <a:avLst>
+              <a:gd name="adj" fmla="val 13755"/>
+            </a:avLst>
+          </a:prstGeom>
+          <a:noFill/>
+          <a:ln>
+            <a:solidFill>
+              <a:schemeClr val="tx1"/>
+            </a:solidFill>
+          </a:ln>
+        </p:spPr>
+        <p:style>
+          <a:lnRef idx="2">
+            <a:schemeClr val="accent1">
+              <a:shade val="15000"/>
+            </a:schemeClr>
+          </a:lnRef>
+          <a:fillRef idx="1">
+            <a:schemeClr val="accent1"/>
+          </a:fillRef>
+          <a:effectRef idx="0">
+            <a:schemeClr val="accent1"/>
+          </a:effectRef>
+          <a:fontRef idx="minor">
+            <a:schemeClr val="lt1"/>
+          </a:fontRef>
+        </p:style>
+        <p:txBody>
+          <a:bodyPr rtlCol="0" anchor="ctr"/>
+          <a:lstStyle/>
+          <a:p>
+            <a:pPr algn="ctr"/>
+            <a:endParaRPr lang="pt-PT" sz="3360"/>
+          </a:p>
+        </p:txBody>
+      </p:sp>
+      <p:sp>
+        <p:nvSpPr>
+          <p:cNvPr id="105" name="CaixaDeTexto 104">
+            <a:extLst>
+              <a:ext uri="{FF2B5EF4-FFF2-40B4-BE49-F238E27FC236}">
+                <a16:creationId xmlns:a16="http://schemas.microsoft.com/office/drawing/2014/main" id="{5B215A79-005A-0578-2122-6D42B4664234}"/>
+              </a:ext>
+            </a:extLst>
+          </p:cNvPr>
+          <p:cNvSpPr txBox="1"/>
+          <p:nvPr/>
+        </p:nvSpPr>
+        <p:spPr>
+          <a:xfrm>
+            <a:off x="7298505" y="1499682"/>
+            <a:ext cx="4931595" cy="369332"/>
+          </a:xfrm>
+          <a:prstGeom prst="rect">
+            <a:avLst/>
+          </a:prstGeom>
+          <a:noFill/>
+        </p:spPr>
+        <p:txBody>
+          <a:bodyPr wrap="square" rtlCol="0">
+            <a:spAutoFit/>
+          </a:bodyPr>
+          <a:lstStyle/>
+          <a:p>
+            <a:pPr algn="ctr"/>
+            <a:r>
+              <a:rPr lang="pt-PT" b="1" dirty="0"/>
+              <a:t>Frontend</a:t>
+            </a:r>
+          </a:p>
+        </p:txBody>
+      </p:sp>
+      <p:cxnSp>
+        <p:nvCxnSpPr>
+          <p:cNvPr id="20" name="Conexão reta unidirecional 84">
+            <a:extLst>
+              <a:ext uri="{FF2B5EF4-FFF2-40B4-BE49-F238E27FC236}">
+                <a16:creationId xmlns:a16="http://schemas.microsoft.com/office/drawing/2014/main" id="{88F10570-0E22-E576-6CFB-EBEDFD9FBCEB}"/>
+              </a:ext>
+            </a:extLst>
+          </p:cNvPr>
+          <p:cNvCxnSpPr>
+            <a:cxnSpLocks/>
+            <a:stCxn id="55" idx="2"/>
+            <a:endCxn id="56" idx="3"/>
+          </p:cNvCxnSpPr>
+          <p:nvPr/>
+        </p:nvCxnSpPr>
+        <p:spPr>
+          <a:xfrm rot="5400000">
+            <a:off x="10306956" y="3194115"/>
+            <a:ext cx="410243" cy="935094"/>
+          </a:xfrm>
+          <a:prstGeom prst="bentConnector2">
+            <a:avLst/>
+          </a:prstGeom>
+          <a:ln>
+            <a:headEnd type="triangle"/>
+            <a:tailEnd type="triangle"/>
+          </a:ln>
+        </p:spPr>
+        <p:style>
+          <a:lnRef idx="2">
+            <a:schemeClr val="accent1"/>
+          </a:lnRef>
+          <a:fillRef idx="0">
+            <a:schemeClr val="accent1"/>
+          </a:fillRef>
+          <a:effectRef idx="1">
+            <a:schemeClr val="accent1"/>
+          </a:effectRef>
+          <a:fontRef idx="minor">
+            <a:schemeClr val="tx1"/>
+          </a:fontRef>
+        </p:style>
+      </p:cxnSp>
+      <p:pic>
+        <p:nvPicPr>
+          <p:cNvPr id="32" name="Picture 4" descr="Free Sync Icon - Free Download Design &amp; Development Icons | IconScout">
+            <a:extLst>
+              <a:ext uri="{FF2B5EF4-FFF2-40B4-BE49-F238E27FC236}">
+                <a16:creationId xmlns:a16="http://schemas.microsoft.com/office/drawing/2014/main" id="{476ACF65-4C7F-3E56-3482-CCAD53E55C1C}"/>
+              </a:ext>
+            </a:extLst>
+          </p:cNvPr>
+          <p:cNvPicPr>
+            <a:picLocks noChangeAspect="1" noChangeArrowheads="1"/>
+          </p:cNvPicPr>
+          <p:nvPr/>
+        </p:nvPicPr>
+        <p:blipFill>
+          <a:blip r:embed="rId8">
+            <a:extLst>
+              <a:ext uri="{28A0092B-C50C-407E-A947-70E740481C1C}">
+                <a14:useLocalDpi xmlns:a14="http://schemas.microsoft.com/office/drawing/2010/main" val="0"/>
+              </a:ext>
+            </a:extLst>
+          </a:blip>
+          <a:srcRect/>
+          <a:stretch>
+            <a:fillRect/>
+          </a:stretch>
+        </p:blipFill>
+        <p:spPr bwMode="auto">
+          <a:xfrm>
+            <a:off x="9511130" y="7803057"/>
+            <a:ext cx="533400" cy="533400"/>
+          </a:xfrm>
+          <a:prstGeom prst="rect">
+            <a:avLst/>
+          </a:prstGeom>
+          <a:noFill/>
+          <a:extLst>
+            <a:ext uri="{909E8E84-426E-40DD-AFC4-6F175D3DCCD1}">
+              <a14:hiddenFill xmlns:a14="http://schemas.microsoft.com/office/drawing/2010/main">
+                <a:solidFill>
+                  <a:srgbClr val="FFFFFF"/>
+                </a:solidFill>
+              </a14:hiddenFill>
+            </a:ext>
+          </a:extLst>
+        </p:spPr>
+      </p:pic>
+      <p:grpSp>
+        <p:nvGrpSpPr>
+          <p:cNvPr id="33" name="Agrupar 32">
+            <a:extLst>
+              <a:ext uri="{FF2B5EF4-FFF2-40B4-BE49-F238E27FC236}">
+                <a16:creationId xmlns:a16="http://schemas.microsoft.com/office/drawing/2014/main" id="{2093DD43-F214-8525-F960-590558E9974A}"/>
+              </a:ext>
+            </a:extLst>
+          </p:cNvPr>
+          <p:cNvGrpSpPr/>
+          <p:nvPr/>
+        </p:nvGrpSpPr>
+        <p:grpSpPr>
+          <a:xfrm>
+            <a:off x="7478570" y="6213256"/>
+            <a:ext cx="2132051" cy="1449376"/>
+            <a:chOff x="8587622" y="4873842"/>
+            <a:chExt cx="2132051" cy="1449376"/>
+          </a:xfrm>
+        </p:grpSpPr>
+        <p:sp>
+          <p:nvSpPr>
+            <p:cNvPr id="34" name="Retângulo: Cantos Arredondados 33">
+              <a:extLst>
+                <a:ext uri="{FF2B5EF4-FFF2-40B4-BE49-F238E27FC236}">
+                  <a16:creationId xmlns:a16="http://schemas.microsoft.com/office/drawing/2014/main" id="{7B7AB3C7-2E70-E369-8C7E-58541ED2DA4A}"/>
+                </a:ext>
+              </a:extLst>
+            </p:cNvPr>
+            <p:cNvSpPr>
+              <a:spLocks noChangeAspect="1"/>
+            </p:cNvSpPr>
+            <p:nvPr/>
+          </p:nvSpPr>
+          <p:spPr>
+            <a:xfrm>
+              <a:off x="8587623" y="4876960"/>
+              <a:ext cx="2132049" cy="1446258"/>
+            </a:xfrm>
+            <a:prstGeom prst="roundRect">
+              <a:avLst/>
+            </a:prstGeom>
+            <a:noFill/>
+            <a:ln>
+              <a:solidFill>
+                <a:schemeClr val="tx1"/>
+              </a:solidFill>
+            </a:ln>
+          </p:spPr>
+          <p:style>
+            <a:lnRef idx="2">
+              <a:schemeClr val="accent1">
+                <a:shade val="15000"/>
+              </a:schemeClr>
+            </a:lnRef>
+            <a:fillRef idx="1">
+              <a:schemeClr val="accent1"/>
+            </a:fillRef>
+            <a:effectRef idx="0">
+              <a:schemeClr val="accent1"/>
+            </a:effectRef>
+            <a:fontRef idx="minor">
+              <a:schemeClr val="lt1"/>
+            </a:fontRef>
+          </p:style>
+          <p:txBody>
+            <a:bodyPr rtlCol="0" anchor="ctr"/>
+            <a:lstStyle/>
+            <a:p>
+              <a:pPr algn="ctr"/>
+              <a:endParaRPr lang="pt-PT" sz="3360"/>
+            </a:p>
+          </p:txBody>
+        </p:sp>
+        <p:pic>
+          <p:nvPicPr>
+            <p:cNvPr id="36" name="Picture 8" descr="Brand">
+              <a:extLst>
+                <a:ext uri="{FF2B5EF4-FFF2-40B4-BE49-F238E27FC236}">
+                  <a16:creationId xmlns:a16="http://schemas.microsoft.com/office/drawing/2014/main" id="{2837D065-83CF-DAB1-3CE0-048120EDD577}"/>
+                </a:ext>
+              </a:extLst>
+            </p:cNvPr>
+            <p:cNvPicPr>
+              <a:picLocks noChangeAspect="1" noChangeArrowheads="1"/>
+            </p:cNvPicPr>
+            <p:nvPr/>
+          </p:nvPicPr>
+          <p:blipFill>
+            <a:blip r:embed="rId9">
+              <a:extLst>
+                <a:ext uri="{28A0092B-C50C-407E-A947-70E740481C1C}">
+                  <a14:useLocalDpi xmlns:a14="http://schemas.microsoft.com/office/drawing/2010/main" val="0"/>
+                </a:ext>
+              </a:extLst>
+            </a:blip>
+            <a:srcRect/>
+            <a:stretch>
+              <a:fillRect/>
+            </a:stretch>
+          </p:blipFill>
+          <p:spPr bwMode="auto">
+            <a:xfrm>
+              <a:off x="9900865" y="5345661"/>
+              <a:ext cx="571589" cy="831802"/>
+            </a:xfrm>
+            <a:prstGeom prst="rect">
+              <a:avLst/>
+            </a:prstGeom>
+            <a:noFill/>
+            <a:extLst>
+              <a:ext uri="{909E8E84-426E-40DD-AFC4-6F175D3DCCD1}">
+                <a14:hiddenFill xmlns:a14="http://schemas.microsoft.com/office/drawing/2010/main">
+                  <a:solidFill>
+                    <a:srgbClr val="FFFFFF"/>
+                  </a:solidFill>
+                </a14:hiddenFill>
+              </a:ext>
+            </a:extLst>
+          </p:spPr>
+        </p:pic>
+        <p:pic>
+          <p:nvPicPr>
+            <p:cNvPr id="37" name="Picture 4" descr="Windows Logo PNGs for Free Download">
+              <a:extLst>
+                <a:ext uri="{FF2B5EF4-FFF2-40B4-BE49-F238E27FC236}">
+                  <a16:creationId xmlns:a16="http://schemas.microsoft.com/office/drawing/2014/main" id="{77A222DA-8D9E-3986-79D0-94F02919B02A}"/>
+                </a:ext>
+              </a:extLst>
+            </p:cNvPr>
+            <p:cNvPicPr>
+              <a:picLocks noChangeAspect="1" noChangeArrowheads="1"/>
+            </p:cNvPicPr>
+            <p:nvPr/>
+          </p:nvPicPr>
+          <p:blipFill>
+            <a:blip r:embed="rId10">
+              <a:extLst>
+                <a:ext uri="{28A0092B-C50C-407E-A947-70E740481C1C}">
+                  <a14:useLocalDpi xmlns:a14="http://schemas.microsoft.com/office/drawing/2010/main" val="0"/>
+                </a:ext>
+              </a:extLst>
+            </a:blip>
+            <a:srcRect/>
+            <a:stretch>
+              <a:fillRect/>
+            </a:stretch>
+          </p:blipFill>
+          <p:spPr bwMode="auto">
+            <a:xfrm>
+              <a:off x="8654310" y="5049476"/>
+              <a:ext cx="1170535" cy="1170535"/>
+            </a:xfrm>
+            <a:prstGeom prst="rect">
+              <a:avLst/>
+            </a:prstGeom>
+            <a:noFill/>
+            <a:extLst>
+              <a:ext uri="{909E8E84-426E-40DD-AFC4-6F175D3DCCD1}">
+                <a14:hiddenFill xmlns:a14="http://schemas.microsoft.com/office/drawing/2010/main">
+                  <a:solidFill>
+                    <a:srgbClr val="FFFFFF"/>
+                  </a:solidFill>
+                </a14:hiddenFill>
+              </a:ext>
+            </a:extLst>
+          </p:spPr>
+        </p:pic>
+        <p:sp>
+          <p:nvSpPr>
+            <p:cNvPr id="38" name="CaixaDeTexto 37">
+              <a:extLst>
+                <a:ext uri="{FF2B5EF4-FFF2-40B4-BE49-F238E27FC236}">
+                  <a16:creationId xmlns:a16="http://schemas.microsoft.com/office/drawing/2014/main" id="{A30423A7-0FDB-918A-7DB3-C69C441D38DA}"/>
+                </a:ext>
+              </a:extLst>
+            </p:cNvPr>
+            <p:cNvSpPr txBox="1"/>
+            <p:nvPr/>
+          </p:nvSpPr>
+          <p:spPr>
+            <a:xfrm>
+              <a:off x="8587622" y="4873842"/>
+              <a:ext cx="2132051" cy="369332"/>
+            </a:xfrm>
+            <a:prstGeom prst="rect">
+              <a:avLst/>
+            </a:prstGeom>
+            <a:noFill/>
+          </p:spPr>
+          <p:txBody>
+            <a:bodyPr wrap="square" rtlCol="0">
+              <a:spAutoFit/>
+            </a:bodyPr>
+            <a:lstStyle/>
+            <a:p>
+              <a:pPr algn="ctr"/>
+              <a:r>
+                <a:rPr lang="pt-PT" dirty="0"/>
+                <a:t>Desktop App</a:t>
+              </a:r>
+            </a:p>
+          </p:txBody>
+        </p:sp>
+      </p:grpSp>
+      <p:grpSp>
+        <p:nvGrpSpPr>
+          <p:cNvPr id="44" name="Agrupar 43">
+            <a:extLst>
+              <a:ext uri="{FF2B5EF4-FFF2-40B4-BE49-F238E27FC236}">
+                <a16:creationId xmlns:a16="http://schemas.microsoft.com/office/drawing/2014/main" id="{C94521AD-428A-B0E2-1E86-637BCA2BF259}"/>
+              </a:ext>
+            </a:extLst>
+          </p:cNvPr>
+          <p:cNvGrpSpPr/>
+          <p:nvPr/>
+        </p:nvGrpSpPr>
+        <p:grpSpPr>
+          <a:xfrm>
+            <a:off x="9913599" y="6213255"/>
+            <a:ext cx="2132049" cy="1446259"/>
+            <a:chOff x="8603297" y="7086559"/>
+            <a:chExt cx="2132049" cy="1446258"/>
+          </a:xfrm>
+        </p:grpSpPr>
+        <p:pic>
+          <p:nvPicPr>
+            <p:cNvPr id="46" name="Picture 4" descr="Database icon - Free download on Iconfinder">
+              <a:extLst>
+                <a:ext uri="{FF2B5EF4-FFF2-40B4-BE49-F238E27FC236}">
+                  <a16:creationId xmlns:a16="http://schemas.microsoft.com/office/drawing/2014/main" id="{9A927DF5-EBC0-DB48-9F31-F9ED30671242}"/>
+                </a:ext>
+              </a:extLst>
+            </p:cNvPr>
+            <p:cNvPicPr>
+              <a:picLocks noChangeAspect="1" noChangeArrowheads="1"/>
+            </p:cNvPicPr>
+            <p:nvPr/>
+          </p:nvPicPr>
+          <p:blipFill>
+            <a:blip r:embed="rId11">
+              <a:extLst>
+                <a:ext uri="{28A0092B-C50C-407E-A947-70E740481C1C}">
+                  <a14:useLocalDpi xmlns:a14="http://schemas.microsoft.com/office/drawing/2010/main" val="0"/>
+                </a:ext>
+              </a:extLst>
+            </a:blip>
+            <a:srcRect/>
+            <a:stretch>
+              <a:fillRect/>
+            </a:stretch>
+          </p:blipFill>
+          <p:spPr bwMode="auto">
+            <a:xfrm>
+              <a:off x="8953441" y="7538699"/>
+              <a:ext cx="741546" cy="741546"/>
+            </a:xfrm>
+            <a:prstGeom prst="rect">
+              <a:avLst/>
+            </a:prstGeom>
+            <a:noFill/>
+            <a:extLst>
+              <a:ext uri="{909E8E84-426E-40DD-AFC4-6F175D3DCCD1}">
+                <a14:hiddenFill xmlns:a14="http://schemas.microsoft.com/office/drawing/2010/main">
+                  <a:solidFill>
+                    <a:srgbClr val="FFFFFF"/>
+                  </a:solidFill>
+                </a14:hiddenFill>
+              </a:ext>
+            </a:extLst>
+          </p:spPr>
+        </p:pic>
+        <p:pic>
+          <p:nvPicPr>
+            <p:cNvPr id="47" name="Imagem 46">
+              <a:extLst>
+                <a:ext uri="{FF2B5EF4-FFF2-40B4-BE49-F238E27FC236}">
+                  <a16:creationId xmlns:a16="http://schemas.microsoft.com/office/drawing/2014/main" id="{50D839D2-87C3-64F8-FD71-3E12C4271F12}"/>
+                </a:ext>
+              </a:extLst>
+            </p:cNvPr>
+            <p:cNvPicPr>
+              <a:picLocks noChangeAspect="1"/>
+            </p:cNvPicPr>
+            <p:nvPr/>
+          </p:nvPicPr>
+          <p:blipFill>
+            <a:blip r:embed="rId12"/>
+            <a:stretch>
+              <a:fillRect/>
+            </a:stretch>
+          </p:blipFill>
+          <p:spPr>
+            <a:xfrm>
+              <a:off x="9921674" y="7648767"/>
+              <a:ext cx="607493" cy="601242"/>
+            </a:xfrm>
+            <a:prstGeom prst="rect">
+              <a:avLst/>
+            </a:prstGeom>
+          </p:spPr>
+        </p:pic>
+        <p:sp>
+          <p:nvSpPr>
+            <p:cNvPr id="48" name="Retângulo: Cantos Arredondados 47">
+              <a:extLst>
+                <a:ext uri="{FF2B5EF4-FFF2-40B4-BE49-F238E27FC236}">
+                  <a16:creationId xmlns:a16="http://schemas.microsoft.com/office/drawing/2014/main" id="{1D9DAD32-4049-449E-6B18-74514688355D}"/>
+                </a:ext>
+              </a:extLst>
+            </p:cNvPr>
+            <p:cNvSpPr>
+              <a:spLocks noChangeAspect="1"/>
+            </p:cNvSpPr>
+            <p:nvPr/>
+          </p:nvSpPr>
+          <p:spPr>
+            <a:xfrm>
+              <a:off x="8603297" y="7086559"/>
+              <a:ext cx="2132049" cy="1446258"/>
+            </a:xfrm>
+            <a:prstGeom prst="roundRect">
+              <a:avLst/>
+            </a:prstGeom>
+            <a:noFill/>
+            <a:ln>
+              <a:solidFill>
+                <a:schemeClr val="tx1"/>
+              </a:solidFill>
+            </a:ln>
+          </p:spPr>
+          <p:style>
+            <a:lnRef idx="2">
+              <a:schemeClr val="accent1">
+                <a:shade val="15000"/>
+              </a:schemeClr>
+            </a:lnRef>
+            <a:fillRef idx="1">
+              <a:schemeClr val="accent1"/>
+            </a:fillRef>
+            <a:effectRef idx="0">
+              <a:schemeClr val="accent1"/>
+            </a:effectRef>
+            <a:fontRef idx="minor">
+              <a:schemeClr val="lt1"/>
+            </a:fontRef>
+          </p:style>
+          <p:txBody>
+            <a:bodyPr rtlCol="0" anchor="ctr"/>
+            <a:lstStyle/>
+            <a:p>
+              <a:pPr algn="ctr"/>
+              <a:endParaRPr lang="pt-PT" sz="3360"/>
+            </a:p>
+          </p:txBody>
+        </p:sp>
+        <p:sp>
+          <p:nvSpPr>
+            <p:cNvPr id="52" name="CaixaDeTexto 51">
+              <a:extLst>
+                <a:ext uri="{FF2B5EF4-FFF2-40B4-BE49-F238E27FC236}">
+                  <a16:creationId xmlns:a16="http://schemas.microsoft.com/office/drawing/2014/main" id="{3F8F14B2-F2F4-3F86-0A6D-36A378341209}"/>
+                </a:ext>
+              </a:extLst>
+            </p:cNvPr>
+            <p:cNvSpPr txBox="1"/>
+            <p:nvPr/>
+          </p:nvSpPr>
+          <p:spPr>
+            <a:xfrm>
+              <a:off x="8603297" y="7092379"/>
+              <a:ext cx="2132049" cy="369332"/>
+            </a:xfrm>
+            <a:prstGeom prst="rect">
+              <a:avLst/>
+            </a:prstGeom>
+            <a:noFill/>
+          </p:spPr>
+          <p:txBody>
+            <a:bodyPr wrap="square" rtlCol="0">
+              <a:spAutoFit/>
+            </a:bodyPr>
+            <a:lstStyle/>
+            <a:p>
+              <a:pPr algn="ctr"/>
+              <a:r>
+                <a:rPr lang="pt-PT" dirty="0"/>
+                <a:t>Local Database</a:t>
+              </a:r>
+            </a:p>
+          </p:txBody>
+        </p:sp>
+      </p:grpSp>
+      <p:cxnSp>
+        <p:nvCxnSpPr>
+          <p:cNvPr id="54" name="Conexão reta unidirecional 53">
+            <a:extLst>
+              <a:ext uri="{FF2B5EF4-FFF2-40B4-BE49-F238E27FC236}">
+                <a16:creationId xmlns:a16="http://schemas.microsoft.com/office/drawing/2014/main" id="{9B4AE5F2-D33B-9A1F-D9C5-A5B0C1164C52}"/>
+              </a:ext>
+            </a:extLst>
+          </p:cNvPr>
+          <p:cNvCxnSpPr>
+            <a:cxnSpLocks/>
+            <a:stCxn id="48" idx="1"/>
+            <a:endCxn id="34" idx="3"/>
+          </p:cNvCxnSpPr>
+          <p:nvPr/>
+        </p:nvCxnSpPr>
+        <p:spPr>
+          <a:xfrm flipH="1">
+            <a:off x="9610620" y="6936385"/>
+            <a:ext cx="302979" cy="3118"/>
+          </a:xfrm>
+          <a:prstGeom prst="straightConnector1">
+            <a:avLst/>
+          </a:prstGeom>
+          <a:ln>
+            <a:headEnd type="triangle"/>
+            <a:tailEnd type="triangle"/>
+          </a:ln>
+        </p:spPr>
+        <p:style>
+          <a:lnRef idx="2">
+            <a:schemeClr val="accent1"/>
+          </a:lnRef>
+          <a:fillRef idx="0">
+            <a:schemeClr val="accent1"/>
+          </a:fillRef>
+          <a:effectRef idx="1">
+            <a:schemeClr val="accent1"/>
+          </a:effectRef>
+          <a:fontRef idx="minor">
+            <a:schemeClr val="tx1"/>
+          </a:fontRef>
+        </p:style>
+      </p:cxnSp>
+      <p:sp>
+        <p:nvSpPr>
+          <p:cNvPr id="59" name="CaixaDeTexto 58">
+            <a:extLst>
+              <a:ext uri="{FF2B5EF4-FFF2-40B4-BE49-F238E27FC236}">
+                <a16:creationId xmlns:a16="http://schemas.microsoft.com/office/drawing/2014/main" id="{5B0D24D9-A306-8F40-0C8C-D49D2E9DD638}"/>
+              </a:ext>
+            </a:extLst>
+          </p:cNvPr>
+          <p:cNvSpPr txBox="1"/>
+          <p:nvPr/>
+        </p:nvSpPr>
+        <p:spPr>
+          <a:xfrm>
+            <a:off x="9121008" y="8335571"/>
+            <a:ext cx="1313641" cy="338554"/>
+          </a:xfrm>
+          <a:prstGeom prst="rect">
+            <a:avLst/>
+          </a:prstGeom>
+          <a:noFill/>
+        </p:spPr>
+        <p:txBody>
+          <a:bodyPr wrap="square" rtlCol="0">
+            <a:spAutoFit/>
+          </a:bodyPr>
+          <a:lstStyle/>
+          <a:p>
+            <a:pPr algn="ctr"/>
+            <a:r>
+              <a:rPr lang="pt-PT" sz="1600" dirty="0"/>
+              <a:t>Sync Service</a:t>
+            </a:r>
+          </a:p>
+        </p:txBody>
+      </p:sp>
+      <p:sp>
+        <p:nvSpPr>
+          <p:cNvPr id="61" name="Retângulo: Cantos Arredondados 60">
+            <a:extLst>
+              <a:ext uri="{FF2B5EF4-FFF2-40B4-BE49-F238E27FC236}">
+                <a16:creationId xmlns:a16="http://schemas.microsoft.com/office/drawing/2014/main" id="{F4945026-8E1B-C608-1DFA-9904DC97D506}"/>
+              </a:ext>
+            </a:extLst>
+          </p:cNvPr>
+          <p:cNvSpPr>
+            <a:spLocks noChangeAspect="1"/>
+          </p:cNvSpPr>
+          <p:nvPr/>
+        </p:nvSpPr>
+        <p:spPr>
+          <a:xfrm>
+            <a:off x="7325558" y="5689955"/>
+            <a:ext cx="4904542" cy="3070006"/>
+          </a:xfrm>
+          <a:prstGeom prst="roundRect">
+            <a:avLst>
+              <a:gd name="adj" fmla="val 13755"/>
+            </a:avLst>
+          </a:prstGeom>
+          <a:noFill/>
+          <a:ln>
+            <a:solidFill>
+              <a:schemeClr val="tx1"/>
+            </a:solidFill>
+          </a:ln>
+        </p:spPr>
+        <p:style>
+          <a:lnRef idx="2">
+            <a:schemeClr val="accent1">
+              <a:shade val="15000"/>
+            </a:schemeClr>
+          </a:lnRef>
+          <a:fillRef idx="1">
+            <a:schemeClr val="accent1"/>
+          </a:fillRef>
+          <a:effectRef idx="0">
+            <a:schemeClr val="accent1"/>
+          </a:effectRef>
+          <a:fontRef idx="minor">
+            <a:schemeClr val="lt1"/>
+          </a:fontRef>
+        </p:style>
+        <p:txBody>
+          <a:bodyPr rtlCol="0" anchor="ctr"/>
+          <a:lstStyle/>
+          <a:p>
+            <a:pPr algn="ctr"/>
+            <a:endParaRPr lang="pt-PT" sz="3360"/>
+          </a:p>
+        </p:txBody>
+      </p:sp>
+      <p:sp>
+        <p:nvSpPr>
+          <p:cNvPr id="62" name="CaixaDeTexto 61">
+            <a:extLst>
+              <a:ext uri="{FF2B5EF4-FFF2-40B4-BE49-F238E27FC236}">
+                <a16:creationId xmlns:a16="http://schemas.microsoft.com/office/drawing/2014/main" id="{E3653AF3-290A-5E76-B819-5B51CCE4098C}"/>
+              </a:ext>
+            </a:extLst>
+          </p:cNvPr>
+          <p:cNvSpPr txBox="1"/>
+          <p:nvPr/>
+        </p:nvSpPr>
+        <p:spPr>
+          <a:xfrm>
+            <a:off x="7298505" y="5689955"/>
+            <a:ext cx="4931595" cy="369332"/>
+          </a:xfrm>
+          <a:prstGeom prst="rect">
+            <a:avLst/>
+          </a:prstGeom>
+          <a:noFill/>
+        </p:spPr>
+        <p:txBody>
+          <a:bodyPr wrap="square" rtlCol="0">
+            <a:spAutoFit/>
+          </a:bodyPr>
+          <a:lstStyle/>
+          <a:p>
+            <a:pPr algn="ctr"/>
+            <a:r>
+              <a:rPr lang="pt-PT" b="1" dirty="0"/>
+              <a:t>Frontend</a:t>
+            </a:r>
+          </a:p>
+        </p:txBody>
+      </p:sp>
+      <p:cxnSp>
+        <p:nvCxnSpPr>
+          <p:cNvPr id="64" name="Conexão reta unidirecional 84">
+            <a:extLst>
+              <a:ext uri="{FF2B5EF4-FFF2-40B4-BE49-F238E27FC236}">
+                <a16:creationId xmlns:a16="http://schemas.microsoft.com/office/drawing/2014/main" id="{1A345A34-DF53-FD8D-706A-327B3B90076C}"/>
+              </a:ext>
+            </a:extLst>
+          </p:cNvPr>
+          <p:cNvCxnSpPr>
+            <a:cxnSpLocks/>
+            <a:stCxn id="48" idx="2"/>
+            <a:endCxn id="32" idx="3"/>
+          </p:cNvCxnSpPr>
+          <p:nvPr/>
+        </p:nvCxnSpPr>
+        <p:spPr>
+          <a:xfrm rot="5400000">
+            <a:off x="10306956" y="7397088"/>
+            <a:ext cx="410243" cy="935094"/>
+          </a:xfrm>
+          <a:prstGeom prst="bentConnector2">
+            <a:avLst/>
+          </a:prstGeom>
+          <a:ln>
+            <a:headEnd type="triangle"/>
+            <a:tailEnd type="triangle"/>
+          </a:ln>
+        </p:spPr>
+        <p:style>
+          <a:lnRef idx="2">
+            <a:schemeClr val="accent1"/>
+          </a:lnRef>
+          <a:fillRef idx="0">
+            <a:schemeClr val="accent1"/>
+          </a:fillRef>
+          <a:effectRef idx="1">
+            <a:schemeClr val="accent1"/>
+          </a:effectRef>
+          <a:fontRef idx="minor">
+            <a:schemeClr val="tx1"/>
+          </a:fontRef>
+        </p:style>
+      </p:cxnSp>
+      <p:cxnSp>
+        <p:nvCxnSpPr>
+          <p:cNvPr id="69" name="Conexão reta unidirecional 84">
+            <a:extLst>
+              <a:ext uri="{FF2B5EF4-FFF2-40B4-BE49-F238E27FC236}">
+                <a16:creationId xmlns:a16="http://schemas.microsoft.com/office/drawing/2014/main" id="{7899CEAD-291D-9A50-3A52-80766964FBC6}"/>
+              </a:ext>
+            </a:extLst>
+          </p:cNvPr>
+          <p:cNvCxnSpPr>
+            <a:cxnSpLocks/>
+            <a:stCxn id="32" idx="1"/>
+            <a:endCxn id="49" idx="2"/>
+          </p:cNvCxnSpPr>
+          <p:nvPr/>
+        </p:nvCxnSpPr>
+        <p:spPr>
+          <a:xfrm rot="10800000">
+            <a:off x="5597346" y="5562955"/>
+            <a:ext cx="3913785" cy="2506802"/>
+          </a:xfrm>
+          <a:prstGeom prst="bentConnector2">
+            <a:avLst/>
+          </a:prstGeom>
+          <a:ln>
+            <a:headEnd type="triangle"/>
+            <a:tailEnd type="triangle"/>
+          </a:ln>
+        </p:spPr>
+        <p:style>
+          <a:lnRef idx="2">
+            <a:schemeClr val="accent1"/>
+          </a:lnRef>
+          <a:fillRef idx="0">
+            <a:schemeClr val="accent1"/>
+          </a:fillRef>
+          <a:effectRef idx="1">
+            <a:schemeClr val="accent1"/>
+          </a:effectRef>
+          <a:fontRef idx="minor">
+            <a:schemeClr val="tx1"/>
+          </a:fontRef>
+        </p:style>
+      </p:cxnSp>
+      <p:sp>
+        <p:nvSpPr>
+          <p:cNvPr id="81" name="Retângulo 80">
+            <a:extLst>
+              <a:ext uri="{FF2B5EF4-FFF2-40B4-BE49-F238E27FC236}">
+                <a16:creationId xmlns:a16="http://schemas.microsoft.com/office/drawing/2014/main" id="{97D182A5-8199-D9B2-F835-0415E8644306}"/>
+              </a:ext>
+            </a:extLst>
+          </p:cNvPr>
+          <p:cNvSpPr/>
+          <p:nvPr/>
+        </p:nvSpPr>
+        <p:spPr>
+          <a:xfrm rot="5400000">
+            <a:off x="9400362" y="4668384"/>
+            <a:ext cx="1144865" cy="923330"/>
+          </a:xfrm>
+          <a:prstGeom prst="rect">
+            <a:avLst/>
+          </a:prstGeom>
+          <a:noFill/>
+        </p:spPr>
+        <p:txBody>
+          <a:bodyPr wrap="none" lIns="91440" tIns="45720" rIns="91440" bIns="45720">
+            <a:spAutoFit/>
+          </a:bodyPr>
+          <a:lstStyle/>
+          <a:p>
+            <a:pPr algn="ctr"/>
+            <a:r>
+              <a:rPr lang="pt-PT" sz="5400" b="0" cap="none" spc="0" dirty="0">
+                <a:ln w="0"/>
+                <a:solidFill>
+                  <a:schemeClr val="tx1"/>
+                </a:solidFill>
+                <a:effectLst>
+                  <a:outerShdw blurRad="38100" dist="19050" dir="2700000" algn="tl" rotWithShape="0">
+                    <a:schemeClr val="dk1">
+                      <a:alpha val="40000"/>
+                    </a:schemeClr>
+                  </a:outerShdw>
+                </a:effectLst>
+              </a:rPr>
+              <a:t>…..</a:t>
+            </a:r>
+          </a:p>
+        </p:txBody>
+      </p:sp>
+    </p:spTree>
+    <p:extLst>
+      <p:ext uri="{BB962C8B-B14F-4D97-AF65-F5344CB8AC3E}">
+        <p14:creationId xmlns:p14="http://schemas.microsoft.com/office/powerpoint/2010/main" val="822737976"/>
+      </p:ext>
+    </p:extLst>
+  </p:cSld>
+  <p:clrMapOvr>
+    <a:masterClrMapping/>
+  </p:clrMapOvr>
+</p:sld>
+</file>
+
+<file path=ppt/slides/slide6.xml><?xml version="1.0" encoding="utf-8"?>
 <p:sld xmlns:a="http://schemas.openxmlformats.org/drawingml/2006/main" xmlns:r="http://schemas.openxmlformats.org/officeDocument/2006/relationships" xmlns:p="http://schemas.openxmlformats.org/presentationml/2006/main">
   <p:cSld>
     <p:spTree>
@@ -17273,6 +19683,594 @@
     <p:extLst>
       <p:ext uri="{BB962C8B-B14F-4D97-AF65-F5344CB8AC3E}">
         <p14:creationId xmlns:p14="http://schemas.microsoft.com/office/powerpoint/2010/main" val="408914952"/>
+      </p:ext>
+    </p:extLst>
+  </p:cSld>
+  <p:clrMapOvr>
+    <a:masterClrMapping/>
+  </p:clrMapOvr>
+</p:sld>
+</file>
+
+<file path=ppt/slides/slide7.xml><?xml version="1.0" encoding="utf-8"?>
+<p:sld xmlns:a="http://schemas.openxmlformats.org/drawingml/2006/main" xmlns:r="http://schemas.openxmlformats.org/officeDocument/2006/relationships" xmlns:p="http://schemas.openxmlformats.org/presentationml/2006/main">
+  <p:cSld>
+    <p:spTree>
+      <p:nvGrpSpPr>
+        <p:cNvPr id="1" name=""/>
+        <p:cNvGrpSpPr/>
+        <p:nvPr/>
+      </p:nvGrpSpPr>
+      <p:grpSpPr>
+        <a:xfrm>
+          <a:off x="0" y="0"/>
+          <a:ext cx="0" cy="0"/>
+          <a:chOff x="0" y="0"/>
+          <a:chExt cx="0" cy="0"/>
+        </a:xfrm>
+      </p:grpSpPr>
+      <p:sp>
+        <p:nvSpPr>
+          <p:cNvPr id="2" name="Oval 1">
+            <a:extLst>
+              <a:ext uri="{FF2B5EF4-FFF2-40B4-BE49-F238E27FC236}">
+                <a16:creationId xmlns:a16="http://schemas.microsoft.com/office/drawing/2014/main" id="{FDA1D22C-91E2-8381-7A9F-C2E6AF830C31}"/>
+              </a:ext>
+            </a:extLst>
+          </p:cNvPr>
+          <p:cNvSpPr/>
+          <p:nvPr/>
+        </p:nvSpPr>
+        <p:spPr>
+          <a:xfrm>
+            <a:off x="2273300" y="1625600"/>
+            <a:ext cx="360000" cy="360000"/>
+          </a:xfrm>
+          <a:prstGeom prst="ellipse">
+            <a:avLst/>
+          </a:prstGeom>
+          <a:solidFill>
+            <a:schemeClr val="accent2">
+              <a:lumMod val="20000"/>
+              <a:lumOff val="80000"/>
+            </a:schemeClr>
+          </a:solidFill>
+        </p:spPr>
+        <p:style>
+          <a:lnRef idx="2">
+            <a:schemeClr val="accent2"/>
+          </a:lnRef>
+          <a:fillRef idx="1">
+            <a:schemeClr val="lt1"/>
+          </a:fillRef>
+          <a:effectRef idx="0">
+            <a:schemeClr val="accent2"/>
+          </a:effectRef>
+          <a:fontRef idx="minor">
+            <a:schemeClr val="dk1"/>
+          </a:fontRef>
+        </p:style>
+        <p:txBody>
+          <a:bodyPr rtlCol="0" anchor="ctr"/>
+          <a:lstStyle/>
+          <a:p>
+            <a:pPr algn="ctr"/>
+            <a:r>
+              <a:rPr lang="pt-PT" sz="2000" dirty="0">
+                <a:solidFill>
+                  <a:schemeClr val="accent2"/>
+                </a:solidFill>
+              </a:rPr>
+              <a:t>1</a:t>
+            </a:r>
+            <a:endParaRPr lang="pt-PT" sz="1100" dirty="0">
+              <a:solidFill>
+                <a:schemeClr val="accent2"/>
+              </a:solidFill>
+            </a:endParaRPr>
+          </a:p>
+        </p:txBody>
+      </p:sp>
+      <p:sp>
+        <p:nvSpPr>
+          <p:cNvPr id="3" name="Oval 2">
+            <a:extLst>
+              <a:ext uri="{FF2B5EF4-FFF2-40B4-BE49-F238E27FC236}">
+                <a16:creationId xmlns:a16="http://schemas.microsoft.com/office/drawing/2014/main" id="{E6110478-6A13-2E86-8920-354FA5706E3C}"/>
+              </a:ext>
+            </a:extLst>
+          </p:cNvPr>
+          <p:cNvSpPr/>
+          <p:nvPr/>
+        </p:nvSpPr>
+        <p:spPr>
+          <a:xfrm>
+            <a:off x="2785700" y="1649050"/>
+            <a:ext cx="360000" cy="360000"/>
+          </a:xfrm>
+          <a:prstGeom prst="ellipse">
+            <a:avLst/>
+          </a:prstGeom>
+          <a:solidFill>
+            <a:schemeClr val="accent2">
+              <a:lumMod val="20000"/>
+              <a:lumOff val="80000"/>
+            </a:schemeClr>
+          </a:solidFill>
+        </p:spPr>
+        <p:style>
+          <a:lnRef idx="2">
+            <a:schemeClr val="accent2"/>
+          </a:lnRef>
+          <a:fillRef idx="1">
+            <a:schemeClr val="lt1"/>
+          </a:fillRef>
+          <a:effectRef idx="0">
+            <a:schemeClr val="accent2"/>
+          </a:effectRef>
+          <a:fontRef idx="minor">
+            <a:schemeClr val="dk1"/>
+          </a:fontRef>
+        </p:style>
+        <p:txBody>
+          <a:bodyPr rtlCol="0" anchor="ctr"/>
+          <a:lstStyle/>
+          <a:p>
+            <a:pPr algn="ctr"/>
+            <a:r>
+              <a:rPr lang="pt-PT" sz="2000" dirty="0">
+                <a:solidFill>
+                  <a:schemeClr val="accent2"/>
+                </a:solidFill>
+              </a:rPr>
+              <a:t>2</a:t>
+            </a:r>
+            <a:endParaRPr lang="pt-PT" sz="1100" dirty="0">
+              <a:solidFill>
+                <a:schemeClr val="accent2"/>
+              </a:solidFill>
+            </a:endParaRPr>
+          </a:p>
+        </p:txBody>
+      </p:sp>
+      <p:sp>
+        <p:nvSpPr>
+          <p:cNvPr id="4" name="Oval 3">
+            <a:extLst>
+              <a:ext uri="{FF2B5EF4-FFF2-40B4-BE49-F238E27FC236}">
+                <a16:creationId xmlns:a16="http://schemas.microsoft.com/office/drawing/2014/main" id="{1D4F8B29-8BB7-3061-51D1-9852414EFFD8}"/>
+              </a:ext>
+            </a:extLst>
+          </p:cNvPr>
+          <p:cNvSpPr/>
+          <p:nvPr/>
+        </p:nvSpPr>
+        <p:spPr>
+          <a:xfrm>
+            <a:off x="3298100" y="1649050"/>
+            <a:ext cx="360000" cy="360000"/>
+          </a:xfrm>
+          <a:prstGeom prst="ellipse">
+            <a:avLst/>
+          </a:prstGeom>
+          <a:solidFill>
+            <a:schemeClr val="accent2">
+              <a:lumMod val="20000"/>
+              <a:lumOff val="80000"/>
+            </a:schemeClr>
+          </a:solidFill>
+        </p:spPr>
+        <p:style>
+          <a:lnRef idx="2">
+            <a:schemeClr val="accent2"/>
+          </a:lnRef>
+          <a:fillRef idx="1">
+            <a:schemeClr val="lt1"/>
+          </a:fillRef>
+          <a:effectRef idx="0">
+            <a:schemeClr val="accent2"/>
+          </a:effectRef>
+          <a:fontRef idx="minor">
+            <a:schemeClr val="dk1"/>
+          </a:fontRef>
+        </p:style>
+        <p:txBody>
+          <a:bodyPr rtlCol="0" anchor="ctr"/>
+          <a:lstStyle/>
+          <a:p>
+            <a:pPr algn="ctr"/>
+            <a:r>
+              <a:rPr lang="pt-PT" sz="2000" dirty="0">
+                <a:solidFill>
+                  <a:schemeClr val="accent2"/>
+                </a:solidFill>
+              </a:rPr>
+              <a:t>3</a:t>
+            </a:r>
+            <a:endParaRPr lang="pt-PT" sz="1100" dirty="0">
+              <a:solidFill>
+                <a:schemeClr val="accent2"/>
+              </a:solidFill>
+            </a:endParaRPr>
+          </a:p>
+        </p:txBody>
+      </p:sp>
+      <p:sp>
+        <p:nvSpPr>
+          <p:cNvPr id="5" name="Oval 4">
+            <a:extLst>
+              <a:ext uri="{FF2B5EF4-FFF2-40B4-BE49-F238E27FC236}">
+                <a16:creationId xmlns:a16="http://schemas.microsoft.com/office/drawing/2014/main" id="{C5FD91B6-EEA4-4507-D035-0B7C3E662676}"/>
+              </a:ext>
+            </a:extLst>
+          </p:cNvPr>
+          <p:cNvSpPr/>
+          <p:nvPr/>
+        </p:nvSpPr>
+        <p:spPr>
+          <a:xfrm>
+            <a:off x="3810500" y="1649050"/>
+            <a:ext cx="360000" cy="360000"/>
+          </a:xfrm>
+          <a:prstGeom prst="ellipse">
+            <a:avLst/>
+          </a:prstGeom>
+          <a:solidFill>
+            <a:schemeClr val="accent2">
+              <a:lumMod val="20000"/>
+              <a:lumOff val="80000"/>
+            </a:schemeClr>
+          </a:solidFill>
+        </p:spPr>
+        <p:style>
+          <a:lnRef idx="2">
+            <a:schemeClr val="accent2"/>
+          </a:lnRef>
+          <a:fillRef idx="1">
+            <a:schemeClr val="lt1"/>
+          </a:fillRef>
+          <a:effectRef idx="0">
+            <a:schemeClr val="accent2"/>
+          </a:effectRef>
+          <a:fontRef idx="minor">
+            <a:schemeClr val="dk1"/>
+          </a:fontRef>
+        </p:style>
+        <p:txBody>
+          <a:bodyPr rtlCol="0" anchor="ctr"/>
+          <a:lstStyle/>
+          <a:p>
+            <a:pPr algn="ctr"/>
+            <a:r>
+              <a:rPr lang="pt-PT" sz="2000" dirty="0">
+                <a:solidFill>
+                  <a:schemeClr val="accent2"/>
+                </a:solidFill>
+              </a:rPr>
+              <a:t>4</a:t>
+            </a:r>
+            <a:endParaRPr lang="pt-PT" sz="1100" dirty="0">
+              <a:solidFill>
+                <a:schemeClr val="accent2"/>
+              </a:solidFill>
+            </a:endParaRPr>
+          </a:p>
+        </p:txBody>
+      </p:sp>
+      <p:sp>
+        <p:nvSpPr>
+          <p:cNvPr id="6" name="Oval 5">
+            <a:extLst>
+              <a:ext uri="{FF2B5EF4-FFF2-40B4-BE49-F238E27FC236}">
+                <a16:creationId xmlns:a16="http://schemas.microsoft.com/office/drawing/2014/main" id="{F4847276-439B-DA4F-B71E-F0DBBEB8B34E}"/>
+              </a:ext>
+            </a:extLst>
+          </p:cNvPr>
+          <p:cNvSpPr/>
+          <p:nvPr/>
+        </p:nvSpPr>
+        <p:spPr>
+          <a:xfrm>
+            <a:off x="4322900" y="1672500"/>
+            <a:ext cx="360000" cy="360000"/>
+          </a:xfrm>
+          <a:prstGeom prst="ellipse">
+            <a:avLst/>
+          </a:prstGeom>
+          <a:solidFill>
+            <a:schemeClr val="accent2">
+              <a:lumMod val="20000"/>
+              <a:lumOff val="80000"/>
+            </a:schemeClr>
+          </a:solidFill>
+        </p:spPr>
+        <p:style>
+          <a:lnRef idx="2">
+            <a:schemeClr val="accent2"/>
+          </a:lnRef>
+          <a:fillRef idx="1">
+            <a:schemeClr val="lt1"/>
+          </a:fillRef>
+          <a:effectRef idx="0">
+            <a:schemeClr val="accent2"/>
+          </a:effectRef>
+          <a:fontRef idx="minor">
+            <a:schemeClr val="dk1"/>
+          </a:fontRef>
+        </p:style>
+        <p:txBody>
+          <a:bodyPr rtlCol="0" anchor="ctr"/>
+          <a:lstStyle/>
+          <a:p>
+            <a:pPr algn="ctr"/>
+            <a:r>
+              <a:rPr lang="pt-PT" sz="2000" dirty="0">
+                <a:solidFill>
+                  <a:schemeClr val="accent2"/>
+                </a:solidFill>
+              </a:rPr>
+              <a:t>5</a:t>
+            </a:r>
+            <a:endParaRPr lang="pt-PT" sz="1100" dirty="0">
+              <a:solidFill>
+                <a:schemeClr val="accent2"/>
+              </a:solidFill>
+            </a:endParaRPr>
+          </a:p>
+        </p:txBody>
+      </p:sp>
+      <p:sp>
+        <p:nvSpPr>
+          <p:cNvPr id="7" name="Oval 6">
+            <a:extLst>
+              <a:ext uri="{FF2B5EF4-FFF2-40B4-BE49-F238E27FC236}">
+                <a16:creationId xmlns:a16="http://schemas.microsoft.com/office/drawing/2014/main" id="{118733FA-F06C-66C1-870E-54D0EE99C013}"/>
+              </a:ext>
+            </a:extLst>
+          </p:cNvPr>
+          <p:cNvSpPr/>
+          <p:nvPr/>
+        </p:nvSpPr>
+        <p:spPr>
+          <a:xfrm>
+            <a:off x="4835300" y="1672500"/>
+            <a:ext cx="360000" cy="360000"/>
+          </a:xfrm>
+          <a:prstGeom prst="ellipse">
+            <a:avLst/>
+          </a:prstGeom>
+          <a:solidFill>
+            <a:schemeClr val="accent2">
+              <a:lumMod val="20000"/>
+              <a:lumOff val="80000"/>
+            </a:schemeClr>
+          </a:solidFill>
+        </p:spPr>
+        <p:style>
+          <a:lnRef idx="2">
+            <a:schemeClr val="accent2"/>
+          </a:lnRef>
+          <a:fillRef idx="1">
+            <a:schemeClr val="lt1"/>
+          </a:fillRef>
+          <a:effectRef idx="0">
+            <a:schemeClr val="accent2"/>
+          </a:effectRef>
+          <a:fontRef idx="minor">
+            <a:schemeClr val="dk1"/>
+          </a:fontRef>
+        </p:style>
+        <p:txBody>
+          <a:bodyPr rtlCol="0" anchor="ctr"/>
+          <a:lstStyle/>
+          <a:p>
+            <a:pPr algn="ctr"/>
+            <a:r>
+              <a:rPr lang="pt-PT" sz="2000" dirty="0">
+                <a:solidFill>
+                  <a:schemeClr val="accent2"/>
+                </a:solidFill>
+              </a:rPr>
+              <a:t>6</a:t>
+            </a:r>
+            <a:endParaRPr lang="pt-PT" sz="1100" dirty="0">
+              <a:solidFill>
+                <a:schemeClr val="accent2"/>
+              </a:solidFill>
+            </a:endParaRPr>
+          </a:p>
+        </p:txBody>
+      </p:sp>
+      <p:sp>
+        <p:nvSpPr>
+          <p:cNvPr id="8" name="Oval 7">
+            <a:extLst>
+              <a:ext uri="{FF2B5EF4-FFF2-40B4-BE49-F238E27FC236}">
+                <a16:creationId xmlns:a16="http://schemas.microsoft.com/office/drawing/2014/main" id="{FF33FE58-86A8-4DA1-7275-3AB45578818A}"/>
+              </a:ext>
+            </a:extLst>
+          </p:cNvPr>
+          <p:cNvSpPr/>
+          <p:nvPr/>
+        </p:nvSpPr>
+        <p:spPr>
+          <a:xfrm>
+            <a:off x="5347700" y="1672500"/>
+            <a:ext cx="360000" cy="360000"/>
+          </a:xfrm>
+          <a:prstGeom prst="ellipse">
+            <a:avLst/>
+          </a:prstGeom>
+          <a:solidFill>
+            <a:schemeClr val="accent2">
+              <a:lumMod val="20000"/>
+              <a:lumOff val="80000"/>
+            </a:schemeClr>
+          </a:solidFill>
+        </p:spPr>
+        <p:style>
+          <a:lnRef idx="2">
+            <a:schemeClr val="accent2"/>
+          </a:lnRef>
+          <a:fillRef idx="1">
+            <a:schemeClr val="lt1"/>
+          </a:fillRef>
+          <a:effectRef idx="0">
+            <a:schemeClr val="accent2"/>
+          </a:effectRef>
+          <a:fontRef idx="minor">
+            <a:schemeClr val="dk1"/>
+          </a:fontRef>
+        </p:style>
+        <p:txBody>
+          <a:bodyPr rtlCol="0" anchor="ctr"/>
+          <a:lstStyle/>
+          <a:p>
+            <a:pPr algn="ctr"/>
+            <a:r>
+              <a:rPr lang="pt-PT" sz="2000" dirty="0">
+                <a:solidFill>
+                  <a:schemeClr val="accent2"/>
+                </a:solidFill>
+              </a:rPr>
+              <a:t>7</a:t>
+            </a:r>
+            <a:endParaRPr lang="pt-PT" sz="1100" dirty="0">
+              <a:solidFill>
+                <a:schemeClr val="accent2"/>
+              </a:solidFill>
+            </a:endParaRPr>
+          </a:p>
+        </p:txBody>
+      </p:sp>
+      <p:sp>
+        <p:nvSpPr>
+          <p:cNvPr id="9" name="Oval 8">
+            <a:extLst>
+              <a:ext uri="{FF2B5EF4-FFF2-40B4-BE49-F238E27FC236}">
+                <a16:creationId xmlns:a16="http://schemas.microsoft.com/office/drawing/2014/main" id="{6AEE2130-FB48-FCC5-81E4-264279432AB3}"/>
+              </a:ext>
+            </a:extLst>
+          </p:cNvPr>
+          <p:cNvSpPr/>
+          <p:nvPr/>
+        </p:nvSpPr>
+        <p:spPr>
+          <a:xfrm>
+            <a:off x="5860100" y="1695950"/>
+            <a:ext cx="360000" cy="360000"/>
+          </a:xfrm>
+          <a:prstGeom prst="ellipse">
+            <a:avLst/>
+          </a:prstGeom>
+          <a:solidFill>
+            <a:schemeClr val="accent2">
+              <a:lumMod val="20000"/>
+              <a:lumOff val="80000"/>
+            </a:schemeClr>
+          </a:solidFill>
+        </p:spPr>
+        <p:style>
+          <a:lnRef idx="2">
+            <a:schemeClr val="accent2"/>
+          </a:lnRef>
+          <a:fillRef idx="1">
+            <a:schemeClr val="lt1"/>
+          </a:fillRef>
+          <a:effectRef idx="0">
+            <a:schemeClr val="accent2"/>
+          </a:effectRef>
+          <a:fontRef idx="minor">
+            <a:schemeClr val="dk1"/>
+          </a:fontRef>
+        </p:style>
+        <p:txBody>
+          <a:bodyPr rtlCol="0" anchor="ctr"/>
+          <a:lstStyle/>
+          <a:p>
+            <a:pPr algn="ctr"/>
+            <a:r>
+              <a:rPr lang="pt-PT" sz="2000" dirty="0">
+                <a:solidFill>
+                  <a:schemeClr val="accent2"/>
+                </a:solidFill>
+              </a:rPr>
+              <a:t>8</a:t>
+            </a:r>
+            <a:endParaRPr lang="pt-PT" sz="1100" dirty="0">
+              <a:solidFill>
+                <a:schemeClr val="accent2"/>
+              </a:solidFill>
+            </a:endParaRPr>
+          </a:p>
+        </p:txBody>
+      </p:sp>
+      <p:sp>
+        <p:nvSpPr>
+          <p:cNvPr id="10" name="Oval 9">
+            <a:extLst>
+              <a:ext uri="{FF2B5EF4-FFF2-40B4-BE49-F238E27FC236}">
+                <a16:creationId xmlns:a16="http://schemas.microsoft.com/office/drawing/2014/main" id="{885802FE-4C06-AE32-119C-2B63D801AF6D}"/>
+              </a:ext>
+            </a:extLst>
+          </p:cNvPr>
+          <p:cNvSpPr/>
+          <p:nvPr/>
+        </p:nvSpPr>
+        <p:spPr>
+          <a:xfrm>
+            <a:off x="6372500" y="1695950"/>
+            <a:ext cx="360000" cy="360000"/>
+          </a:xfrm>
+          <a:prstGeom prst="ellipse">
+            <a:avLst/>
+          </a:prstGeom>
+          <a:solidFill>
+            <a:schemeClr val="accent2">
+              <a:lumMod val="20000"/>
+              <a:lumOff val="80000"/>
+            </a:schemeClr>
+          </a:solidFill>
+        </p:spPr>
+        <p:style>
+          <a:lnRef idx="2">
+            <a:schemeClr val="accent2"/>
+          </a:lnRef>
+          <a:fillRef idx="1">
+            <a:schemeClr val="lt1"/>
+          </a:fillRef>
+          <a:effectRef idx="0">
+            <a:schemeClr val="accent2"/>
+          </a:effectRef>
+          <a:fontRef idx="minor">
+            <a:schemeClr val="dk1"/>
+          </a:fontRef>
+        </p:style>
+        <p:txBody>
+          <a:bodyPr rtlCol="0" anchor="ctr"/>
+          <a:lstStyle/>
+          <a:p>
+            <a:pPr algn="ctr"/>
+            <a:r>
+              <a:rPr lang="pt-PT" sz="2000" dirty="0">
+                <a:solidFill>
+                  <a:schemeClr val="accent2"/>
+                </a:solidFill>
+              </a:rPr>
+              <a:t>9</a:t>
+            </a:r>
+            <a:endParaRPr lang="pt-PT" sz="1100" dirty="0">
+              <a:solidFill>
+                <a:schemeClr val="accent2"/>
+              </a:solidFill>
+            </a:endParaRPr>
+          </a:p>
+        </p:txBody>
+      </p:sp>
+    </p:spTree>
+    <p:extLst>
+      <p:ext uri="{BB962C8B-B14F-4D97-AF65-F5344CB8AC3E}">
+        <p14:creationId xmlns:p14="http://schemas.microsoft.com/office/powerpoint/2010/main" val="3017697166"/>
       </p:ext>
     </p:extLst>
   </p:cSld>

</xml_diff>

<commit_message>
refactoring some classes. feat: manual html continuation
</commit_message>
<xml_diff>
--- a/Entregas/06 Final Report/Cartaz v2.pptx
+++ b/Entregas/06 Final Report/Cartaz v2.pptx
@@ -5,7 +5,7 @@
     <p:sldMasterId id="2147483708" r:id="rId1"/>
   </p:sldMasterIdLst>
   <p:notesMasterIdLst>
-    <p:notesMasterId r:id="rId9"/>
+    <p:notesMasterId r:id="rId10"/>
   </p:notesMasterIdLst>
   <p:sldIdLst>
     <p:sldId id="256" r:id="rId2"/>
@@ -15,6 +15,7 @@
     <p:sldId id="261" r:id="rId6"/>
     <p:sldId id="260" r:id="rId7"/>
     <p:sldId id="262" r:id="rId8"/>
+    <p:sldId id="263" r:id="rId9"/>
   </p:sldIdLst>
   <p:sldSz cx="12801600" cy="9601200" type="A3"/>
   <p:notesSz cx="6858000" cy="9144000"/>
@@ -6081,7 +6082,7 @@
           <a:p>
             <a:fld id="{D8D22204-511D-42DB-B769-E600439F120D}" type="datetimeFigureOut">
               <a:rPr lang="pt-PT" smtClean="0"/>
-              <a:t>16/07/2025</a:t>
+              <a:t>17/07/2025</a:t>
             </a:fld>
             <a:endParaRPr lang="pt-PT"/>
           </a:p>
@@ -7020,7 +7021,7 @@
           <a:p>
             <a:fld id="{FF3E7115-E5A5-49CB-9497-9E6CDBEED4A9}" type="datetimeFigureOut">
               <a:rPr lang="pt-PT" smtClean="0"/>
-              <a:t>16/07/2025</a:t>
+              <a:t>17/07/2025</a:t>
             </a:fld>
             <a:endParaRPr lang="pt-PT"/>
           </a:p>
@@ -7190,7 +7191,7 @@
           <a:p>
             <a:fld id="{FF3E7115-E5A5-49CB-9497-9E6CDBEED4A9}" type="datetimeFigureOut">
               <a:rPr lang="pt-PT" smtClean="0"/>
-              <a:t>16/07/2025</a:t>
+              <a:t>17/07/2025</a:t>
             </a:fld>
             <a:endParaRPr lang="pt-PT"/>
           </a:p>
@@ -7370,7 +7371,7 @@
           <a:p>
             <a:fld id="{FF3E7115-E5A5-49CB-9497-9E6CDBEED4A9}" type="datetimeFigureOut">
               <a:rPr lang="pt-PT" smtClean="0"/>
-              <a:t>16/07/2025</a:t>
+              <a:t>17/07/2025</a:t>
             </a:fld>
             <a:endParaRPr lang="pt-PT"/>
           </a:p>
@@ -7540,7 +7541,7 @@
           <a:p>
             <a:fld id="{FF3E7115-E5A5-49CB-9497-9E6CDBEED4A9}" type="datetimeFigureOut">
               <a:rPr lang="pt-PT" smtClean="0"/>
-              <a:t>16/07/2025</a:t>
+              <a:t>17/07/2025</a:t>
             </a:fld>
             <a:endParaRPr lang="pt-PT"/>
           </a:p>
@@ -7786,7 +7787,7 @@
           <a:p>
             <a:fld id="{FF3E7115-E5A5-49CB-9497-9E6CDBEED4A9}" type="datetimeFigureOut">
               <a:rPr lang="pt-PT" smtClean="0"/>
-              <a:t>16/07/2025</a:t>
+              <a:t>17/07/2025</a:t>
             </a:fld>
             <a:endParaRPr lang="pt-PT"/>
           </a:p>
@@ -8018,7 +8019,7 @@
           <a:p>
             <a:fld id="{FF3E7115-E5A5-49CB-9497-9E6CDBEED4A9}" type="datetimeFigureOut">
               <a:rPr lang="pt-PT" smtClean="0"/>
-              <a:t>16/07/2025</a:t>
+              <a:t>17/07/2025</a:t>
             </a:fld>
             <a:endParaRPr lang="pt-PT"/>
           </a:p>
@@ -8385,7 +8386,7 @@
           <a:p>
             <a:fld id="{FF3E7115-E5A5-49CB-9497-9E6CDBEED4A9}" type="datetimeFigureOut">
               <a:rPr lang="pt-PT" smtClean="0"/>
-              <a:t>16/07/2025</a:t>
+              <a:t>17/07/2025</a:t>
             </a:fld>
             <a:endParaRPr lang="pt-PT"/>
           </a:p>
@@ -8503,7 +8504,7 @@
           <a:p>
             <a:fld id="{FF3E7115-E5A5-49CB-9497-9E6CDBEED4A9}" type="datetimeFigureOut">
               <a:rPr lang="pt-PT" smtClean="0"/>
-              <a:t>16/07/2025</a:t>
+              <a:t>17/07/2025</a:t>
             </a:fld>
             <a:endParaRPr lang="pt-PT"/>
           </a:p>
@@ -8598,7 +8599,7 @@
           <a:p>
             <a:fld id="{FF3E7115-E5A5-49CB-9497-9E6CDBEED4A9}" type="datetimeFigureOut">
               <a:rPr lang="pt-PT" smtClean="0"/>
-              <a:t>16/07/2025</a:t>
+              <a:t>17/07/2025</a:t>
             </a:fld>
             <a:endParaRPr lang="pt-PT"/>
           </a:p>
@@ -8875,7 +8876,7 @@
           <a:p>
             <a:fld id="{FF3E7115-E5A5-49CB-9497-9E6CDBEED4A9}" type="datetimeFigureOut">
               <a:rPr lang="pt-PT" smtClean="0"/>
-              <a:t>16/07/2025</a:t>
+              <a:t>17/07/2025</a:t>
             </a:fld>
             <a:endParaRPr lang="pt-PT"/>
           </a:p>
@@ -9132,7 +9133,7 @@
           <a:p>
             <a:fld id="{FF3E7115-E5A5-49CB-9497-9E6CDBEED4A9}" type="datetimeFigureOut">
               <a:rPr lang="pt-PT" smtClean="0"/>
-              <a:t>16/07/2025</a:t>
+              <a:t>17/07/2025</a:t>
             </a:fld>
             <a:endParaRPr lang="pt-PT"/>
           </a:p>
@@ -9345,7 +9346,7 @@
           <a:p>
             <a:fld id="{FF3E7115-E5A5-49CB-9497-9E6CDBEED4A9}" type="datetimeFigureOut">
               <a:rPr lang="pt-PT" smtClean="0"/>
-              <a:t>16/07/2025</a:t>
+              <a:t>17/07/2025</a:t>
             </a:fld>
             <a:endParaRPr lang="pt-PT"/>
           </a:p>
@@ -19723,7 +19724,7 @@
         </p:nvSpPr>
         <p:spPr>
           <a:xfrm>
-            <a:off x="2273300" y="1625600"/>
+            <a:off x="2273300" y="1660775"/>
             <a:ext cx="360000" cy="360000"/>
           </a:xfrm>
           <a:prstGeom prst="ellipse">
@@ -19785,7 +19786,7 @@
         </p:nvSpPr>
         <p:spPr>
           <a:xfrm>
-            <a:off x="2785700" y="1649050"/>
+            <a:off x="2785700" y="1660775"/>
             <a:ext cx="360000" cy="360000"/>
           </a:xfrm>
           <a:prstGeom prst="ellipse">
@@ -19847,7 +19848,7 @@
         </p:nvSpPr>
         <p:spPr>
           <a:xfrm>
-            <a:off x="3298100" y="1649050"/>
+            <a:off x="3298100" y="1660775"/>
             <a:ext cx="360000" cy="360000"/>
           </a:xfrm>
           <a:prstGeom prst="ellipse">
@@ -19909,7 +19910,7 @@
         </p:nvSpPr>
         <p:spPr>
           <a:xfrm>
-            <a:off x="3810500" y="1649050"/>
+            <a:off x="3810500" y="1660775"/>
             <a:ext cx="360000" cy="360000"/>
           </a:xfrm>
           <a:prstGeom prst="ellipse">
@@ -19971,7 +19972,7 @@
         </p:nvSpPr>
         <p:spPr>
           <a:xfrm>
-            <a:off x="4322900" y="1672500"/>
+            <a:off x="4322900" y="1660775"/>
             <a:ext cx="360000" cy="360000"/>
           </a:xfrm>
           <a:prstGeom prst="ellipse">
@@ -20033,7 +20034,7 @@
         </p:nvSpPr>
         <p:spPr>
           <a:xfrm>
-            <a:off x="4835300" y="1672500"/>
+            <a:off x="4835300" y="1660775"/>
             <a:ext cx="360000" cy="360000"/>
           </a:xfrm>
           <a:prstGeom prst="ellipse">
@@ -20095,7 +20096,7 @@
         </p:nvSpPr>
         <p:spPr>
           <a:xfrm>
-            <a:off x="5347700" y="1672500"/>
+            <a:off x="5347700" y="1660775"/>
             <a:ext cx="360000" cy="360000"/>
           </a:xfrm>
           <a:prstGeom prst="ellipse">
@@ -20157,7 +20158,7 @@
         </p:nvSpPr>
         <p:spPr>
           <a:xfrm>
-            <a:off x="5860100" y="1695950"/>
+            <a:off x="5860100" y="1660775"/>
             <a:ext cx="360000" cy="360000"/>
           </a:xfrm>
           <a:prstGeom prst="ellipse">
@@ -20219,7 +20220,7 @@
         </p:nvSpPr>
         <p:spPr>
           <a:xfrm>
-            <a:off x="6372500" y="1695950"/>
+            <a:off x="6372500" y="1660775"/>
             <a:ext cx="360000" cy="360000"/>
           </a:xfrm>
           <a:prstGeom prst="ellipse">
@@ -20271,6 +20272,1788 @@
     <p:extLst>
       <p:ext uri="{BB962C8B-B14F-4D97-AF65-F5344CB8AC3E}">
         <p14:creationId xmlns:p14="http://schemas.microsoft.com/office/powerpoint/2010/main" val="3017697166"/>
+      </p:ext>
+    </p:extLst>
+  </p:cSld>
+  <p:clrMapOvr>
+    <a:masterClrMapping/>
+  </p:clrMapOvr>
+</p:sld>
+</file>
+
+<file path=ppt/slides/slide8.xml><?xml version="1.0" encoding="utf-8"?>
+<p:sld xmlns:a="http://schemas.openxmlformats.org/drawingml/2006/main" xmlns:r="http://schemas.openxmlformats.org/officeDocument/2006/relationships" xmlns:p="http://schemas.openxmlformats.org/presentationml/2006/main">
+  <p:cSld>
+    <p:spTree>
+      <p:nvGrpSpPr>
+        <p:cNvPr id="1" name=""/>
+        <p:cNvGrpSpPr/>
+        <p:nvPr/>
+      </p:nvGrpSpPr>
+      <p:grpSpPr>
+        <a:xfrm>
+          <a:off x="0" y="0"/>
+          <a:ext cx="0" cy="0"/>
+          <a:chOff x="0" y="0"/>
+          <a:chExt cx="0" cy="0"/>
+        </a:xfrm>
+      </p:grpSpPr>
+      <p:sp>
+        <p:nvSpPr>
+          <p:cNvPr id="3" name="Retângulo: Cantos Arredondados 2">
+            <a:extLst>
+              <a:ext uri="{FF2B5EF4-FFF2-40B4-BE49-F238E27FC236}">
+                <a16:creationId xmlns:a16="http://schemas.microsoft.com/office/drawing/2014/main" id="{DFB80908-B472-3691-BCF4-95748E37C977}"/>
+              </a:ext>
+            </a:extLst>
+          </p:cNvPr>
+          <p:cNvSpPr/>
+          <p:nvPr/>
+        </p:nvSpPr>
+        <p:spPr>
+          <a:xfrm>
+            <a:off x="5435200" y="522514"/>
+            <a:ext cx="1728000" cy="720000"/>
+          </a:xfrm>
+          <a:prstGeom prst="roundRect">
+            <a:avLst/>
+          </a:prstGeom>
+          <a:ln w="31750"/>
+        </p:spPr>
+        <p:style>
+          <a:lnRef idx="2">
+            <a:schemeClr val="accent3"/>
+          </a:lnRef>
+          <a:fillRef idx="1">
+            <a:schemeClr val="lt1"/>
+          </a:fillRef>
+          <a:effectRef idx="0">
+            <a:schemeClr val="accent3"/>
+          </a:effectRef>
+          <a:fontRef idx="minor">
+            <a:schemeClr val="dk1"/>
+          </a:fontRef>
+        </p:style>
+        <p:txBody>
+          <a:bodyPr rtlCol="0" anchor="ctr"/>
+          <a:lstStyle/>
+          <a:p>
+            <a:pPr algn="ctr"/>
+            <a:r>
+              <a:rPr lang="pt-PT" dirty="0"/>
+              <a:t>Inicio / Login</a:t>
+            </a:r>
+          </a:p>
+        </p:txBody>
+      </p:sp>
+      <p:cxnSp>
+        <p:nvCxnSpPr>
+          <p:cNvPr id="8" name="Conexão reta unidirecional 7">
+            <a:extLst>
+              <a:ext uri="{FF2B5EF4-FFF2-40B4-BE49-F238E27FC236}">
+                <a16:creationId xmlns:a16="http://schemas.microsoft.com/office/drawing/2014/main" id="{EFD7567A-7E90-B310-1477-1044E38989B6}"/>
+              </a:ext>
+            </a:extLst>
+          </p:cNvPr>
+          <p:cNvCxnSpPr>
+            <a:cxnSpLocks/>
+            <a:stCxn id="3" idx="2"/>
+            <a:endCxn id="41" idx="0"/>
+          </p:cNvCxnSpPr>
+          <p:nvPr/>
+        </p:nvCxnSpPr>
+        <p:spPr>
+          <a:xfrm flipH="1">
+            <a:off x="6299199" y="1242514"/>
+            <a:ext cx="1" cy="342633"/>
+          </a:xfrm>
+          <a:prstGeom prst="straightConnector1">
+            <a:avLst/>
+          </a:prstGeom>
+          <a:ln w="31750">
+            <a:tailEnd type="triangle"/>
+          </a:ln>
+        </p:spPr>
+        <p:style>
+          <a:lnRef idx="2">
+            <a:schemeClr val="accent3"/>
+          </a:lnRef>
+          <a:fillRef idx="0">
+            <a:schemeClr val="accent3"/>
+          </a:fillRef>
+          <a:effectRef idx="1">
+            <a:schemeClr val="accent3"/>
+          </a:effectRef>
+          <a:fontRef idx="minor">
+            <a:schemeClr val="tx1"/>
+          </a:fontRef>
+        </p:style>
+      </p:cxnSp>
+      <p:cxnSp>
+        <p:nvCxnSpPr>
+          <p:cNvPr id="10" name="Conexão reta unidirecional 9">
+            <a:extLst>
+              <a:ext uri="{FF2B5EF4-FFF2-40B4-BE49-F238E27FC236}">
+                <a16:creationId xmlns:a16="http://schemas.microsoft.com/office/drawing/2014/main" id="{C1708409-074C-054F-AD8D-922F599C1D31}"/>
+              </a:ext>
+            </a:extLst>
+          </p:cNvPr>
+          <p:cNvCxnSpPr>
+            <a:cxnSpLocks/>
+            <a:stCxn id="41" idx="1"/>
+            <a:endCxn id="43" idx="0"/>
+          </p:cNvCxnSpPr>
+          <p:nvPr/>
+        </p:nvCxnSpPr>
+        <p:spPr>
+          <a:xfrm rot="10800000" flipV="1">
+            <a:off x="4023735" y="2125146"/>
+            <a:ext cx="1195464" cy="813529"/>
+          </a:xfrm>
+          <a:prstGeom prst="bentConnector2">
+            <a:avLst/>
+          </a:prstGeom>
+          <a:ln w="31750">
+            <a:tailEnd type="triangle"/>
+          </a:ln>
+        </p:spPr>
+        <p:style>
+          <a:lnRef idx="2">
+            <a:schemeClr val="accent3"/>
+          </a:lnRef>
+          <a:fillRef idx="0">
+            <a:schemeClr val="accent3"/>
+          </a:fillRef>
+          <a:effectRef idx="1">
+            <a:schemeClr val="accent3"/>
+          </a:effectRef>
+          <a:fontRef idx="minor">
+            <a:schemeClr val="tx1"/>
+          </a:fontRef>
+        </p:style>
+      </p:cxnSp>
+      <p:cxnSp>
+        <p:nvCxnSpPr>
+          <p:cNvPr id="13" name="Conexão reta unidirecional 9">
+            <a:extLst>
+              <a:ext uri="{FF2B5EF4-FFF2-40B4-BE49-F238E27FC236}">
+                <a16:creationId xmlns:a16="http://schemas.microsoft.com/office/drawing/2014/main" id="{A92C0769-234E-9618-40AA-A52F916274E3}"/>
+              </a:ext>
+            </a:extLst>
+          </p:cNvPr>
+          <p:cNvCxnSpPr>
+            <a:cxnSpLocks/>
+            <a:stCxn id="41" idx="3"/>
+            <a:endCxn id="50" idx="0"/>
+          </p:cNvCxnSpPr>
+          <p:nvPr/>
+        </p:nvCxnSpPr>
+        <p:spPr>
+          <a:xfrm>
+            <a:off x="7379199" y="2125147"/>
+            <a:ext cx="1370161" cy="813529"/>
+          </a:xfrm>
+          <a:prstGeom prst="bentConnector2">
+            <a:avLst/>
+          </a:prstGeom>
+          <a:ln w="31750">
+            <a:tailEnd type="triangle"/>
+          </a:ln>
+        </p:spPr>
+        <p:style>
+          <a:lnRef idx="2">
+            <a:schemeClr val="accent3"/>
+          </a:lnRef>
+          <a:fillRef idx="0">
+            <a:schemeClr val="accent3"/>
+          </a:fillRef>
+          <a:effectRef idx="1">
+            <a:schemeClr val="accent3"/>
+          </a:effectRef>
+          <a:fontRef idx="minor">
+            <a:schemeClr val="tx1"/>
+          </a:fontRef>
+        </p:style>
+      </p:cxnSp>
+      <p:pic>
+        <p:nvPicPr>
+          <p:cNvPr id="17" name="Gráfico 16">
+            <a:extLst>
+              <a:ext uri="{FF2B5EF4-FFF2-40B4-BE49-F238E27FC236}">
+                <a16:creationId xmlns:a16="http://schemas.microsoft.com/office/drawing/2014/main" id="{6E3A4D56-2F88-121F-5A43-7E9D28176412}"/>
+              </a:ext>
+            </a:extLst>
+          </p:cNvPr>
+          <p:cNvPicPr>
+            <a:picLocks noChangeAspect="1"/>
+          </p:cNvPicPr>
+          <p:nvPr/>
+        </p:nvPicPr>
+        <p:blipFill>
+          <a:blip r:embed="rId2">
+            <a:extLst>
+              <a:ext uri="{96DAC541-7B7A-43D3-8B79-37D633B846F1}">
+                <asvg:svgBlip xmlns:asvg="http://schemas.microsoft.com/office/drawing/2016/SVG/main" r:embed="rId3"/>
+              </a:ext>
+            </a:extLst>
+          </a:blip>
+          <a:stretch>
+            <a:fillRect/>
+          </a:stretch>
+        </p:blipFill>
+        <p:spPr>
+          <a:xfrm>
+            <a:off x="4100798" y="2125147"/>
+            <a:ext cx="540000" cy="540000"/>
+          </a:xfrm>
+          <a:prstGeom prst="rect">
+            <a:avLst/>
+          </a:prstGeom>
+        </p:spPr>
+      </p:pic>
+      <p:pic>
+        <p:nvPicPr>
+          <p:cNvPr id="19" name="Gráfico 18">
+            <a:extLst>
+              <a:ext uri="{FF2B5EF4-FFF2-40B4-BE49-F238E27FC236}">
+                <a16:creationId xmlns:a16="http://schemas.microsoft.com/office/drawing/2014/main" id="{D6463F69-64BB-4383-1EE7-A0C8F86C195B}"/>
+              </a:ext>
+            </a:extLst>
+          </p:cNvPr>
+          <p:cNvPicPr>
+            <a:picLocks noChangeAspect="1"/>
+          </p:cNvPicPr>
+          <p:nvPr/>
+        </p:nvPicPr>
+        <p:blipFill>
+          <a:blip r:embed="rId4">
+            <a:extLst>
+              <a:ext uri="{96DAC541-7B7A-43D3-8B79-37D633B846F1}">
+                <asvg:svgBlip xmlns:asvg="http://schemas.microsoft.com/office/drawing/2016/SVG/main" r:embed="rId5"/>
+              </a:ext>
+            </a:extLst>
+          </a:blip>
+          <a:stretch>
+            <a:fillRect/>
+          </a:stretch>
+        </p:blipFill>
+        <p:spPr>
+          <a:xfrm>
+            <a:off x="8090397" y="2136745"/>
+            <a:ext cx="540000" cy="540000"/>
+          </a:xfrm>
+          <a:prstGeom prst="rect">
+            <a:avLst/>
+          </a:prstGeom>
+        </p:spPr>
+      </p:pic>
+      <p:sp>
+        <p:nvSpPr>
+          <p:cNvPr id="20" name="Retângulo: Cantos Arredondados 19">
+            <a:extLst>
+              <a:ext uri="{FF2B5EF4-FFF2-40B4-BE49-F238E27FC236}">
+                <a16:creationId xmlns:a16="http://schemas.microsoft.com/office/drawing/2014/main" id="{1CFF9E1C-2A3F-4B4A-D2F8-F5DAE968A446}"/>
+              </a:ext>
+            </a:extLst>
+          </p:cNvPr>
+          <p:cNvSpPr/>
+          <p:nvPr/>
+        </p:nvSpPr>
+        <p:spPr>
+          <a:xfrm>
+            <a:off x="4867211" y="4237159"/>
+            <a:ext cx="1728000" cy="864000"/>
+          </a:xfrm>
+          <a:prstGeom prst="roundRect">
+            <a:avLst/>
+          </a:prstGeom>
+          <a:ln w="31750"/>
+        </p:spPr>
+        <p:style>
+          <a:lnRef idx="2">
+            <a:schemeClr val="accent3"/>
+          </a:lnRef>
+          <a:fillRef idx="1">
+            <a:schemeClr val="lt1"/>
+          </a:fillRef>
+          <a:effectRef idx="0">
+            <a:schemeClr val="accent3"/>
+          </a:effectRef>
+          <a:fontRef idx="minor">
+            <a:schemeClr val="dk1"/>
+          </a:fontRef>
+        </p:style>
+        <p:txBody>
+          <a:bodyPr rtlCol="0" anchor="ctr"/>
+          <a:lstStyle/>
+          <a:p>
+            <a:pPr algn="ctr"/>
+            <a:r>
+              <a:rPr lang="pt-PT" dirty="0"/>
+              <a:t>Devolve JWT</a:t>
+            </a:r>
+          </a:p>
+        </p:txBody>
+      </p:sp>
+      <p:sp>
+        <p:nvSpPr>
+          <p:cNvPr id="21" name="Retângulo: Cantos Arredondados 20">
+            <a:extLst>
+              <a:ext uri="{FF2B5EF4-FFF2-40B4-BE49-F238E27FC236}">
+                <a16:creationId xmlns:a16="http://schemas.microsoft.com/office/drawing/2014/main" id="{3E63C6F7-37C5-46EC-1C10-7465A74E8B85}"/>
+              </a:ext>
+            </a:extLst>
+          </p:cNvPr>
+          <p:cNvSpPr/>
+          <p:nvPr/>
+        </p:nvSpPr>
+        <p:spPr>
+          <a:xfrm>
+            <a:off x="9528815" y="4237159"/>
+            <a:ext cx="1728000" cy="864000"/>
+          </a:xfrm>
+          <a:prstGeom prst="roundRect">
+            <a:avLst/>
+          </a:prstGeom>
+          <a:ln w="31750"/>
+        </p:spPr>
+        <p:style>
+          <a:lnRef idx="2">
+            <a:schemeClr val="accent3"/>
+          </a:lnRef>
+          <a:fillRef idx="1">
+            <a:schemeClr val="lt1"/>
+          </a:fillRef>
+          <a:effectRef idx="0">
+            <a:schemeClr val="accent3"/>
+          </a:effectRef>
+          <a:fontRef idx="minor">
+            <a:schemeClr val="dk1"/>
+          </a:fontRef>
+        </p:style>
+        <p:txBody>
+          <a:bodyPr rtlCol="0" anchor="ctr"/>
+          <a:lstStyle/>
+          <a:p>
+            <a:pPr algn="ctr"/>
+            <a:r>
+              <a:rPr lang="pt-PT" sz="1600" dirty="0"/>
+              <a:t>User/Password inválidas</a:t>
+            </a:r>
+          </a:p>
+        </p:txBody>
+      </p:sp>
+      <p:sp>
+        <p:nvSpPr>
+          <p:cNvPr id="22" name="Retângulo: Cantos Arredondados 21">
+            <a:extLst>
+              <a:ext uri="{FF2B5EF4-FFF2-40B4-BE49-F238E27FC236}">
+                <a16:creationId xmlns:a16="http://schemas.microsoft.com/office/drawing/2014/main" id="{A55F615A-A9F4-D6E8-DB18-6F9F3D0A0227}"/>
+              </a:ext>
+            </a:extLst>
+          </p:cNvPr>
+          <p:cNvSpPr/>
+          <p:nvPr/>
+        </p:nvSpPr>
+        <p:spPr>
+          <a:xfrm>
+            <a:off x="7885360" y="7044053"/>
+            <a:ext cx="1728000" cy="864000"/>
+          </a:xfrm>
+          <a:prstGeom prst="roundRect">
+            <a:avLst/>
+          </a:prstGeom>
+          <a:ln w="31750"/>
+        </p:spPr>
+        <p:style>
+          <a:lnRef idx="2">
+            <a:schemeClr val="accent3"/>
+          </a:lnRef>
+          <a:fillRef idx="1">
+            <a:schemeClr val="lt1"/>
+          </a:fillRef>
+          <a:effectRef idx="0">
+            <a:schemeClr val="accent3"/>
+          </a:effectRef>
+          <a:fontRef idx="minor">
+            <a:schemeClr val="dk1"/>
+          </a:fontRef>
+        </p:style>
+        <p:txBody>
+          <a:bodyPr rtlCol="0" anchor="ctr"/>
+          <a:lstStyle/>
+          <a:p>
+            <a:pPr algn="ctr"/>
+            <a:r>
+              <a:rPr lang="pt-PT" dirty="0"/>
+              <a:t>Acesso permitido</a:t>
+            </a:r>
+          </a:p>
+        </p:txBody>
+      </p:sp>
+      <p:cxnSp>
+        <p:nvCxnSpPr>
+          <p:cNvPr id="23" name="Conexão reta unidirecional 9">
+            <a:extLst>
+              <a:ext uri="{FF2B5EF4-FFF2-40B4-BE49-F238E27FC236}">
+                <a16:creationId xmlns:a16="http://schemas.microsoft.com/office/drawing/2014/main" id="{9DC5B586-1576-6E93-1B1B-0A7F96077C14}"/>
+              </a:ext>
+            </a:extLst>
+          </p:cNvPr>
+          <p:cNvCxnSpPr>
+            <a:cxnSpLocks/>
+            <a:stCxn id="43" idx="3"/>
+            <a:endCxn id="20" idx="0"/>
+          </p:cNvCxnSpPr>
+          <p:nvPr/>
+        </p:nvCxnSpPr>
+        <p:spPr>
+          <a:xfrm>
+            <a:off x="5103735" y="3478676"/>
+            <a:ext cx="627476" cy="758483"/>
+          </a:xfrm>
+          <a:prstGeom prst="bentConnector2">
+            <a:avLst/>
+          </a:prstGeom>
+          <a:ln w="31750">
+            <a:tailEnd type="triangle"/>
+          </a:ln>
+        </p:spPr>
+        <p:style>
+          <a:lnRef idx="2">
+            <a:schemeClr val="accent3"/>
+          </a:lnRef>
+          <a:fillRef idx="0">
+            <a:schemeClr val="accent3"/>
+          </a:fillRef>
+          <a:effectRef idx="1">
+            <a:schemeClr val="accent3"/>
+          </a:effectRef>
+          <a:fontRef idx="minor">
+            <a:schemeClr val="tx1"/>
+          </a:fontRef>
+        </p:style>
+      </p:cxnSp>
+      <p:cxnSp>
+        <p:nvCxnSpPr>
+          <p:cNvPr id="26" name="Conexão reta unidirecional 9">
+            <a:extLst>
+              <a:ext uri="{FF2B5EF4-FFF2-40B4-BE49-F238E27FC236}">
+                <a16:creationId xmlns:a16="http://schemas.microsoft.com/office/drawing/2014/main" id="{99C33D5C-70C3-841C-391E-DB354FEB672D}"/>
+              </a:ext>
+            </a:extLst>
+          </p:cNvPr>
+          <p:cNvCxnSpPr>
+            <a:cxnSpLocks/>
+            <a:stCxn id="43" idx="1"/>
+            <a:endCxn id="69" idx="0"/>
+          </p:cNvCxnSpPr>
+          <p:nvPr/>
+        </p:nvCxnSpPr>
+        <p:spPr>
+          <a:xfrm rot="10800000" flipV="1">
+            <a:off x="2391545" y="3478675"/>
+            <a:ext cx="552191" cy="758483"/>
+          </a:xfrm>
+          <a:prstGeom prst="bentConnector2">
+            <a:avLst/>
+          </a:prstGeom>
+          <a:ln w="31750">
+            <a:solidFill>
+              <a:srgbClr val="FF0000"/>
+            </a:solidFill>
+            <a:tailEnd type="triangle"/>
+          </a:ln>
+        </p:spPr>
+        <p:style>
+          <a:lnRef idx="2">
+            <a:schemeClr val="accent3"/>
+          </a:lnRef>
+          <a:fillRef idx="0">
+            <a:schemeClr val="accent3"/>
+          </a:fillRef>
+          <a:effectRef idx="1">
+            <a:schemeClr val="accent3"/>
+          </a:effectRef>
+          <a:fontRef idx="minor">
+            <a:schemeClr val="tx1"/>
+          </a:fontRef>
+        </p:style>
+      </p:cxnSp>
+      <p:cxnSp>
+        <p:nvCxnSpPr>
+          <p:cNvPr id="29" name="Conexão reta unidirecional 9">
+            <a:extLst>
+              <a:ext uri="{FF2B5EF4-FFF2-40B4-BE49-F238E27FC236}">
+                <a16:creationId xmlns:a16="http://schemas.microsoft.com/office/drawing/2014/main" id="{0E02361E-592F-9EA0-EF1E-6675F6BC4EB9}"/>
+              </a:ext>
+            </a:extLst>
+          </p:cNvPr>
+          <p:cNvCxnSpPr>
+            <a:cxnSpLocks/>
+            <a:stCxn id="59" idx="3"/>
+            <a:endCxn id="22" idx="0"/>
+          </p:cNvCxnSpPr>
+          <p:nvPr/>
+        </p:nvCxnSpPr>
+        <p:spPr>
+          <a:xfrm>
+            <a:off x="6813143" y="6069198"/>
+            <a:ext cx="1936217" cy="974855"/>
+          </a:xfrm>
+          <a:prstGeom prst="bentConnector2">
+            <a:avLst/>
+          </a:prstGeom>
+          <a:ln w="31750">
+            <a:tailEnd type="triangle"/>
+          </a:ln>
+        </p:spPr>
+        <p:style>
+          <a:lnRef idx="2">
+            <a:schemeClr val="accent3"/>
+          </a:lnRef>
+          <a:fillRef idx="0">
+            <a:schemeClr val="accent3"/>
+          </a:fillRef>
+          <a:effectRef idx="1">
+            <a:schemeClr val="accent3"/>
+          </a:effectRef>
+          <a:fontRef idx="minor">
+            <a:schemeClr val="tx1"/>
+          </a:fontRef>
+        </p:style>
+      </p:cxnSp>
+      <p:cxnSp>
+        <p:nvCxnSpPr>
+          <p:cNvPr id="32" name="Conexão reta unidirecional 9">
+            <a:extLst>
+              <a:ext uri="{FF2B5EF4-FFF2-40B4-BE49-F238E27FC236}">
+                <a16:creationId xmlns:a16="http://schemas.microsoft.com/office/drawing/2014/main" id="{FDE2CDA6-262D-1AA0-FC5F-E32076C7EEF0}"/>
+              </a:ext>
+            </a:extLst>
+          </p:cNvPr>
+          <p:cNvCxnSpPr>
+            <a:cxnSpLocks/>
+            <a:stCxn id="50" idx="3"/>
+            <a:endCxn id="21" idx="0"/>
+          </p:cNvCxnSpPr>
+          <p:nvPr/>
+        </p:nvCxnSpPr>
+        <p:spPr>
+          <a:xfrm>
+            <a:off x="9829360" y="3478676"/>
+            <a:ext cx="563455" cy="758483"/>
+          </a:xfrm>
+          <a:prstGeom prst="bentConnector2">
+            <a:avLst/>
+          </a:prstGeom>
+          <a:ln w="31750">
+            <a:solidFill>
+              <a:srgbClr val="FF0000"/>
+            </a:solidFill>
+            <a:tailEnd type="triangle"/>
+          </a:ln>
+        </p:spPr>
+        <p:style>
+          <a:lnRef idx="2">
+            <a:schemeClr val="accent3"/>
+          </a:lnRef>
+          <a:fillRef idx="0">
+            <a:schemeClr val="accent3"/>
+          </a:fillRef>
+          <a:effectRef idx="1">
+            <a:schemeClr val="accent3"/>
+          </a:effectRef>
+          <a:fontRef idx="minor">
+            <a:schemeClr val="tx1"/>
+          </a:fontRef>
+        </p:style>
+      </p:cxnSp>
+      <p:sp>
+        <p:nvSpPr>
+          <p:cNvPr id="38" name="Retângulo 37">
+            <a:extLst>
+              <a:ext uri="{FF2B5EF4-FFF2-40B4-BE49-F238E27FC236}">
+                <a16:creationId xmlns:a16="http://schemas.microsoft.com/office/drawing/2014/main" id="{4773AAE4-5269-52E7-9208-AF10BD1087FD}"/>
+              </a:ext>
+            </a:extLst>
+          </p:cNvPr>
+          <p:cNvSpPr/>
+          <p:nvPr/>
+        </p:nvSpPr>
+        <p:spPr>
+          <a:xfrm>
+            <a:off x="5035187" y="3451494"/>
+            <a:ext cx="696024" cy="461665"/>
+          </a:xfrm>
+          <a:prstGeom prst="rect">
+            <a:avLst/>
+          </a:prstGeom>
+          <a:noFill/>
+        </p:spPr>
+        <p:txBody>
+          <a:bodyPr wrap="none" lIns="91440" tIns="45720" rIns="91440" bIns="45720">
+            <a:spAutoFit/>
+          </a:bodyPr>
+          <a:lstStyle/>
+          <a:p>
+            <a:pPr algn="ctr"/>
+            <a:r>
+              <a:rPr lang="pt-PT" sz="2400" b="0" cap="none" spc="0" dirty="0">
+                <a:ln w="0"/>
+                <a:solidFill>
+                  <a:schemeClr val="tx1"/>
+                </a:solidFill>
+                <a:effectLst>
+                  <a:outerShdw blurRad="38100" dist="19050" dir="2700000" algn="tl" rotWithShape="0">
+                    <a:schemeClr val="dk1">
+                      <a:alpha val="40000"/>
+                    </a:schemeClr>
+                  </a:outerShdw>
+                </a:effectLst>
+              </a:rPr>
+              <a:t>Sim</a:t>
+            </a:r>
+          </a:p>
+        </p:txBody>
+      </p:sp>
+      <p:sp>
+        <p:nvSpPr>
+          <p:cNvPr id="39" name="Retângulo 38">
+            <a:extLst>
+              <a:ext uri="{FF2B5EF4-FFF2-40B4-BE49-F238E27FC236}">
+                <a16:creationId xmlns:a16="http://schemas.microsoft.com/office/drawing/2014/main" id="{99789D91-7B2A-19AF-A141-7C2E8E9DAF63}"/>
+              </a:ext>
+            </a:extLst>
+          </p:cNvPr>
+          <p:cNvSpPr/>
+          <p:nvPr/>
+        </p:nvSpPr>
+        <p:spPr>
+          <a:xfrm>
+            <a:off x="8037513" y="3914623"/>
+            <a:ext cx="696024" cy="461665"/>
+          </a:xfrm>
+          <a:prstGeom prst="rect">
+            <a:avLst/>
+          </a:prstGeom>
+          <a:noFill/>
+        </p:spPr>
+        <p:txBody>
+          <a:bodyPr wrap="none" lIns="91440" tIns="45720" rIns="91440" bIns="45720">
+            <a:spAutoFit/>
+          </a:bodyPr>
+          <a:lstStyle/>
+          <a:p>
+            <a:pPr algn="ctr"/>
+            <a:r>
+              <a:rPr lang="pt-PT" sz="2400" b="0" cap="none" spc="0" dirty="0">
+                <a:ln w="0"/>
+                <a:solidFill>
+                  <a:schemeClr val="tx1"/>
+                </a:solidFill>
+                <a:effectLst>
+                  <a:outerShdw blurRad="38100" dist="19050" dir="2700000" algn="tl" rotWithShape="0">
+                    <a:schemeClr val="dk1">
+                      <a:alpha val="40000"/>
+                    </a:schemeClr>
+                  </a:outerShdw>
+                </a:effectLst>
+              </a:rPr>
+              <a:t>Sim</a:t>
+            </a:r>
+          </a:p>
+        </p:txBody>
+      </p:sp>
+      <p:sp>
+        <p:nvSpPr>
+          <p:cNvPr id="40" name="Retângulo 39">
+            <a:extLst>
+              <a:ext uri="{FF2B5EF4-FFF2-40B4-BE49-F238E27FC236}">
+                <a16:creationId xmlns:a16="http://schemas.microsoft.com/office/drawing/2014/main" id="{83992740-4B6A-B364-EDBF-A66CD986645F}"/>
+              </a:ext>
+            </a:extLst>
+          </p:cNvPr>
+          <p:cNvSpPr/>
+          <p:nvPr/>
+        </p:nvSpPr>
+        <p:spPr>
+          <a:xfrm>
+            <a:off x="9711900" y="3435419"/>
+            <a:ext cx="736100" cy="461665"/>
+          </a:xfrm>
+          <a:prstGeom prst="rect">
+            <a:avLst/>
+          </a:prstGeom>
+          <a:noFill/>
+        </p:spPr>
+        <p:txBody>
+          <a:bodyPr wrap="none" lIns="91440" tIns="45720" rIns="91440" bIns="45720">
+            <a:spAutoFit/>
+          </a:bodyPr>
+          <a:lstStyle/>
+          <a:p>
+            <a:pPr algn="ctr"/>
+            <a:r>
+              <a:rPr lang="pt-PT" sz="2400" b="0" cap="none" spc="0" dirty="0">
+                <a:ln w="0"/>
+                <a:solidFill>
+                  <a:schemeClr val="tx1"/>
+                </a:solidFill>
+                <a:effectLst>
+                  <a:outerShdw blurRad="38100" dist="19050" dir="2700000" algn="tl" rotWithShape="0">
+                    <a:schemeClr val="dk1">
+                      <a:alpha val="40000"/>
+                    </a:schemeClr>
+                  </a:outerShdw>
+                </a:effectLst>
+              </a:rPr>
+              <a:t>Não</a:t>
+            </a:r>
+          </a:p>
+        </p:txBody>
+      </p:sp>
+      <p:sp>
+        <p:nvSpPr>
+          <p:cNvPr id="41" name="Losango 40">
+            <a:extLst>
+              <a:ext uri="{FF2B5EF4-FFF2-40B4-BE49-F238E27FC236}">
+                <a16:creationId xmlns:a16="http://schemas.microsoft.com/office/drawing/2014/main" id="{A95EA889-AF40-9336-20AE-40DB52DDAB12}"/>
+              </a:ext>
+            </a:extLst>
+          </p:cNvPr>
+          <p:cNvSpPr/>
+          <p:nvPr/>
+        </p:nvSpPr>
+        <p:spPr>
+          <a:xfrm>
+            <a:off x="5219199" y="1585147"/>
+            <a:ext cx="2160000" cy="1080000"/>
+          </a:xfrm>
+          <a:prstGeom prst="diamond">
+            <a:avLst/>
+          </a:prstGeom>
+          <a:ln w="31750"/>
+        </p:spPr>
+        <p:style>
+          <a:lnRef idx="2">
+            <a:schemeClr val="accent3"/>
+          </a:lnRef>
+          <a:fillRef idx="1">
+            <a:schemeClr val="lt1"/>
+          </a:fillRef>
+          <a:effectRef idx="0">
+            <a:schemeClr val="accent3"/>
+          </a:effectRef>
+          <a:fontRef idx="minor">
+            <a:schemeClr val="dk1"/>
+          </a:fontRef>
+        </p:style>
+        <p:txBody>
+          <a:bodyPr rtlCol="0" anchor="ctr"/>
+          <a:lstStyle/>
+          <a:p>
+            <a:pPr algn="ctr"/>
+            <a:r>
+              <a:rPr lang="pt-PT" dirty="0">
+                <a:solidFill>
+                  <a:schemeClr val="dk1"/>
+                </a:solidFill>
+              </a:rPr>
+              <a:t>API Online?</a:t>
+            </a:r>
+          </a:p>
+        </p:txBody>
+      </p:sp>
+      <p:grpSp>
+        <p:nvGrpSpPr>
+          <p:cNvPr id="47" name="Agrupar 46">
+            <a:extLst>
+              <a:ext uri="{FF2B5EF4-FFF2-40B4-BE49-F238E27FC236}">
+                <a16:creationId xmlns:a16="http://schemas.microsoft.com/office/drawing/2014/main" id="{0A4FE25B-5274-EFDD-6D4C-CFFF5FB8B042}"/>
+              </a:ext>
+            </a:extLst>
+          </p:cNvPr>
+          <p:cNvGrpSpPr/>
+          <p:nvPr/>
+        </p:nvGrpSpPr>
+        <p:grpSpPr>
+          <a:xfrm>
+            <a:off x="2943735" y="2938676"/>
+            <a:ext cx="2160000" cy="1080000"/>
+            <a:chOff x="1547200" y="1500915"/>
+            <a:chExt cx="2160000" cy="1080000"/>
+          </a:xfrm>
+        </p:grpSpPr>
+        <p:sp>
+          <p:nvSpPr>
+            <p:cNvPr id="43" name="Losango 42">
+              <a:extLst>
+                <a:ext uri="{FF2B5EF4-FFF2-40B4-BE49-F238E27FC236}">
+                  <a16:creationId xmlns:a16="http://schemas.microsoft.com/office/drawing/2014/main" id="{3517BB71-1632-B18D-AAB5-8FBC8CE1763D}"/>
+                </a:ext>
+              </a:extLst>
+            </p:cNvPr>
+            <p:cNvSpPr/>
+            <p:nvPr/>
+          </p:nvSpPr>
+          <p:spPr>
+            <a:xfrm>
+              <a:off x="1547200" y="1500915"/>
+              <a:ext cx="2160000" cy="1080000"/>
+            </a:xfrm>
+            <a:prstGeom prst="diamond">
+              <a:avLst/>
+            </a:prstGeom>
+            <a:ln w="31750"/>
+          </p:spPr>
+          <p:style>
+            <a:lnRef idx="2">
+              <a:schemeClr val="accent3"/>
+            </a:lnRef>
+            <a:fillRef idx="1">
+              <a:schemeClr val="lt1"/>
+            </a:fillRef>
+            <a:effectRef idx="0">
+              <a:schemeClr val="accent3"/>
+            </a:effectRef>
+            <a:fontRef idx="minor">
+              <a:schemeClr val="dk1"/>
+            </a:fontRef>
+          </p:style>
+          <p:txBody>
+            <a:bodyPr rtlCol="0" anchor="ctr"/>
+            <a:lstStyle/>
+            <a:p>
+              <a:pPr algn="ctr"/>
+              <a:endParaRPr lang="pt-PT" sz="1600" dirty="0">
+                <a:solidFill>
+                  <a:schemeClr val="dk1"/>
+                </a:solidFill>
+              </a:endParaRPr>
+            </a:p>
+          </p:txBody>
+        </p:sp>
+        <p:sp>
+          <p:nvSpPr>
+            <p:cNvPr id="46" name="Retângulo 45">
+              <a:extLst>
+                <a:ext uri="{FF2B5EF4-FFF2-40B4-BE49-F238E27FC236}">
+                  <a16:creationId xmlns:a16="http://schemas.microsoft.com/office/drawing/2014/main" id="{59866C6E-68E8-B4BE-A421-D34C862B31C1}"/>
+                </a:ext>
+              </a:extLst>
+            </p:cNvPr>
+            <p:cNvSpPr/>
+            <p:nvPr/>
+          </p:nvSpPr>
+          <p:spPr>
+            <a:xfrm>
+              <a:off x="1853317" y="1759317"/>
+              <a:ext cx="1516121" cy="646331"/>
+            </a:xfrm>
+            <a:prstGeom prst="rect">
+              <a:avLst/>
+            </a:prstGeom>
+            <a:noFill/>
+          </p:spPr>
+          <p:txBody>
+            <a:bodyPr wrap="none" lIns="91440" tIns="45720" rIns="91440" bIns="45720">
+              <a:spAutoFit/>
+            </a:bodyPr>
+            <a:lstStyle/>
+            <a:p>
+              <a:pPr algn="ctr"/>
+              <a:r>
+                <a:rPr lang="pt-PT" b="0" cap="none" spc="0" dirty="0">
+                  <a:ln w="0"/>
+                  <a:solidFill>
+                    <a:schemeClr val="tx1"/>
+                  </a:solidFill>
+                  <a:effectLst>
+                    <a:outerShdw blurRad="38100" dist="19050" dir="2700000" algn="tl" rotWithShape="0">
+                      <a:schemeClr val="dk1">
+                        <a:alpha val="40000"/>
+                      </a:schemeClr>
+                    </a:outerShdw>
+                  </a:effectLst>
+                </a:rPr>
+                <a:t>Autenticação</a:t>
+              </a:r>
+            </a:p>
+            <a:p>
+              <a:pPr algn="ctr"/>
+              <a:r>
+                <a:rPr lang="pt-PT" dirty="0">
+                  <a:ln w="0"/>
+                  <a:effectLst>
+                    <a:outerShdw blurRad="38100" dist="19050" dir="2700000" algn="tl" rotWithShape="0">
+                      <a:schemeClr val="dk1">
+                        <a:alpha val="40000"/>
+                      </a:schemeClr>
+                    </a:outerShdw>
+                  </a:effectLst>
+                </a:rPr>
+                <a:t>OK?</a:t>
+              </a:r>
+              <a:endParaRPr lang="pt-PT" b="0" cap="none" spc="0" dirty="0">
+                <a:ln w="0"/>
+                <a:solidFill>
+                  <a:schemeClr val="tx1"/>
+                </a:solidFill>
+                <a:effectLst>
+                  <a:outerShdw blurRad="38100" dist="19050" dir="2700000" algn="tl" rotWithShape="0">
+                    <a:schemeClr val="dk1">
+                      <a:alpha val="40000"/>
+                    </a:schemeClr>
+                  </a:outerShdw>
+                </a:effectLst>
+              </a:endParaRPr>
+            </a:p>
+          </p:txBody>
+        </p:sp>
+      </p:grpSp>
+      <p:grpSp>
+        <p:nvGrpSpPr>
+          <p:cNvPr id="49" name="Agrupar 48">
+            <a:extLst>
+              <a:ext uri="{FF2B5EF4-FFF2-40B4-BE49-F238E27FC236}">
+                <a16:creationId xmlns:a16="http://schemas.microsoft.com/office/drawing/2014/main" id="{9915DFDA-6CE7-CC18-630B-F862702AACE9}"/>
+              </a:ext>
+            </a:extLst>
+          </p:cNvPr>
+          <p:cNvGrpSpPr/>
+          <p:nvPr/>
+        </p:nvGrpSpPr>
+        <p:grpSpPr>
+          <a:xfrm>
+            <a:off x="7669360" y="2938676"/>
+            <a:ext cx="2160000" cy="1080000"/>
+            <a:chOff x="1547200" y="1500915"/>
+            <a:chExt cx="2160000" cy="1080000"/>
+          </a:xfrm>
+        </p:grpSpPr>
+        <p:sp>
+          <p:nvSpPr>
+            <p:cNvPr id="50" name="Losango 49">
+              <a:extLst>
+                <a:ext uri="{FF2B5EF4-FFF2-40B4-BE49-F238E27FC236}">
+                  <a16:creationId xmlns:a16="http://schemas.microsoft.com/office/drawing/2014/main" id="{B81A2233-7602-E263-469C-D96A3F095C7E}"/>
+                </a:ext>
+              </a:extLst>
+            </p:cNvPr>
+            <p:cNvSpPr/>
+            <p:nvPr/>
+          </p:nvSpPr>
+          <p:spPr>
+            <a:xfrm>
+              <a:off x="1547200" y="1500915"/>
+              <a:ext cx="2160000" cy="1080000"/>
+            </a:xfrm>
+            <a:prstGeom prst="diamond">
+              <a:avLst/>
+            </a:prstGeom>
+            <a:ln w="31750"/>
+          </p:spPr>
+          <p:style>
+            <a:lnRef idx="2">
+              <a:schemeClr val="accent3"/>
+            </a:lnRef>
+            <a:fillRef idx="1">
+              <a:schemeClr val="lt1"/>
+            </a:fillRef>
+            <a:effectRef idx="0">
+              <a:schemeClr val="accent3"/>
+            </a:effectRef>
+            <a:fontRef idx="minor">
+              <a:schemeClr val="dk1"/>
+            </a:fontRef>
+          </p:style>
+          <p:txBody>
+            <a:bodyPr rtlCol="0" anchor="ctr"/>
+            <a:lstStyle/>
+            <a:p>
+              <a:pPr algn="ctr"/>
+              <a:endParaRPr lang="pt-PT" sz="1600" dirty="0">
+                <a:solidFill>
+                  <a:schemeClr val="dk1"/>
+                </a:solidFill>
+              </a:endParaRPr>
+            </a:p>
+          </p:txBody>
+        </p:sp>
+        <p:sp>
+          <p:nvSpPr>
+            <p:cNvPr id="51" name="Retângulo 50">
+              <a:extLst>
+                <a:ext uri="{FF2B5EF4-FFF2-40B4-BE49-F238E27FC236}">
+                  <a16:creationId xmlns:a16="http://schemas.microsoft.com/office/drawing/2014/main" id="{99FA537C-037B-8568-081E-AE7BD93192F2}"/>
+                </a:ext>
+              </a:extLst>
+            </p:cNvPr>
+            <p:cNvSpPr/>
+            <p:nvPr/>
+          </p:nvSpPr>
+          <p:spPr>
+            <a:xfrm>
+              <a:off x="1853317" y="1759317"/>
+              <a:ext cx="1516121" cy="646331"/>
+            </a:xfrm>
+            <a:prstGeom prst="rect">
+              <a:avLst/>
+            </a:prstGeom>
+            <a:noFill/>
+          </p:spPr>
+          <p:txBody>
+            <a:bodyPr wrap="none" lIns="91440" tIns="45720" rIns="91440" bIns="45720">
+              <a:spAutoFit/>
+            </a:bodyPr>
+            <a:lstStyle/>
+            <a:p>
+              <a:pPr algn="ctr"/>
+              <a:r>
+                <a:rPr lang="pt-PT" b="0" cap="none" spc="0" dirty="0">
+                  <a:ln w="0"/>
+                  <a:solidFill>
+                    <a:schemeClr val="tx1"/>
+                  </a:solidFill>
+                  <a:effectLst>
+                    <a:outerShdw blurRad="38100" dist="19050" dir="2700000" algn="tl" rotWithShape="0">
+                      <a:schemeClr val="dk1">
+                        <a:alpha val="40000"/>
+                      </a:schemeClr>
+                    </a:outerShdw>
+                  </a:effectLst>
+                </a:rPr>
+                <a:t>Autenticação</a:t>
+              </a:r>
+            </a:p>
+            <a:p>
+              <a:pPr algn="ctr"/>
+              <a:r>
+                <a:rPr lang="pt-PT" dirty="0">
+                  <a:ln w="0"/>
+                  <a:effectLst>
+                    <a:outerShdw blurRad="38100" dist="19050" dir="2700000" algn="tl" rotWithShape="0">
+                      <a:schemeClr val="dk1">
+                        <a:alpha val="40000"/>
+                      </a:schemeClr>
+                    </a:outerShdw>
+                  </a:effectLst>
+                </a:rPr>
+                <a:t>Local OK?</a:t>
+              </a:r>
+              <a:endParaRPr lang="pt-PT" b="0" cap="none" spc="0" dirty="0">
+                <a:ln w="0"/>
+                <a:solidFill>
+                  <a:schemeClr val="tx1"/>
+                </a:solidFill>
+                <a:effectLst>
+                  <a:outerShdw blurRad="38100" dist="19050" dir="2700000" algn="tl" rotWithShape="0">
+                    <a:schemeClr val="dk1">
+                      <a:alpha val="40000"/>
+                    </a:schemeClr>
+                  </a:outerShdw>
+                </a:effectLst>
+              </a:endParaRPr>
+            </a:p>
+          </p:txBody>
+        </p:sp>
+      </p:grpSp>
+      <p:grpSp>
+        <p:nvGrpSpPr>
+          <p:cNvPr id="58" name="Agrupar 57">
+            <a:extLst>
+              <a:ext uri="{FF2B5EF4-FFF2-40B4-BE49-F238E27FC236}">
+                <a16:creationId xmlns:a16="http://schemas.microsoft.com/office/drawing/2014/main" id="{3EB0C3C9-DE91-6946-1953-79731CD38414}"/>
+              </a:ext>
+            </a:extLst>
+          </p:cNvPr>
+          <p:cNvGrpSpPr/>
+          <p:nvPr/>
+        </p:nvGrpSpPr>
+        <p:grpSpPr>
+          <a:xfrm>
+            <a:off x="4653143" y="5529198"/>
+            <a:ext cx="2160000" cy="1080000"/>
+            <a:chOff x="1547200" y="1500915"/>
+            <a:chExt cx="2160000" cy="1080000"/>
+          </a:xfrm>
+        </p:grpSpPr>
+        <p:sp>
+          <p:nvSpPr>
+            <p:cNvPr id="59" name="Losango 58">
+              <a:extLst>
+                <a:ext uri="{FF2B5EF4-FFF2-40B4-BE49-F238E27FC236}">
+                  <a16:creationId xmlns:a16="http://schemas.microsoft.com/office/drawing/2014/main" id="{051894BA-99D7-09AB-C706-3986899D426C}"/>
+                </a:ext>
+              </a:extLst>
+            </p:cNvPr>
+            <p:cNvSpPr/>
+            <p:nvPr/>
+          </p:nvSpPr>
+          <p:spPr>
+            <a:xfrm>
+              <a:off x="1547200" y="1500915"/>
+              <a:ext cx="2160000" cy="1080000"/>
+            </a:xfrm>
+            <a:prstGeom prst="diamond">
+              <a:avLst/>
+            </a:prstGeom>
+            <a:ln w="31750"/>
+          </p:spPr>
+          <p:style>
+            <a:lnRef idx="2">
+              <a:schemeClr val="accent3"/>
+            </a:lnRef>
+            <a:fillRef idx="1">
+              <a:schemeClr val="lt1"/>
+            </a:fillRef>
+            <a:effectRef idx="0">
+              <a:schemeClr val="accent3"/>
+            </a:effectRef>
+            <a:fontRef idx="minor">
+              <a:schemeClr val="dk1"/>
+            </a:fontRef>
+          </p:style>
+          <p:txBody>
+            <a:bodyPr rtlCol="0" anchor="ctr"/>
+            <a:lstStyle/>
+            <a:p>
+              <a:pPr algn="ctr"/>
+              <a:endParaRPr lang="pt-PT" sz="1600" dirty="0">
+                <a:solidFill>
+                  <a:schemeClr val="dk1"/>
+                </a:solidFill>
+              </a:endParaRPr>
+            </a:p>
+          </p:txBody>
+        </p:sp>
+        <p:sp>
+          <p:nvSpPr>
+            <p:cNvPr id="60" name="Retângulo 59">
+              <a:extLst>
+                <a:ext uri="{FF2B5EF4-FFF2-40B4-BE49-F238E27FC236}">
+                  <a16:creationId xmlns:a16="http://schemas.microsoft.com/office/drawing/2014/main" id="{84E44B27-40E0-BA6E-9967-51CE2332635C}"/>
+                </a:ext>
+              </a:extLst>
+            </p:cNvPr>
+            <p:cNvSpPr/>
+            <p:nvPr/>
+          </p:nvSpPr>
+          <p:spPr>
+            <a:xfrm>
+              <a:off x="1887792" y="1730289"/>
+              <a:ext cx="1534266" cy="646331"/>
+            </a:xfrm>
+            <a:prstGeom prst="rect">
+              <a:avLst/>
+            </a:prstGeom>
+            <a:noFill/>
+          </p:spPr>
+          <p:txBody>
+            <a:bodyPr wrap="none" lIns="91440" tIns="45720" rIns="91440" bIns="45720">
+              <a:spAutoFit/>
+            </a:bodyPr>
+            <a:lstStyle/>
+            <a:p>
+              <a:pPr algn="ctr"/>
+              <a:r>
+                <a:rPr lang="pt-PT" dirty="0">
+                  <a:ln w="0"/>
+                  <a:effectLst>
+                    <a:outerShdw blurRad="38100" dist="19050" dir="2700000" algn="tl" rotWithShape="0">
+                      <a:schemeClr val="dk1">
+                        <a:alpha val="40000"/>
+                      </a:schemeClr>
+                    </a:outerShdw>
+                  </a:effectLst>
+                </a:rPr>
+                <a:t>User gravado </a:t>
+              </a:r>
+            </a:p>
+            <a:p>
+              <a:pPr algn="ctr"/>
+              <a:r>
+                <a:rPr lang="pt-PT" dirty="0">
+                  <a:ln w="0"/>
+                  <a:effectLst>
+                    <a:outerShdw blurRad="38100" dist="19050" dir="2700000" algn="tl" rotWithShape="0">
+                      <a:schemeClr val="dk1">
+                        <a:alpha val="40000"/>
+                      </a:schemeClr>
+                    </a:outerShdw>
+                  </a:effectLst>
+                </a:rPr>
+                <a:t>localmente?</a:t>
+              </a:r>
+              <a:endParaRPr lang="pt-PT" b="0" cap="none" spc="0" dirty="0">
+                <a:ln w="0"/>
+                <a:solidFill>
+                  <a:schemeClr val="tx1"/>
+                </a:solidFill>
+                <a:effectLst>
+                  <a:outerShdw blurRad="38100" dist="19050" dir="2700000" algn="tl" rotWithShape="0">
+                    <a:schemeClr val="dk1">
+                      <a:alpha val="40000"/>
+                    </a:schemeClr>
+                  </a:outerShdw>
+                </a:effectLst>
+              </a:endParaRPr>
+            </a:p>
+          </p:txBody>
+        </p:sp>
+      </p:grpSp>
+      <p:cxnSp>
+        <p:nvCxnSpPr>
+          <p:cNvPr id="61" name="Conexão reta unidirecional 60">
+            <a:extLst>
+              <a:ext uri="{FF2B5EF4-FFF2-40B4-BE49-F238E27FC236}">
+                <a16:creationId xmlns:a16="http://schemas.microsoft.com/office/drawing/2014/main" id="{F59C949E-C8E6-FE9B-FF78-CCEA19DFCF75}"/>
+              </a:ext>
+            </a:extLst>
+          </p:cNvPr>
+          <p:cNvCxnSpPr>
+            <a:cxnSpLocks/>
+            <a:stCxn id="20" idx="2"/>
+            <a:endCxn id="59" idx="0"/>
+          </p:cNvCxnSpPr>
+          <p:nvPr/>
+        </p:nvCxnSpPr>
+        <p:spPr>
+          <a:xfrm>
+            <a:off x="5731211" y="5101159"/>
+            <a:ext cx="1932" cy="428039"/>
+          </a:xfrm>
+          <a:prstGeom prst="straightConnector1">
+            <a:avLst/>
+          </a:prstGeom>
+          <a:ln w="31750">
+            <a:tailEnd type="triangle"/>
+          </a:ln>
+        </p:spPr>
+        <p:style>
+          <a:lnRef idx="2">
+            <a:schemeClr val="accent3"/>
+          </a:lnRef>
+          <a:fillRef idx="0">
+            <a:schemeClr val="accent3"/>
+          </a:fillRef>
+          <a:effectRef idx="1">
+            <a:schemeClr val="accent3"/>
+          </a:effectRef>
+          <a:fontRef idx="minor">
+            <a:schemeClr val="tx1"/>
+          </a:fontRef>
+        </p:style>
+      </p:cxnSp>
+      <p:sp>
+        <p:nvSpPr>
+          <p:cNvPr id="65" name="Retângulo: Cantos Arredondados 64">
+            <a:extLst>
+              <a:ext uri="{FF2B5EF4-FFF2-40B4-BE49-F238E27FC236}">
+                <a16:creationId xmlns:a16="http://schemas.microsoft.com/office/drawing/2014/main" id="{F5EC151D-CAFB-E5E2-C7FE-B69BF8AA670A}"/>
+              </a:ext>
+            </a:extLst>
+          </p:cNvPr>
+          <p:cNvSpPr/>
+          <p:nvPr/>
+        </p:nvSpPr>
+        <p:spPr>
+          <a:xfrm>
+            <a:off x="4861360" y="7041819"/>
+            <a:ext cx="1728000" cy="864000"/>
+          </a:xfrm>
+          <a:prstGeom prst="roundRect">
+            <a:avLst/>
+          </a:prstGeom>
+          <a:ln w="31750"/>
+        </p:spPr>
+        <p:style>
+          <a:lnRef idx="2">
+            <a:schemeClr val="accent3"/>
+          </a:lnRef>
+          <a:fillRef idx="1">
+            <a:schemeClr val="lt1"/>
+          </a:fillRef>
+          <a:effectRef idx="0">
+            <a:schemeClr val="accent3"/>
+          </a:effectRef>
+          <a:fontRef idx="minor">
+            <a:schemeClr val="dk1"/>
+          </a:fontRef>
+        </p:style>
+        <p:txBody>
+          <a:bodyPr rtlCol="0" anchor="ctr"/>
+          <a:lstStyle/>
+          <a:p>
+            <a:r>
+              <a:rPr lang="pt-PT" dirty="0"/>
+              <a:t>Sincronização</a:t>
+            </a:r>
+            <a:br>
+              <a:rPr lang="pt-PT" dirty="0"/>
+            </a:br>
+            <a:r>
+              <a:rPr lang="pt-PT" dirty="0"/>
+              <a:t>de dados</a:t>
+            </a:r>
+          </a:p>
+        </p:txBody>
+      </p:sp>
+      <p:sp>
+        <p:nvSpPr>
+          <p:cNvPr id="69" name="Retângulo: Cantos Arredondados 68">
+            <a:extLst>
+              <a:ext uri="{FF2B5EF4-FFF2-40B4-BE49-F238E27FC236}">
+                <a16:creationId xmlns:a16="http://schemas.microsoft.com/office/drawing/2014/main" id="{D5F7A8CD-DB1B-132A-D517-4000A3035A53}"/>
+              </a:ext>
+            </a:extLst>
+          </p:cNvPr>
+          <p:cNvSpPr/>
+          <p:nvPr/>
+        </p:nvSpPr>
+        <p:spPr>
+          <a:xfrm>
+            <a:off x="1527544" y="4237159"/>
+            <a:ext cx="1728000" cy="864000"/>
+          </a:xfrm>
+          <a:prstGeom prst="roundRect">
+            <a:avLst/>
+          </a:prstGeom>
+          <a:ln w="31750"/>
+        </p:spPr>
+        <p:style>
+          <a:lnRef idx="2">
+            <a:schemeClr val="accent3"/>
+          </a:lnRef>
+          <a:fillRef idx="1">
+            <a:schemeClr val="lt1"/>
+          </a:fillRef>
+          <a:effectRef idx="0">
+            <a:schemeClr val="accent3"/>
+          </a:effectRef>
+          <a:fontRef idx="minor">
+            <a:schemeClr val="dk1"/>
+          </a:fontRef>
+        </p:style>
+        <p:txBody>
+          <a:bodyPr rtlCol="0" anchor="ctr"/>
+          <a:lstStyle/>
+          <a:p>
+            <a:pPr algn="ctr"/>
+            <a:r>
+              <a:rPr lang="pt-PT" sz="1600" dirty="0"/>
+              <a:t>User/Password inválidas</a:t>
+            </a:r>
+          </a:p>
+        </p:txBody>
+      </p:sp>
+      <p:sp>
+        <p:nvSpPr>
+          <p:cNvPr id="87" name="Retângulo 86">
+            <a:extLst>
+              <a:ext uri="{FF2B5EF4-FFF2-40B4-BE49-F238E27FC236}">
+                <a16:creationId xmlns:a16="http://schemas.microsoft.com/office/drawing/2014/main" id="{69F0D51A-77EC-1E7A-C0A9-D5BEC5E52FAF}"/>
+              </a:ext>
+            </a:extLst>
+          </p:cNvPr>
+          <p:cNvSpPr/>
+          <p:nvPr/>
+        </p:nvSpPr>
+        <p:spPr>
+          <a:xfrm>
+            <a:off x="2353600" y="3435420"/>
+            <a:ext cx="736100" cy="461665"/>
+          </a:xfrm>
+          <a:prstGeom prst="rect">
+            <a:avLst/>
+          </a:prstGeom>
+          <a:noFill/>
+        </p:spPr>
+        <p:txBody>
+          <a:bodyPr wrap="none" lIns="91440" tIns="45720" rIns="91440" bIns="45720">
+            <a:spAutoFit/>
+          </a:bodyPr>
+          <a:lstStyle/>
+          <a:p>
+            <a:pPr algn="ctr"/>
+            <a:r>
+              <a:rPr lang="pt-PT" sz="2400" b="0" cap="none" spc="0" dirty="0">
+                <a:ln w="0"/>
+                <a:solidFill>
+                  <a:schemeClr val="tx1"/>
+                </a:solidFill>
+                <a:effectLst>
+                  <a:outerShdw blurRad="38100" dist="19050" dir="2700000" algn="tl" rotWithShape="0">
+                    <a:schemeClr val="dk1">
+                      <a:alpha val="40000"/>
+                    </a:schemeClr>
+                  </a:outerShdw>
+                </a:effectLst>
+              </a:rPr>
+              <a:t>Não</a:t>
+            </a:r>
+          </a:p>
+        </p:txBody>
+      </p:sp>
+      <p:cxnSp>
+        <p:nvCxnSpPr>
+          <p:cNvPr id="91" name="Conexão reta unidirecional 90">
+            <a:extLst>
+              <a:ext uri="{FF2B5EF4-FFF2-40B4-BE49-F238E27FC236}">
+                <a16:creationId xmlns:a16="http://schemas.microsoft.com/office/drawing/2014/main" id="{364F7566-B711-A07A-86C2-57B0A99246B2}"/>
+              </a:ext>
+            </a:extLst>
+          </p:cNvPr>
+          <p:cNvCxnSpPr>
+            <a:cxnSpLocks/>
+            <a:stCxn id="50" idx="2"/>
+            <a:endCxn id="22" idx="0"/>
+          </p:cNvCxnSpPr>
+          <p:nvPr/>
+        </p:nvCxnSpPr>
+        <p:spPr>
+          <a:xfrm>
+            <a:off x="8749360" y="4018676"/>
+            <a:ext cx="0" cy="3025377"/>
+          </a:xfrm>
+          <a:prstGeom prst="straightConnector1">
+            <a:avLst/>
+          </a:prstGeom>
+          <a:ln w="31750">
+            <a:tailEnd type="triangle"/>
+          </a:ln>
+        </p:spPr>
+        <p:style>
+          <a:lnRef idx="2">
+            <a:schemeClr val="accent3"/>
+          </a:lnRef>
+          <a:fillRef idx="0">
+            <a:schemeClr val="accent3"/>
+          </a:fillRef>
+          <a:effectRef idx="1">
+            <a:schemeClr val="accent3"/>
+          </a:effectRef>
+          <a:fontRef idx="minor">
+            <a:schemeClr val="tx1"/>
+          </a:fontRef>
+        </p:style>
+      </p:cxnSp>
+      <p:cxnSp>
+        <p:nvCxnSpPr>
+          <p:cNvPr id="94" name="Conexão reta unidirecional 93">
+            <a:extLst>
+              <a:ext uri="{FF2B5EF4-FFF2-40B4-BE49-F238E27FC236}">
+                <a16:creationId xmlns:a16="http://schemas.microsoft.com/office/drawing/2014/main" id="{9AC9BE3C-B80A-0E1D-5E15-37EECD72E0C8}"/>
+              </a:ext>
+            </a:extLst>
+          </p:cNvPr>
+          <p:cNvCxnSpPr>
+            <a:cxnSpLocks/>
+            <a:stCxn id="65" idx="3"/>
+            <a:endCxn id="22" idx="1"/>
+          </p:cNvCxnSpPr>
+          <p:nvPr/>
+        </p:nvCxnSpPr>
+        <p:spPr>
+          <a:xfrm>
+            <a:off x="6589360" y="7473819"/>
+            <a:ext cx="1296000" cy="2234"/>
+          </a:xfrm>
+          <a:prstGeom prst="straightConnector1">
+            <a:avLst/>
+          </a:prstGeom>
+          <a:ln w="31750">
+            <a:tailEnd type="triangle"/>
+          </a:ln>
+        </p:spPr>
+        <p:style>
+          <a:lnRef idx="2">
+            <a:schemeClr val="accent3"/>
+          </a:lnRef>
+          <a:fillRef idx="0">
+            <a:schemeClr val="accent3"/>
+          </a:fillRef>
+          <a:effectRef idx="1">
+            <a:schemeClr val="accent3"/>
+          </a:effectRef>
+          <a:fontRef idx="minor">
+            <a:schemeClr val="tx1"/>
+          </a:fontRef>
+        </p:style>
+      </p:cxnSp>
+      <p:cxnSp>
+        <p:nvCxnSpPr>
+          <p:cNvPr id="97" name="Conexão reta unidirecional 96">
+            <a:extLst>
+              <a:ext uri="{FF2B5EF4-FFF2-40B4-BE49-F238E27FC236}">
+                <a16:creationId xmlns:a16="http://schemas.microsoft.com/office/drawing/2014/main" id="{359D3A4C-3758-D004-F5E7-157058BBBA92}"/>
+              </a:ext>
+            </a:extLst>
+          </p:cNvPr>
+          <p:cNvCxnSpPr>
+            <a:cxnSpLocks/>
+            <a:stCxn id="59" idx="2"/>
+            <a:endCxn id="65" idx="0"/>
+          </p:cNvCxnSpPr>
+          <p:nvPr/>
+        </p:nvCxnSpPr>
+        <p:spPr>
+          <a:xfrm flipH="1">
+            <a:off x="5725360" y="6609198"/>
+            <a:ext cx="7783" cy="432621"/>
+          </a:xfrm>
+          <a:prstGeom prst="straightConnector1">
+            <a:avLst/>
+          </a:prstGeom>
+          <a:ln w="31750">
+            <a:solidFill>
+              <a:srgbClr val="FF0000"/>
+            </a:solidFill>
+            <a:tailEnd type="triangle"/>
+          </a:ln>
+        </p:spPr>
+        <p:style>
+          <a:lnRef idx="2">
+            <a:schemeClr val="accent3"/>
+          </a:lnRef>
+          <a:fillRef idx="0">
+            <a:schemeClr val="accent3"/>
+          </a:fillRef>
+          <a:effectRef idx="1">
+            <a:schemeClr val="accent3"/>
+          </a:effectRef>
+          <a:fontRef idx="minor">
+            <a:schemeClr val="tx1"/>
+          </a:fontRef>
+        </p:style>
+      </p:cxnSp>
+      <p:pic>
+        <p:nvPicPr>
+          <p:cNvPr id="101" name="Gráfico 100">
+            <a:extLst>
+              <a:ext uri="{FF2B5EF4-FFF2-40B4-BE49-F238E27FC236}">
+                <a16:creationId xmlns:a16="http://schemas.microsoft.com/office/drawing/2014/main" id="{0A7BC489-27EC-2EFE-3048-4FDF5A889920}"/>
+              </a:ext>
+            </a:extLst>
+          </p:cNvPr>
+          <p:cNvPicPr>
+            <a:picLocks noChangeAspect="1"/>
+          </p:cNvPicPr>
+          <p:nvPr/>
+        </p:nvPicPr>
+        <p:blipFill>
+          <a:blip r:embed="rId6">
+            <a:extLst>
+              <a:ext uri="{96DAC541-7B7A-43D3-8B79-37D633B846F1}">
+                <asvg:svgBlip xmlns:asvg="http://schemas.microsoft.com/office/drawing/2016/SVG/main" r:embed="rId7"/>
+              </a:ext>
+            </a:extLst>
+          </a:blip>
+          <a:stretch>
+            <a:fillRect/>
+          </a:stretch>
+        </p:blipFill>
+        <p:spPr>
+          <a:xfrm>
+            <a:off x="5964914" y="7365819"/>
+            <a:ext cx="540000" cy="540000"/>
+          </a:xfrm>
+          <a:prstGeom prst="rect">
+            <a:avLst/>
+          </a:prstGeom>
+        </p:spPr>
+      </p:pic>
+      <p:sp>
+        <p:nvSpPr>
+          <p:cNvPr id="102" name="Retângulo 101">
+            <a:extLst>
+              <a:ext uri="{FF2B5EF4-FFF2-40B4-BE49-F238E27FC236}">
+                <a16:creationId xmlns:a16="http://schemas.microsoft.com/office/drawing/2014/main" id="{1EC16B77-CC7E-4E4D-0557-6B0CFA664E65}"/>
+              </a:ext>
+            </a:extLst>
+          </p:cNvPr>
+          <p:cNvSpPr/>
+          <p:nvPr/>
+        </p:nvSpPr>
+        <p:spPr>
+          <a:xfrm>
+            <a:off x="4997043" y="6540330"/>
+            <a:ext cx="736100" cy="461665"/>
+          </a:xfrm>
+          <a:prstGeom prst="rect">
+            <a:avLst/>
+          </a:prstGeom>
+          <a:noFill/>
+        </p:spPr>
+        <p:txBody>
+          <a:bodyPr wrap="none" lIns="91440" tIns="45720" rIns="91440" bIns="45720">
+            <a:spAutoFit/>
+          </a:bodyPr>
+          <a:lstStyle/>
+          <a:p>
+            <a:pPr algn="ctr"/>
+            <a:r>
+              <a:rPr lang="pt-PT" sz="2400" b="0" cap="none" spc="0" dirty="0">
+                <a:ln w="0"/>
+                <a:solidFill>
+                  <a:schemeClr val="tx1"/>
+                </a:solidFill>
+                <a:effectLst>
+                  <a:outerShdw blurRad="38100" dist="19050" dir="2700000" algn="tl" rotWithShape="0">
+                    <a:schemeClr val="dk1">
+                      <a:alpha val="40000"/>
+                    </a:schemeClr>
+                  </a:outerShdw>
+                </a:effectLst>
+              </a:rPr>
+              <a:t>Não</a:t>
+            </a:r>
+          </a:p>
+        </p:txBody>
+      </p:sp>
+      <p:sp>
+        <p:nvSpPr>
+          <p:cNvPr id="103" name="Retângulo 102">
+            <a:extLst>
+              <a:ext uri="{FF2B5EF4-FFF2-40B4-BE49-F238E27FC236}">
+                <a16:creationId xmlns:a16="http://schemas.microsoft.com/office/drawing/2014/main" id="{3A2E6473-40A2-2F3A-1A7B-3E75CAFA6781}"/>
+              </a:ext>
+            </a:extLst>
+          </p:cNvPr>
+          <p:cNvSpPr/>
+          <p:nvPr/>
+        </p:nvSpPr>
+        <p:spPr>
+          <a:xfrm>
+            <a:off x="6695977" y="6069198"/>
+            <a:ext cx="696024" cy="461665"/>
+          </a:xfrm>
+          <a:prstGeom prst="rect">
+            <a:avLst/>
+          </a:prstGeom>
+          <a:noFill/>
+        </p:spPr>
+        <p:txBody>
+          <a:bodyPr wrap="none" lIns="91440" tIns="45720" rIns="91440" bIns="45720">
+            <a:spAutoFit/>
+          </a:bodyPr>
+          <a:lstStyle/>
+          <a:p>
+            <a:pPr algn="ctr"/>
+            <a:r>
+              <a:rPr lang="pt-PT" sz="2400" b="0" cap="none" spc="0" dirty="0">
+                <a:ln w="0"/>
+                <a:solidFill>
+                  <a:schemeClr val="tx1"/>
+                </a:solidFill>
+                <a:effectLst>
+                  <a:outerShdw blurRad="38100" dist="19050" dir="2700000" algn="tl" rotWithShape="0">
+                    <a:schemeClr val="dk1">
+                      <a:alpha val="40000"/>
+                    </a:schemeClr>
+                  </a:outerShdw>
+                </a:effectLst>
+              </a:rPr>
+              <a:t>Sim</a:t>
+            </a:r>
+          </a:p>
+        </p:txBody>
+      </p:sp>
+      <p:cxnSp>
+        <p:nvCxnSpPr>
+          <p:cNvPr id="104" name="Conexão reta unidirecional 9">
+            <a:extLst>
+              <a:ext uri="{FF2B5EF4-FFF2-40B4-BE49-F238E27FC236}">
+                <a16:creationId xmlns:a16="http://schemas.microsoft.com/office/drawing/2014/main" id="{D74F8127-ADB0-F250-F02E-14EDB47392E0}"/>
+              </a:ext>
+            </a:extLst>
+          </p:cNvPr>
+          <p:cNvCxnSpPr>
+            <a:cxnSpLocks/>
+            <a:stCxn id="69" idx="1"/>
+            <a:endCxn id="3" idx="1"/>
+          </p:cNvCxnSpPr>
+          <p:nvPr/>
+        </p:nvCxnSpPr>
+        <p:spPr>
+          <a:xfrm rot="10800000" flipH="1">
+            <a:off x="1527544" y="882515"/>
+            <a:ext cx="3907656" cy="3786645"/>
+          </a:xfrm>
+          <a:prstGeom prst="bentConnector3">
+            <a:avLst>
+              <a:gd name="adj1" fmla="val -5850"/>
+            </a:avLst>
+          </a:prstGeom>
+          <a:ln w="31750">
+            <a:tailEnd type="triangle"/>
+          </a:ln>
+        </p:spPr>
+        <p:style>
+          <a:lnRef idx="2">
+            <a:schemeClr val="accent3"/>
+          </a:lnRef>
+          <a:fillRef idx="0">
+            <a:schemeClr val="accent3"/>
+          </a:fillRef>
+          <a:effectRef idx="1">
+            <a:schemeClr val="accent3"/>
+          </a:effectRef>
+          <a:fontRef idx="minor">
+            <a:schemeClr val="tx1"/>
+          </a:fontRef>
+        </p:style>
+      </p:cxnSp>
+      <p:cxnSp>
+        <p:nvCxnSpPr>
+          <p:cNvPr id="109" name="Conexão reta unidirecional 9">
+            <a:extLst>
+              <a:ext uri="{FF2B5EF4-FFF2-40B4-BE49-F238E27FC236}">
+                <a16:creationId xmlns:a16="http://schemas.microsoft.com/office/drawing/2014/main" id="{F9EDE31C-E292-60CC-6D92-C2A61FF7FF4A}"/>
+              </a:ext>
+            </a:extLst>
+          </p:cNvPr>
+          <p:cNvCxnSpPr>
+            <a:cxnSpLocks/>
+            <a:stCxn id="21" idx="3"/>
+            <a:endCxn id="3" idx="3"/>
+          </p:cNvCxnSpPr>
+          <p:nvPr/>
+        </p:nvCxnSpPr>
+        <p:spPr>
+          <a:xfrm flipH="1" flipV="1">
+            <a:off x="7163200" y="882514"/>
+            <a:ext cx="4093615" cy="3786645"/>
+          </a:xfrm>
+          <a:prstGeom prst="bentConnector3">
+            <a:avLst>
+              <a:gd name="adj1" fmla="val -5584"/>
+            </a:avLst>
+          </a:prstGeom>
+          <a:ln w="31750">
+            <a:tailEnd type="triangle"/>
+          </a:ln>
+        </p:spPr>
+        <p:style>
+          <a:lnRef idx="2">
+            <a:schemeClr val="accent3"/>
+          </a:lnRef>
+          <a:fillRef idx="0">
+            <a:schemeClr val="accent3"/>
+          </a:fillRef>
+          <a:effectRef idx="1">
+            <a:schemeClr val="accent3"/>
+          </a:effectRef>
+          <a:fontRef idx="minor">
+            <a:schemeClr val="tx1"/>
+          </a:fontRef>
+        </p:style>
+      </p:cxnSp>
+    </p:spTree>
+    <p:extLst>
+      <p:ext uri="{BB962C8B-B14F-4D97-AF65-F5344CB8AC3E}">
+        <p14:creationId xmlns:p14="http://schemas.microsoft.com/office/powerpoint/2010/main" val="1467072477"/>
       </p:ext>
     </p:extLst>
   </p:cSld>

</xml_diff>